<commit_message>
Refresh judge pitch with completed niche shortlist screenshots
</commit_message>
<xml_diff>
--- a/docs/submission/pitch.pptx
+++ b/docs/submission/pitch.pptx
@@ -2,20 +2,20 @@
 <file path=ppt/presentation.xml><?xml version="1.0" encoding="utf-8"?>
 <p:presentation xmlns:p="http://schemas.openxmlformats.org/presentationml/2006/main">
   <p:sldMasterIdLst>
-    <p:sldMasterId xmlns:r="http://schemas.openxmlformats.org/officeDocument/2006/relationships" id="2147483648" r:id="R67fca93ff55d4721"/>
+    <p:sldMasterId xmlns:r="http://schemas.openxmlformats.org/officeDocument/2006/relationships" id="2147483648" r:id="R4373effcc41b4d5a"/>
   </p:sldMasterIdLst>
   <p:notesMasterIdLst>
-    <p:notesMasterId xmlns:r="http://schemas.openxmlformats.org/officeDocument/2006/relationships" r:id="Re32aa4f957b04e56"/>
+    <p:notesMasterId xmlns:r="http://schemas.openxmlformats.org/officeDocument/2006/relationships" r:id="R28919c5e45aa46a9"/>
   </p:notesMasterIdLst>
   <p:sldIdLst>
-    <p:sldId xmlns:r="http://schemas.openxmlformats.org/officeDocument/2006/relationships" id="256" r:id="R6128a18c6d0d448c"/>
-    <p:sldId xmlns:r="http://schemas.openxmlformats.org/officeDocument/2006/relationships" id="257" r:id="Rdedbae05d20c458a"/>
-    <p:sldId xmlns:r="http://schemas.openxmlformats.org/officeDocument/2006/relationships" id="258" r:id="R1ed5b1b365a24a54"/>
-    <p:sldId xmlns:r="http://schemas.openxmlformats.org/officeDocument/2006/relationships" id="259" r:id="Rc63c1b3bf6bc4a32"/>
-    <p:sldId xmlns:r="http://schemas.openxmlformats.org/officeDocument/2006/relationships" id="260" r:id="R999cc49ae8804fcc"/>
-    <p:sldId xmlns:r="http://schemas.openxmlformats.org/officeDocument/2006/relationships" id="261" r:id="R90680c1ecc154162"/>
-    <p:sldId xmlns:r="http://schemas.openxmlformats.org/officeDocument/2006/relationships" id="262" r:id="Rf2506e8861114a22"/>
-    <p:sldId xmlns:r="http://schemas.openxmlformats.org/officeDocument/2006/relationships" id="263" r:id="R88d7e878b8d54e15"/>
+    <p:sldId xmlns:r="http://schemas.openxmlformats.org/officeDocument/2006/relationships" id="256" r:id="Re3b02ac23602483a"/>
+    <p:sldId xmlns:r="http://schemas.openxmlformats.org/officeDocument/2006/relationships" id="257" r:id="Rde94b61844f8483d"/>
+    <p:sldId xmlns:r="http://schemas.openxmlformats.org/officeDocument/2006/relationships" id="258" r:id="Rdab422c5250748c9"/>
+    <p:sldId xmlns:r="http://schemas.openxmlformats.org/officeDocument/2006/relationships" id="259" r:id="R9865262c1b044564"/>
+    <p:sldId xmlns:r="http://schemas.openxmlformats.org/officeDocument/2006/relationships" id="260" r:id="R9c21ae4b7ba94999"/>
+    <p:sldId xmlns:r="http://schemas.openxmlformats.org/officeDocument/2006/relationships" id="261" r:id="R6a3223e17c6846b1"/>
+    <p:sldId xmlns:r="http://schemas.openxmlformats.org/officeDocument/2006/relationships" id="262" r:id="Rc4ef52b2481342a6"/>
+    <p:sldId xmlns:r="http://schemas.openxmlformats.org/officeDocument/2006/relationships" id="263" r:id="Rded0d4a6f48a481d"/>
   </p:sldIdLst>
   <p:sldSz cx="12192000" cy="6858000"/>
   <p:notesSz cx="6858000" cy="9144000"/>
@@ -644,7 +644,7 @@
           </a:p>
           <a:p xmlns:a="http://schemas.openxmlformats.org/drawingml/2006/main">
             <a:r>
-              <a:t>/Users/pascalboneu/Desktop/PARALLAX/docs/screenshots/overview.jpg</a:t>
+              <a:t>/Users/pascalboneu/Desktop/PARALLAX/docs/screenshots/top5.jpg</a:t>
             </a:r>
           </a:p>
         </p:txBody>
@@ -804,7 +804,7 @@
           <a:lstStyle xmlns:a="http://schemas.openxmlformats.org/drawingml/2006/main"/>
           <a:p xmlns:a="http://schemas.openxmlformats.org/drawingml/2006/main">
             <a:r>
-              <a:t>The diagram uses native editable PowerPoint shapes and connectors. There are nine distinct research roles. Bull revision is a feedback pass, not a tenth distinct role. Founder and Competitive run in parallel, then Bull and Bear run in parallel. Verifier performs fresh search. Orchestration persists actual provider usage, budgets, events and admitted evidence. Theme shortlist discovery is a separate smaller team with parallel scouts, price verification, adversarial review and ranking.</a:t>
+              <a:t>There are nine distinct research roles. Bull revision is a feedback pass, not a tenth distinct role. Founder and Competitive run in parallel, then Bull and Bear run in parallel. Verifier performs fresh search. Orchestration persists actual provider usage, budgets, events and admitted evidence. Theme shortlist discovery is a separate smaller team with parallel scouts, price verification, adversarial review and ranking.</a:t>
             </a:r>
           </a:p>
           <a:p xmlns:a="http://schemas.openxmlformats.org/drawingml/2006/main">
@@ -1089,7 +1089,7 @@
           <a:lstStyle xmlns:a="http://schemas.openxmlformats.org/drawingml/2006/main"/>
           <a:p xmlns:a="http://schemas.openxmlformats.org/drawingml/2006/main">
             <a:r>
-              <a:t>Pricing is a proposed hypothesis:299 USD per analyst per month, plus a team plan to be specified. No verified paying customers, contracted pilot funds, revenue, margin or willingness-to-pay evidence has been provided. The ask is an invitation to recruit five pilot funds. Usage limits and unit economics need measurement because long Claude investigations can be token-intensive. Success criteria are proposed pilot measures rather than achieved results. The demo app runs locally unless a separate external deployment is configured.</a:t>
+              <a:t>Pricing is a proposed hypothesis:299 USD per analyst per month, plus a team plan to be specified. No verified paying customers, contracted pilot funds, revenue, margin or willingness-to-pay evidence has been provided. The ask is an invitation to recruit five pilot funds. Usage limits and unit economics need measurement because long Claude investigations can be token-intensive. Success criteria are proposed pilot measures rather than achieved results. The public GitHub Pages output provides a recorded research replay. Fresh Claude execution requires the separate Node server and a private API key.</a:t>
             </a:r>
           </a:p>
           <a:p xmlns:a="http://schemas.openxmlformats.org/drawingml/2006/main">
@@ -1151,7 +1151,7 @@
           <p:cNvPr id="3" name="Title">
             <a:extLst xmlns:a="http://schemas.openxmlformats.org/drawingml/2006/main">
               <a:ext uri="{FF2B5EF4-FFF2-40B4-BE49-F238E27FC236}">
-                <a16:creationId xmlns:a16="http://schemas.microsoft.com/office/drawing/2014/main" id="{20386034-5171-4950-A093-D183F1E63E38}"/>
+                <a16:creationId xmlns:a16="http://schemas.microsoft.com/office/drawing/2014/main" id="{443D7081-20ED-4608-A74C-6F1750931D17}"/>
               </a:ext>
             </a:extLst>
           </p:cNvPr>
@@ -1308,7 +1308,7 @@
           <p:cNvPr id="2" name="Subtitle">
             <a:extLst xmlns:a="http://schemas.openxmlformats.org/drawingml/2006/main">
               <a:ext uri="{FF2B5EF4-FFF2-40B4-BE49-F238E27FC236}">
-                <a16:creationId xmlns:a16="http://schemas.microsoft.com/office/drawing/2014/main" id="{6B3106CA-72F7-45BA-A453-91C81A916C2A}"/>
+                <a16:creationId xmlns:a16="http://schemas.microsoft.com/office/drawing/2014/main" id="{2445450A-AD1A-44DE-ADBC-419B68836252}"/>
               </a:ext>
             </a:extLst>
           </p:cNvPr>
@@ -1482,7 +1482,7 @@
           <p:cNvPr id="2" name="Section title">
             <a:extLst xmlns:a="http://schemas.openxmlformats.org/drawingml/2006/main">
               <a:ext uri="{FF2B5EF4-FFF2-40B4-BE49-F238E27FC236}">
-                <a16:creationId xmlns:a16="http://schemas.microsoft.com/office/drawing/2014/main" id="{D8DD24D9-8FEF-4510-AE63-B182EA5FA011}"/>
+                <a16:creationId xmlns:a16="http://schemas.microsoft.com/office/drawing/2014/main" id="{9E16C008-7129-4895-A40A-83E257FDD66A}"/>
               </a:ext>
             </a:extLst>
           </p:cNvPr>
@@ -1656,7 +1656,7 @@
           <p:cNvPr id="3" name="Title">
             <a:extLst xmlns:a="http://schemas.openxmlformats.org/drawingml/2006/main">
               <a:ext uri="{FF2B5EF4-FFF2-40B4-BE49-F238E27FC236}">
-                <a16:creationId xmlns:a16="http://schemas.microsoft.com/office/drawing/2014/main" id="{C050E8A4-ABA7-4C0A-A3E2-405EE683A5DB}"/>
+                <a16:creationId xmlns:a16="http://schemas.microsoft.com/office/drawing/2014/main" id="{BC29AC3C-1EBA-4B12-9BA4-9B0CD043141A}"/>
               </a:ext>
             </a:extLst>
           </p:cNvPr>
@@ -1813,7 +1813,7 @@
           <p:cNvPr id="2" name="Body">
             <a:extLst xmlns:a="http://schemas.openxmlformats.org/drawingml/2006/main">
               <a:ext uri="{FF2B5EF4-FFF2-40B4-BE49-F238E27FC236}">
-                <a16:creationId xmlns:a16="http://schemas.microsoft.com/office/drawing/2014/main" id="{045A5F02-BA64-4A48-9EAE-86FF59A3F7C5}"/>
+                <a16:creationId xmlns:a16="http://schemas.microsoft.com/office/drawing/2014/main" id="{C8D396EA-8799-476C-AE36-F5FA02FF7F74}"/>
               </a:ext>
             </a:extLst>
           </p:cNvPr>
@@ -1987,7 +1987,7 @@
           <p:cNvPr id="4" name="Title">
             <a:extLst xmlns:a="http://schemas.openxmlformats.org/drawingml/2006/main">
               <a:ext uri="{FF2B5EF4-FFF2-40B4-BE49-F238E27FC236}">
-                <a16:creationId xmlns:a16="http://schemas.microsoft.com/office/drawing/2014/main" id="{196A1AED-E103-486B-9324-A9A27C06D630}"/>
+                <a16:creationId xmlns:a16="http://schemas.microsoft.com/office/drawing/2014/main" id="{7D3D014B-EE74-4CE7-AA60-D523C6AE017D}"/>
               </a:ext>
             </a:extLst>
           </p:cNvPr>
@@ -2144,7 +2144,7 @@
           <p:cNvPr id="2" name="Left column">
             <a:extLst xmlns:a="http://schemas.openxmlformats.org/drawingml/2006/main">
               <a:ext uri="{FF2B5EF4-FFF2-40B4-BE49-F238E27FC236}">
-                <a16:creationId xmlns:a16="http://schemas.microsoft.com/office/drawing/2014/main" id="{8F898D39-68BC-4B13-BEF8-D1E348B9F3F5}"/>
+                <a16:creationId xmlns:a16="http://schemas.microsoft.com/office/drawing/2014/main" id="{5A0933C1-BE81-4914-B2E4-0A41F04A4B4E}"/>
               </a:ext>
             </a:extLst>
           </p:cNvPr>
@@ -2301,7 +2301,7 @@
           <p:cNvPr id="3" name="Right column">
             <a:extLst xmlns:a="http://schemas.openxmlformats.org/drawingml/2006/main">
               <a:ext uri="{FF2B5EF4-FFF2-40B4-BE49-F238E27FC236}">
-                <a16:creationId xmlns:a16="http://schemas.microsoft.com/office/drawing/2014/main" id="{14966A25-99CF-4E46-925D-7E3E50B2C4D2}"/>
+                <a16:creationId xmlns:a16="http://schemas.microsoft.com/office/drawing/2014/main" id="{17015657-7FA0-4C21-A29A-FF75B23F5E5A}"/>
               </a:ext>
             </a:extLst>
           </p:cNvPr>
@@ -2475,7 +2475,7 @@
           <p:cNvPr id="3" name="Title">
             <a:extLst xmlns:a="http://schemas.openxmlformats.org/drawingml/2006/main">
               <a:ext uri="{FF2B5EF4-FFF2-40B4-BE49-F238E27FC236}">
-                <a16:creationId xmlns:a16="http://schemas.microsoft.com/office/drawing/2014/main" id="{39B4CDFC-306A-44FC-A474-EB954C8F2519}"/>
+                <a16:creationId xmlns:a16="http://schemas.microsoft.com/office/drawing/2014/main" id="{0713EB83-D95D-4A80-944C-30A3C831F83C}"/>
               </a:ext>
             </a:extLst>
           </p:cNvPr>
@@ -2632,7 +2632,7 @@
           <p:cNvPr id="2" name="Left column">
             <a:extLst xmlns:a="http://schemas.openxmlformats.org/drawingml/2006/main">
               <a:ext uri="{FF2B5EF4-FFF2-40B4-BE49-F238E27FC236}">
-                <a16:creationId xmlns:a16="http://schemas.microsoft.com/office/drawing/2014/main" id="{4184AA08-50A8-45B3-AFE3-CC547F8ED378}"/>
+                <a16:creationId xmlns:a16="http://schemas.microsoft.com/office/drawing/2014/main" id="{B1AB22E3-9B5B-496B-A72F-467E8538C825}"/>
               </a:ext>
             </a:extLst>
           </p:cNvPr>
@@ -2827,12 +2827,12 @@
   </p:cSld>
   <p:clrMap bg1="lt1" tx1="dk1" bg2="lt2" tx2="dk2" accent1="accent1" accent2="accent2" accent3="accent3" accent4="accent4" accent5="accent5" accent6="accent6" hlink="hlink" folHlink="folHlink"/>
   <p:sldLayoutIdLst>
-    <p:sldLayoutId xmlns:r="http://schemas.openxmlformats.org/officeDocument/2006/relationships" id="2147483649" r:id="Re968f68099824bc5"/>
-    <p:sldLayoutId xmlns:r="http://schemas.openxmlformats.org/officeDocument/2006/relationships" id="2147483650" r:id="R10e853c8de48485c"/>
-    <p:sldLayoutId xmlns:r="http://schemas.openxmlformats.org/officeDocument/2006/relationships" id="2147483651" r:id="R27a635b5301345f4"/>
-    <p:sldLayoutId xmlns:r="http://schemas.openxmlformats.org/officeDocument/2006/relationships" id="2147483652" r:id="Ra515cf26dd224c59"/>
-    <p:sldLayoutId xmlns:r="http://schemas.openxmlformats.org/officeDocument/2006/relationships" id="2147483653" r:id="R3c423c903f344062"/>
-    <p:sldLayoutId xmlns:r="http://schemas.openxmlformats.org/officeDocument/2006/relationships" id="2147483654" r:id="R8ffa2aaf700e49d3"/>
+    <p:sldLayoutId xmlns:r="http://schemas.openxmlformats.org/officeDocument/2006/relationships" id="2147483649" r:id="R25ccc8d1ebef44c3"/>
+    <p:sldLayoutId xmlns:r="http://schemas.openxmlformats.org/officeDocument/2006/relationships" id="2147483650" r:id="R1b860bf577a343cf"/>
+    <p:sldLayoutId xmlns:r="http://schemas.openxmlformats.org/officeDocument/2006/relationships" id="2147483651" r:id="Rca229b02f6af4159"/>
+    <p:sldLayoutId xmlns:r="http://schemas.openxmlformats.org/officeDocument/2006/relationships" id="2147483652" r:id="R455df05343dc4550"/>
+    <p:sldLayoutId xmlns:r="http://schemas.openxmlformats.org/officeDocument/2006/relationships" id="2147483653" r:id="Reec86ebaf86c41b5"/>
+    <p:sldLayoutId xmlns:r="http://schemas.openxmlformats.org/officeDocument/2006/relationships" id="2147483654" r:id="Rf264cae9b29147f3"/>
   </p:sldLayoutIdLst>
   <p:txStyles>
     <p:titleStyle>
@@ -3383,7 +3383,7 @@
           <p:cNvPr id="7" name="slide-number">
             <a:extLst xmlns:a="http://schemas.openxmlformats.org/drawingml/2006/main">
               <a:ext uri="{FF2B5EF4-FFF2-40B4-BE49-F238E27FC236}">
-                <a16:creationId xmlns:a16="http://schemas.microsoft.com/office/drawing/2014/main" id="{E056F826-894E-448E-B7D1-B1FE7FF336BA}"/>
+                <a16:creationId xmlns:a16="http://schemas.microsoft.com/office/drawing/2014/main" id="{C9290A94-EC6D-484B-B297-E4B60ACE65D1}"/>
               </a:ext>
             </a:extLst>
           </p:cNvPr>
@@ -3451,7 +3451,7 @@
           <p:cNvPr id="2" name="">
             <a:extLst xmlns:a="http://schemas.openxmlformats.org/drawingml/2006/main">
               <a:ext uri="{FF2B5EF4-FFF2-40B4-BE49-F238E27FC236}">
-                <a16:creationId xmlns:a16="http://schemas.microsoft.com/office/drawing/2014/main" id="{C20437BC-4904-47BF-B0E2-8F0380195815}"/>
+                <a16:creationId xmlns:a16="http://schemas.microsoft.com/office/drawing/2014/main" id="{4FEFD1E5-C313-4CCB-AA60-CCBA8F66E946}"/>
               </a:ext>
             </a:extLst>
           </p:cNvPr>
@@ -3461,10 +3461,10 @@
           <p:nvPr/>
         </p:nvPicPr>
         <p:blipFill>
-          <a:blip xmlns:r="http://schemas.openxmlformats.org/officeDocument/2006/relationships" xmlns:a="http://schemas.openxmlformats.org/drawingml/2006/main" r:embed="R9e6f9defcbbf413e">
+          <a:blip xmlns:r="http://schemas.openxmlformats.org/officeDocument/2006/relationships" xmlns:a="http://schemas.openxmlformats.org/drawingml/2006/main" r:embed="Rcfd1047079354857">
             <a:extLst>
               <a:ext uri="{96DAC541-7B7A-43D3-8B79-37D633B846F1}">
-                <asvg:svgBlip xmlns:asvg="http://schemas.microsoft.com/office/drawing/2016/SVG/main" r:embed="R2bf7d9f4198542eb"/>
+                <asvg:svgBlip xmlns:asvg="http://schemas.microsoft.com/office/drawing/2016/SVG/main" r:embed="R9db32e91fb5e4a4f"/>
               </a:ext>
             </a:extLst>
           </a:blip>
@@ -3485,7 +3485,7 @@
           <p:cNvPr id="3" name="wordmark">
             <a:extLst xmlns:a="http://schemas.openxmlformats.org/drawingml/2006/main">
               <a:ext uri="{FF2B5EF4-FFF2-40B4-BE49-F238E27FC236}">
-                <a16:creationId xmlns:a16="http://schemas.microsoft.com/office/drawing/2014/main" id="{CDC802F2-F94D-4BCF-AB4E-C7DD998785C9}"/>
+                <a16:creationId xmlns:a16="http://schemas.microsoft.com/office/drawing/2014/main" id="{16B6D334-DA06-4D25-AE31-8867018A78B5}"/>
               </a:ext>
             </a:extLst>
           </p:cNvPr>
@@ -3553,7 +3553,7 @@
           <p:cNvPr id="4" name="cover-title">
             <a:extLst xmlns:a="http://schemas.openxmlformats.org/drawingml/2006/main">
               <a:ext uri="{FF2B5EF4-FFF2-40B4-BE49-F238E27FC236}">
-                <a16:creationId xmlns:a16="http://schemas.microsoft.com/office/drawing/2014/main" id="{D53A9689-4133-4D3A-8D88-367209A16FD6}"/>
+                <a16:creationId xmlns:a16="http://schemas.microsoft.com/office/drawing/2014/main" id="{0136E58B-3FBB-4807-8AAE-013014FE8307}"/>
               </a:ext>
             </a:extLst>
           </p:cNvPr>
@@ -3644,7 +3644,7 @@
           <p:cNvPr id="5" name="cover-description">
             <a:extLst xmlns:a="http://schemas.openxmlformats.org/drawingml/2006/main">
               <a:ext uri="{FF2B5EF4-FFF2-40B4-BE49-F238E27FC236}">
-                <a16:creationId xmlns:a16="http://schemas.microsoft.com/office/drawing/2014/main" id="{8A88691F-19A5-42B4-B0DA-050409A44250}"/>
+                <a16:creationId xmlns:a16="http://schemas.microsoft.com/office/drawing/2014/main" id="{55D9DEDB-BE02-496D-8729-390B72781ACA}"/>
               </a:ext>
             </a:extLst>
           </p:cNvPr>
@@ -3712,7 +3712,7 @@
           <p:cNvPr id="6" name="cover-link">
             <a:extLst xmlns:a="http://schemas.openxmlformats.org/drawingml/2006/main">
               <a:ext uri="{FF2B5EF4-FFF2-40B4-BE49-F238E27FC236}">
-                <a16:creationId xmlns:a16="http://schemas.microsoft.com/office/drawing/2014/main" id="{72C8DC9F-E9F4-46E2-B817-B740EBFCF341}"/>
+                <a16:creationId xmlns:a16="http://schemas.microsoft.com/office/drawing/2014/main" id="{824FFBE1-F8F0-4522-ABCD-813BD8539854}"/>
               </a:ext>
             </a:extLst>
           </p:cNvPr>
@@ -3769,8 +3769,9 @@
                 <a:latin typeface="Arial"/>
                 <a:ea typeface="Arial"/>
                 <a:cs typeface="Arial"/>
+                <a:hlinkClick xmlns:r="http://schemas.openxmlformats.org/officeDocument/2006/relationships" r:id="R217d8230dbfe47f7"/>
               </a:rPr>
-              <a:t>github.com/eliott-crypto/PARALLAX</a:t>
+              <a:t>eliott-crypto.github.io/PARALLAX</a:t>
             </a:r>
           </a:p>
         </p:txBody>
@@ -3778,7 +3779,7 @@
     </p:spTree>
     <p:extLst>
       <p:ext uri="{BB962C8B-B14F-4D97-AF65-F5344CB8AC3E}">
-        <p14:creationId xmlns:p14="http://schemas.microsoft.com/office/powerpoint/2010/main" val="503302537"/>
+        <p14:creationId xmlns:p14="http://schemas.microsoft.com/office/powerpoint/2010/main" val="575917113"/>
       </p:ext>
     </p:extLst>
   </p:cSld>
@@ -3809,7 +3810,7 @@
           <p:cNvPr id="8" name="slide-number">
             <a:extLst xmlns:a="http://schemas.openxmlformats.org/drawingml/2006/main">
               <a:ext uri="{FF2B5EF4-FFF2-40B4-BE49-F238E27FC236}">
-                <a16:creationId xmlns:a16="http://schemas.microsoft.com/office/drawing/2014/main" id="{1C9CCE2D-F312-4E8C-A697-2EEB413B801D}"/>
+                <a16:creationId xmlns:a16="http://schemas.microsoft.com/office/drawing/2014/main" id="{906D2C77-0579-4635-9B47-10BEAE5B3D8E}"/>
               </a:ext>
             </a:extLst>
           </p:cNvPr>
@@ -3877,7 +3878,7 @@
           <p:cNvPr id="2" name="slide-title">
             <a:extLst xmlns:a="http://schemas.openxmlformats.org/drawingml/2006/main">
               <a:ext uri="{FF2B5EF4-FFF2-40B4-BE49-F238E27FC236}">
-                <a16:creationId xmlns:a16="http://schemas.microsoft.com/office/drawing/2014/main" id="{3C6B4750-853D-4A9F-A2B8-B903DDAE0B11}"/>
+                <a16:creationId xmlns:a16="http://schemas.microsoft.com/office/drawing/2014/main" id="{8B8BF4E1-BE23-411A-83B6-FA02B34C8040}"/>
               </a:ext>
             </a:extLst>
           </p:cNvPr>
@@ -3945,7 +3946,7 @@
           <p:cNvPr id="3" name="customer-label">
             <a:extLst xmlns:a="http://schemas.openxmlformats.org/drawingml/2006/main">
               <a:ext uri="{FF2B5EF4-FFF2-40B4-BE49-F238E27FC236}">
-                <a16:creationId xmlns:a16="http://schemas.microsoft.com/office/drawing/2014/main" id="{C7A0AA4C-CFBE-4465-8AC6-F086645F1205}"/>
+                <a16:creationId xmlns:a16="http://schemas.microsoft.com/office/drawing/2014/main" id="{FBA00276-9BAD-4DA5-96E3-6745E1ABF5E1}"/>
               </a:ext>
             </a:extLst>
           </p:cNvPr>
@@ -4013,7 +4014,7 @@
           <p:cNvPr id="4" name="customer">
             <a:extLst xmlns:a="http://schemas.openxmlformats.org/drawingml/2006/main">
               <a:ext uri="{FF2B5EF4-FFF2-40B4-BE49-F238E27FC236}">
-                <a16:creationId xmlns:a16="http://schemas.microsoft.com/office/drawing/2014/main" id="{C36C8DA5-D67B-45A5-A18B-C4ADBD005BD5}"/>
+                <a16:creationId xmlns:a16="http://schemas.microsoft.com/office/drawing/2014/main" id="{BD5DABDA-019E-4CB8-9DE9-F036DF847D1A}"/>
               </a:ext>
             </a:extLst>
           </p:cNvPr>
@@ -4104,7 +4105,7 @@
           <p:cNvPr id="5" name="customer-job">
             <a:extLst xmlns:a="http://schemas.openxmlformats.org/drawingml/2006/main">
               <a:ext uri="{FF2B5EF4-FFF2-40B4-BE49-F238E27FC236}">
-                <a16:creationId xmlns:a16="http://schemas.microsoft.com/office/drawing/2014/main" id="{A12F55AC-C556-44F0-89CD-FB40F10BDC06}"/>
+                <a16:creationId xmlns:a16="http://schemas.microsoft.com/office/drawing/2014/main" id="{12D11661-4FA4-4517-96E7-EA268B221081}"/>
               </a:ext>
             </a:extLst>
           </p:cNvPr>
@@ -4218,7 +4219,7 @@
           <p:cNvPr id="6" name="decision">
             <a:extLst xmlns:a="http://schemas.openxmlformats.org/drawingml/2006/main">
               <a:ext uri="{FF2B5EF4-FFF2-40B4-BE49-F238E27FC236}">
-                <a16:creationId xmlns:a16="http://schemas.microsoft.com/office/drawing/2014/main" id="{47A4EEC2-93E3-4C70-B888-A82804DD9988}"/>
+                <a16:creationId xmlns:a16="http://schemas.microsoft.com/office/drawing/2014/main" id="{7199ECE1-0B75-47AA-B030-13477CB1750E}"/>
               </a:ext>
             </a:extLst>
           </p:cNvPr>
@@ -4309,7 +4310,7 @@
           <p:cNvPr id="7" name="decision-risk">
             <a:extLst xmlns:a="http://schemas.openxmlformats.org/drawingml/2006/main">
               <a:ext uri="{FF2B5EF4-FFF2-40B4-BE49-F238E27FC236}">
-                <a16:creationId xmlns:a16="http://schemas.microsoft.com/office/drawing/2014/main" id="{898D5867-FB0F-4147-8BFC-2195E2D81B5F}"/>
+                <a16:creationId xmlns:a16="http://schemas.microsoft.com/office/drawing/2014/main" id="{2188CEBB-C124-4263-AFC4-E82108541B35}"/>
               </a:ext>
             </a:extLst>
           </p:cNvPr>
@@ -4421,7 +4422,7 @@
     </p:spTree>
     <p:extLst>
       <p:ext uri="{BB962C8B-B14F-4D97-AF65-F5344CB8AC3E}">
-        <p14:creationId xmlns:p14="http://schemas.microsoft.com/office/powerpoint/2010/main" val="373451662"/>
+        <p14:creationId xmlns:p14="http://schemas.microsoft.com/office/powerpoint/2010/main" val="1728693295"/>
       </p:ext>
     </p:extLst>
   </p:cSld>
@@ -4452,7 +4453,7 @@
           <p:cNvPr id="8" name="slide-number">
             <a:extLst xmlns:a="http://schemas.openxmlformats.org/drawingml/2006/main">
               <a:ext uri="{FF2B5EF4-FFF2-40B4-BE49-F238E27FC236}">
-                <a16:creationId xmlns:a16="http://schemas.microsoft.com/office/drawing/2014/main" id="{A204FA22-973F-4E6C-A41C-D5801243E2E4}"/>
+                <a16:creationId xmlns:a16="http://schemas.microsoft.com/office/drawing/2014/main" id="{77E06140-B8DF-49CA-854B-1BAB23A41976}"/>
               </a:ext>
             </a:extLst>
           </p:cNvPr>
@@ -4520,7 +4521,7 @@
           <p:cNvPr id="2" name="slide-title">
             <a:extLst xmlns:a="http://schemas.openxmlformats.org/drawingml/2006/main">
               <a:ext uri="{FF2B5EF4-FFF2-40B4-BE49-F238E27FC236}">
-                <a16:creationId xmlns:a16="http://schemas.microsoft.com/office/drawing/2014/main" id="{5BB0B68B-73C1-4C2B-AD9A-F38995214D04}"/>
+                <a16:creationId xmlns:a16="http://schemas.microsoft.com/office/drawing/2014/main" id="{6304A87A-9D20-4F8B-9892-AF88B8F66E07}"/>
               </a:ext>
             </a:extLst>
           </p:cNvPr>
@@ -4588,7 +4589,7 @@
           <p:cNvPr id="3" name="shortlist-description">
             <a:extLst xmlns:a="http://schemas.openxmlformats.org/drawingml/2006/main">
               <a:ext uri="{FF2B5EF4-FFF2-40B4-BE49-F238E27FC236}">
-                <a16:creationId xmlns:a16="http://schemas.microsoft.com/office/drawing/2014/main" id="{DA190B53-0C0E-4A41-BF8B-5192AB835E3E}"/>
+                <a16:creationId xmlns:a16="http://schemas.microsoft.com/office/drawing/2014/main" id="{6CFBD159-BF7A-4250-A99D-000F03BA9BD5}"/>
               </a:ext>
             </a:extLst>
           </p:cNvPr>
@@ -4679,7 +4680,7 @@
           <p:cNvPr id="4" name="shortlist-body">
             <a:extLst xmlns:a="http://schemas.openxmlformats.org/drawingml/2006/main">
               <a:ext uri="{FF2B5EF4-FFF2-40B4-BE49-F238E27FC236}">
-                <a16:creationId xmlns:a16="http://schemas.microsoft.com/office/drawing/2014/main" id="{243AF324-BBED-4FF1-AC5C-DC88C1A29D4D}"/>
+                <a16:creationId xmlns:a16="http://schemas.microsoft.com/office/drawing/2014/main" id="{EC750104-841F-46EA-849C-AA672459418A}"/>
               </a:ext>
             </a:extLst>
           </p:cNvPr>
@@ -4816,7 +4817,7 @@
           <p:cNvPr id="5" name="shortlist-preference">
             <a:extLst xmlns:a="http://schemas.openxmlformats.org/drawingml/2006/main">
               <a:ext uri="{FF2B5EF4-FFF2-40B4-BE49-F238E27FC236}">
-                <a16:creationId xmlns:a16="http://schemas.microsoft.com/office/drawing/2014/main" id="{1026B1E8-2069-44CB-A2E8-064690280770}"/>
+                <a16:creationId xmlns:a16="http://schemas.microsoft.com/office/drawing/2014/main" id="{D5D3BD7A-BBE2-4BBB-94E5-109DCB6C8C27}"/>
               </a:ext>
             </a:extLst>
           </p:cNvPr>
@@ -4907,7 +4908,7 @@
           <p:cNvPr id="6" name="">
             <a:extLst xmlns:a="http://schemas.openxmlformats.org/drawingml/2006/main">
               <a:ext uri="{FF2B5EF4-FFF2-40B4-BE49-F238E27FC236}">
-                <a16:creationId xmlns:a16="http://schemas.microsoft.com/office/drawing/2014/main" id="{06DD1C01-01AB-4A32-B9CC-038EED6C2DF3}"/>
+                <a16:creationId xmlns:a16="http://schemas.microsoft.com/office/drawing/2014/main" id="{B8D5AE33-B3AF-419F-B12C-58F33C18DAC6}"/>
               </a:ext>
             </a:extLst>
           </p:cNvPr>
@@ -4917,7 +4918,7 @@
           <p:nvPr/>
         </p:nvPicPr>
         <p:blipFill>
-          <a:blip xmlns:r="http://schemas.openxmlformats.org/officeDocument/2006/relationships" xmlns:a="http://schemas.openxmlformats.org/drawingml/2006/main" r:embed="R7cf94e9f5da54a2b"/>
+          <a:blip xmlns:r="http://schemas.openxmlformats.org/officeDocument/2006/relationships" xmlns:a="http://schemas.openxmlformats.org/drawingml/2006/main" r:embed="Rffa362fb2f3f41c3"/>
           <a:stretch xmlns:a="http://schemas.openxmlformats.org/drawingml/2006/main"/>
         </p:blipFill>
         <p:spPr>
@@ -4935,7 +4936,7 @@
           <p:cNvPr id="7" name="financing-note">
             <a:extLst xmlns:a="http://schemas.openxmlformats.org/drawingml/2006/main">
               <a:ext uri="{FF2B5EF4-FFF2-40B4-BE49-F238E27FC236}">
-                <a16:creationId xmlns:a16="http://schemas.microsoft.com/office/drawing/2014/main" id="{5FFC7084-66F9-40DE-B7E5-2D92A617DDD9}"/>
+                <a16:creationId xmlns:a16="http://schemas.microsoft.com/office/drawing/2014/main" id="{72750356-A057-45D9-AA02-34A984DBF7B9}"/>
               </a:ext>
             </a:extLst>
           </p:cNvPr>
@@ -5001,7 +5002,7 @@
     </p:spTree>
     <p:extLst>
       <p:ext uri="{BB962C8B-B14F-4D97-AF65-F5344CB8AC3E}">
-        <p14:creationId xmlns:p14="http://schemas.microsoft.com/office/powerpoint/2010/main" val="1129750673"/>
+        <p14:creationId xmlns:p14="http://schemas.microsoft.com/office/powerpoint/2010/main" val="899557345"/>
       </p:ext>
     </p:extLst>
   </p:cSld>
@@ -5032,7 +5033,7 @@
           <p:cNvPr id="10" name="slide-number">
             <a:extLst xmlns:a="http://schemas.openxmlformats.org/drawingml/2006/main">
               <a:ext uri="{FF2B5EF4-FFF2-40B4-BE49-F238E27FC236}">
-                <a16:creationId xmlns:a16="http://schemas.microsoft.com/office/drawing/2014/main" id="{38DDF5F5-D7E3-4FB9-BA2A-5225D54C49BA}"/>
+                <a16:creationId xmlns:a16="http://schemas.microsoft.com/office/drawing/2014/main" id="{3A7090CA-30CF-43E4-BE5B-AE77F98560DA}"/>
               </a:ext>
             </a:extLst>
           </p:cNvPr>
@@ -5100,7 +5101,7 @@
           <p:cNvPr id="2" name="slide-title">
             <a:extLst xmlns:a="http://schemas.openxmlformats.org/drawingml/2006/main">
               <a:ext uri="{FF2B5EF4-FFF2-40B4-BE49-F238E27FC236}">
-                <a16:creationId xmlns:a16="http://schemas.microsoft.com/office/drawing/2014/main" id="{147D9130-7E4F-4725-92B4-6B98D5B74D94}"/>
+                <a16:creationId xmlns:a16="http://schemas.microsoft.com/office/drawing/2014/main" id="{055E40B4-784F-4A1D-95EF-7F4401D7A732}"/>
               </a:ext>
             </a:extLst>
           </p:cNvPr>
@@ -5168,7 +5169,7 @@
           <p:cNvPr id="3" name="universe-question">
             <a:extLst xmlns:a="http://schemas.openxmlformats.org/drawingml/2006/main">
               <a:ext uri="{FF2B5EF4-FFF2-40B4-BE49-F238E27FC236}">
-                <a16:creationId xmlns:a16="http://schemas.microsoft.com/office/drawing/2014/main" id="{1B6A3874-5B91-4180-9068-CE559DD5D23E}"/>
+                <a16:creationId xmlns:a16="http://schemas.microsoft.com/office/drawing/2014/main" id="{FF4B80CE-4D06-4DF5-A8B7-F27385288DA7}"/>
               </a:ext>
             </a:extLst>
           </p:cNvPr>
@@ -5254,149 +5255,40 @@
           </a:p>
         </p:txBody>
       </p:sp>
-      <p:sp>
-        <p:nvSpPr>
-          <p:cNvPr id="4" name="universe-fallback">
+      <p:pic>
+        <p:nvPicPr>
+          <p:cNvPr id="4" name="">
             <a:extLst xmlns:a="http://schemas.openxmlformats.org/drawingml/2006/main">
               <a:ext uri="{FF2B5EF4-FFF2-40B4-BE49-F238E27FC236}">
-                <a16:creationId xmlns:a16="http://schemas.microsoft.com/office/drawing/2014/main" id="{BBBE698E-1AB5-4385-9910-F343A69531C7}"/>
+                <a16:creationId xmlns:a16="http://schemas.microsoft.com/office/drawing/2014/main" id="{3610613E-D0A3-4796-B2D0-FE58B770C9BA}"/>
               </a:ext>
             </a:extLst>
           </p:cNvPr>
-          <p:cNvSpPr>
-            <a:spLocks xmlns:a="http://schemas.openxmlformats.org/drawingml/2006/main" noGrp="1"/>
-          </p:cNvSpPr>
+          <p:cNvPicPr>
+            <a:picLocks xmlns:a="http://schemas.openxmlformats.org/drawingml/2006/main" noChangeAspect="1"/>
+          </p:cNvPicPr>
           <p:nvPr/>
-        </p:nvSpPr>
+        </p:nvPicPr>
+        <p:blipFill>
+          <a:blip xmlns:r="http://schemas.openxmlformats.org/officeDocument/2006/relationships" xmlns:a="http://schemas.openxmlformats.org/drawingml/2006/main" r:embed="R6eeb2d6738214a01"/>
+          <a:stretch xmlns:a="http://schemas.openxmlformats.org/drawingml/2006/main"/>
+        </p:blipFill>
         <p:spPr>
           <a:xfrm xmlns:a="http://schemas.openxmlformats.org/drawingml/2006/main">
-            <a:off x="647700" y="3162300"/>
-            <a:ext cx="6810375" cy="1952625"/>
+            <a:off x="2120497" y="2762250"/>
+            <a:ext cx="4531531" cy="3324225"/>
           </a:xfrm>
           <a:prstGeom xmlns:a="http://schemas.openxmlformats.org/drawingml/2006/main" prst="rect">
             <a:avLst/>
           </a:prstGeom>
-          <a:noFill xmlns:a="http://schemas.openxmlformats.org/drawingml/2006/main"/>
-          <a:ln xmlns:a="http://schemas.openxmlformats.org/drawingml/2006/main" w="0">
-            <a:noFill/>
-          </a:ln>
-        </p:spPr>
-        <p:txBody>
-          <a:bodyPr xmlns:a="http://schemas.openxmlformats.org/drawingml/2006/main" wrap="square" lIns="0" tIns="0" rIns="0" bIns="0">
-            <a:noAutofit/>
-          </a:bodyPr>
-          <a:lstStyle xmlns:a="http://schemas.openxmlformats.org/drawingml/2006/main">
-            <a:defPPr>
-              <a:defRPr sz="2550" b="0">
-                <a:solidFill>
-                  <a:srgbClr val="F1F7FA"/>
-                </a:solidFill>
-                <a:latin typeface="Arial"/>
-                <a:ea typeface="Arial"/>
-                <a:cs typeface="Arial"/>
-              </a:defRPr>
-            </a:defPPr>
-          </a:lstStyle>
-          <a:p xmlns:a="http://schemas.openxmlformats.org/drawingml/2006/main">
-            <a:pPr>
-              <a:defRPr sz="2550" b="0">
-                <a:solidFill>
-                  <a:srgbClr val="F1F7FA"/>
-                </a:solidFill>
-                <a:latin typeface="Arial"/>
-                <a:ea typeface="Arial"/>
-                <a:cs typeface="Arial"/>
-              </a:defRPr>
-            </a:pPr>
-            <a:r>
-              <a:rPr sz="2550" b="0">
-                <a:solidFill>
-                  <a:srgbClr val="F1F7FA"/>
-                </a:solidFill>
-                <a:latin typeface="Arial"/>
-                <a:ea typeface="Arial"/>
-                <a:cs typeface="Arial"/>
-              </a:rPr>
-              <a:t>The evidence map shows companies</a:t>
-            </a:r>
-          </a:p>
-          <a:p xmlns:a="http://schemas.openxmlformats.org/drawingml/2006/main">
-            <a:pPr>
-              <a:defRPr sz="2550" b="0">
-                <a:solidFill>
-                  <a:srgbClr val="F1F7FA"/>
-                </a:solidFill>
-                <a:latin typeface="Arial"/>
-                <a:ea typeface="Arial"/>
-                <a:cs typeface="Arial"/>
-              </a:defRPr>
-            </a:pPr>
-            <a:r>
-              <a:rPr sz="2550" b="0">
-                <a:solidFill>
-                  <a:srgbClr val="F1F7FA"/>
-                </a:solidFill>
-                <a:latin typeface="Arial"/>
-                <a:ea typeface="Arial"/>
-                <a:cs typeface="Arial"/>
-              </a:rPr>
-              <a:t>across the investor’s themes.</a:t>
-            </a:r>
-          </a:p>
-          <a:p xmlns:a="http://schemas.openxmlformats.org/drawingml/2006/main">
-            <a:pPr>
-              <a:defRPr sz="2550" b="0">
-                <a:solidFill>
-                  <a:srgbClr val="F1F7FA"/>
-                </a:solidFill>
-                <a:latin typeface="Arial"/>
-                <a:ea typeface="Arial"/>
-                <a:cs typeface="Arial"/>
-              </a:defRPr>
-            </a:pPr>
-            <a:r>
-              <a:rPr sz="2550" b="0">
-                <a:solidFill>
-                  <a:srgbClr val="F1F7FA"/>
-                </a:solidFill>
-                <a:latin typeface="Arial"/>
-                <a:ea typeface="Arial"/>
-                <a:cs typeface="Arial"/>
-              </a:rPr>
-              <a:t>A reversible lens removes</a:t>
-            </a:r>
-          </a:p>
-          <a:p xmlns:a="http://schemas.openxmlformats.org/drawingml/2006/main">
-            <a:pPr>
-              <a:defRPr sz="2550" b="0">
-                <a:solidFill>
-                  <a:srgbClr val="F1F7FA"/>
-                </a:solidFill>
-                <a:latin typeface="Arial"/>
-                <a:ea typeface="Arial"/>
-                <a:cs typeface="Arial"/>
-              </a:defRPr>
-            </a:pPr>
-            <a:r>
-              <a:rPr sz="2550" b="0">
-                <a:solidFill>
-                  <a:srgbClr val="F1F7FA"/>
-                </a:solidFill>
-                <a:latin typeface="Arial"/>
-                <a:ea typeface="Arial"/>
-                <a:cs typeface="Arial"/>
-              </a:rPr>
-              <a:t>company claims.</a:t>
-            </a:r>
-          </a:p>
-        </p:txBody>
-      </p:sp>
+        </p:spPr>
+      </p:pic>
       <p:sp>
         <p:nvSpPr>
           <p:cNvPr id="5" name="universe-radius">
             <a:extLst xmlns:a="http://schemas.openxmlformats.org/drawingml/2006/main">
               <a:ext uri="{FF2B5EF4-FFF2-40B4-BE49-F238E27FC236}">
-                <a16:creationId xmlns:a16="http://schemas.microsoft.com/office/drawing/2014/main" id="{D5E4B860-8E63-4432-850C-F0359EF00999}"/>
+                <a16:creationId xmlns:a16="http://schemas.microsoft.com/office/drawing/2014/main" id="{688700AC-1530-4E09-97C1-93BE5F6F3229}"/>
               </a:ext>
             </a:extLst>
           </p:cNvPr>
@@ -5464,7 +5356,7 @@
           <p:cNvPr id="6" name="universe-radius-body">
             <a:extLst xmlns:a="http://schemas.openxmlformats.org/drawingml/2006/main">
               <a:ext uri="{FF2B5EF4-FFF2-40B4-BE49-F238E27FC236}">
-                <a16:creationId xmlns:a16="http://schemas.microsoft.com/office/drawing/2014/main" id="{3CD6B479-B360-4BAB-8BA5-BE4F6E75CC2A}"/>
+                <a16:creationId xmlns:a16="http://schemas.microsoft.com/office/drawing/2014/main" id="{D8AF6325-B925-44B1-ADF8-55500A03EAA6}"/>
               </a:ext>
             </a:extLst>
           </p:cNvPr>
@@ -5555,7 +5447,7 @@
           <p:cNvPr id="7" name="universe-height">
             <a:extLst xmlns:a="http://schemas.openxmlformats.org/drawingml/2006/main">
               <a:ext uri="{FF2B5EF4-FFF2-40B4-BE49-F238E27FC236}">
-                <a16:creationId xmlns:a16="http://schemas.microsoft.com/office/drawing/2014/main" id="{515AAB42-55E8-4E7B-BDB5-6E54ADF09DE9}"/>
+                <a16:creationId xmlns:a16="http://schemas.microsoft.com/office/drawing/2014/main" id="{CABC015C-9CD1-462F-8F0E-D502AD4C9CE9}"/>
               </a:ext>
             </a:extLst>
           </p:cNvPr>
@@ -5623,7 +5515,7 @@
           <p:cNvPr id="8" name="universe-height-body">
             <a:extLst xmlns:a="http://schemas.openxmlformats.org/drawingml/2006/main">
               <a:ext uri="{FF2B5EF4-FFF2-40B4-BE49-F238E27FC236}">
-                <a16:creationId xmlns:a16="http://schemas.microsoft.com/office/drawing/2014/main" id="{0753EFDF-4EB9-4CD0-8C90-60340D4AC88B}"/>
+                <a16:creationId xmlns:a16="http://schemas.microsoft.com/office/drawing/2014/main" id="{DD3BB6B7-4471-41B0-BA8D-18EC783F131F}"/>
               </a:ext>
             </a:extLst>
           </p:cNvPr>
@@ -5691,7 +5583,7 @@
           <p:cNvPr id="9" name="universe-note">
             <a:extLst xmlns:a="http://schemas.openxmlformats.org/drawingml/2006/main">
               <a:ext uri="{FF2B5EF4-FFF2-40B4-BE49-F238E27FC236}">
-                <a16:creationId xmlns:a16="http://schemas.microsoft.com/office/drawing/2014/main" id="{2326F597-430B-4C5B-BB0D-2A4624B7ED10}"/>
+                <a16:creationId xmlns:a16="http://schemas.microsoft.com/office/drawing/2014/main" id="{23059DDF-60C2-4D1E-98D2-AEC91D67BAF1}"/>
               </a:ext>
             </a:extLst>
           </p:cNvPr>
@@ -5757,7 +5649,7 @@
     </p:spTree>
     <p:extLst>
       <p:ext uri="{BB962C8B-B14F-4D97-AF65-F5344CB8AC3E}">
-        <p14:creationId xmlns:p14="http://schemas.microsoft.com/office/powerpoint/2010/main" val="31602601"/>
+        <p14:creationId xmlns:p14="http://schemas.microsoft.com/office/powerpoint/2010/main" val="1638505573"/>
       </p:ext>
     </p:extLst>
   </p:cSld>
@@ -5788,7 +5680,7 @@
           <p:cNvPr id="23" name="">
             <a:extLst xmlns:a="http://schemas.openxmlformats.org/drawingml/2006/main">
               <a:ext uri="{FF2B5EF4-FFF2-40B4-BE49-F238E27FC236}">
-                <a16:creationId xmlns:a16="http://schemas.microsoft.com/office/drawing/2014/main" id="{3920197B-9C96-4219-A2BC-060BA7CE9FB1}"/>
+                <a16:creationId xmlns:a16="http://schemas.microsoft.com/office/drawing/2014/main" id="{E164CEF3-7202-409E-8BC3-2FB47F1E4F29}"/>
               </a:ext>
             </a:extLst>
           </p:cNvPr>
@@ -5819,7 +5711,7 @@
           <p:cNvPr id="22" name="">
             <a:extLst xmlns:a="http://schemas.openxmlformats.org/drawingml/2006/main">
               <a:ext uri="{FF2B5EF4-FFF2-40B4-BE49-F238E27FC236}">
-                <a16:creationId xmlns:a16="http://schemas.microsoft.com/office/drawing/2014/main" id="{84D5DCB1-0030-4196-9665-9EE8CD8DE633}"/>
+                <a16:creationId xmlns:a16="http://schemas.microsoft.com/office/drawing/2014/main" id="{1BB607C5-631D-406E-B636-7A73F8610ABD}"/>
               </a:ext>
             </a:extLst>
           </p:cNvPr>
@@ -5834,11 +5726,8 @@
             <a:off x="8286750" y="3695700"/>
             <a:ext cx="1614488" cy="1400175"/>
           </a:xfrm>
-          <a:prstGeom xmlns:a="http://schemas.openxmlformats.org/drawingml/2006/main" prst="bentConnector4">
-            <a:avLst>
-              <a:gd name="adj1" fmla="val 0"/>
-              <a:gd name="adj2" fmla="val 83673"/>
-            </a:avLst>
+          <a:prstGeom xmlns:a="http://schemas.openxmlformats.org/drawingml/2006/main" prst="straightConnector1">
+            <a:avLst/>
           </a:prstGeom>
           <a:ln xmlns:a="http://schemas.openxmlformats.org/drawingml/2006/main" w="16193">
             <a:solidFill>
@@ -5853,7 +5742,7 @@
           <p:cNvPr id="21" name="">
             <a:extLst xmlns:a="http://schemas.openxmlformats.org/drawingml/2006/main">
               <a:ext uri="{FF2B5EF4-FFF2-40B4-BE49-F238E27FC236}">
-                <a16:creationId xmlns:a16="http://schemas.microsoft.com/office/drawing/2014/main" id="{364CA442-4A87-4B65-959A-BB802CD3B0D8}"/>
+                <a16:creationId xmlns:a16="http://schemas.microsoft.com/office/drawing/2014/main" id="{5B721A19-1801-49EC-8413-043F1F33A3EE}"/>
               </a:ext>
             </a:extLst>
           </p:cNvPr>
@@ -5886,7 +5775,7 @@
           <p:cNvPr id="20" name="">
             <a:extLst xmlns:a="http://schemas.openxmlformats.org/drawingml/2006/main">
               <a:ext uri="{FF2B5EF4-FFF2-40B4-BE49-F238E27FC236}">
-                <a16:creationId xmlns:a16="http://schemas.microsoft.com/office/drawing/2014/main" id="{6BF32F98-D33B-46E7-BB6A-5B3958702ADB}"/>
+                <a16:creationId xmlns:a16="http://schemas.microsoft.com/office/drawing/2014/main" id="{58927CB6-C25A-4472-9812-C5214A04A7C9}"/>
               </a:ext>
             </a:extLst>
           </p:cNvPr>
@@ -5919,7 +5808,7 @@
           <p:cNvPr id="19" name="">
             <a:extLst xmlns:a="http://schemas.openxmlformats.org/drawingml/2006/main">
               <a:ext uri="{FF2B5EF4-FFF2-40B4-BE49-F238E27FC236}">
-                <a16:creationId xmlns:a16="http://schemas.microsoft.com/office/drawing/2014/main" id="{CE3D8B57-1E8B-4F2E-980C-2AF7C438E5D1}"/>
+                <a16:creationId xmlns:a16="http://schemas.microsoft.com/office/drawing/2014/main" id="{E781D17F-757B-404C-BE12-B4540A03D1B0}"/>
               </a:ext>
             </a:extLst>
           </p:cNvPr>
@@ -5950,7 +5839,7 @@
           <p:cNvPr id="18" name="">
             <a:extLst xmlns:a="http://schemas.openxmlformats.org/drawingml/2006/main">
               <a:ext uri="{FF2B5EF4-FFF2-40B4-BE49-F238E27FC236}">
-                <a16:creationId xmlns:a16="http://schemas.microsoft.com/office/drawing/2014/main" id="{E939D42B-7FBE-4D17-9303-116383F292AB}"/>
+                <a16:creationId xmlns:a16="http://schemas.microsoft.com/office/drawing/2014/main" id="{91472D9D-968A-4349-97F3-30AD1E0E7A18}"/>
               </a:ext>
             </a:extLst>
           </p:cNvPr>
@@ -5981,7 +5870,7 @@
           <p:cNvPr id="17" name="">
             <a:extLst xmlns:a="http://schemas.openxmlformats.org/drawingml/2006/main">
               <a:ext uri="{FF2B5EF4-FFF2-40B4-BE49-F238E27FC236}">
-                <a16:creationId xmlns:a16="http://schemas.microsoft.com/office/drawing/2014/main" id="{0C167CF7-6226-4ABA-990B-6560835E5B6D}"/>
+                <a16:creationId xmlns:a16="http://schemas.microsoft.com/office/drawing/2014/main" id="{5C3BAC66-7A6F-4E61-9E0A-227DB614BDB0}"/>
               </a:ext>
             </a:extLst>
           </p:cNvPr>
@@ -6014,7 +5903,7 @@
           <p:cNvPr id="16" name="">
             <a:extLst xmlns:a="http://schemas.openxmlformats.org/drawingml/2006/main">
               <a:ext uri="{FF2B5EF4-FFF2-40B4-BE49-F238E27FC236}">
-                <a16:creationId xmlns:a16="http://schemas.microsoft.com/office/drawing/2014/main" id="{39C2B433-1A1A-49A1-A22B-5DF05BEA50FC}"/>
+                <a16:creationId xmlns:a16="http://schemas.microsoft.com/office/drawing/2014/main" id="{463FE674-4B89-484D-8BA5-022FF9196EB9}"/>
               </a:ext>
             </a:extLst>
           </p:cNvPr>
@@ -6047,7 +5936,7 @@
           <p:cNvPr id="15" name="">
             <a:extLst xmlns:a="http://schemas.openxmlformats.org/drawingml/2006/main">
               <a:ext uri="{FF2B5EF4-FFF2-40B4-BE49-F238E27FC236}">
-                <a16:creationId xmlns:a16="http://schemas.microsoft.com/office/drawing/2014/main" id="{3DACCC21-B214-462C-8F1B-597A4810FA32}"/>
+                <a16:creationId xmlns:a16="http://schemas.microsoft.com/office/drawing/2014/main" id="{EA9A1F20-B985-4F4F-A541-40A6F413694A}"/>
               </a:ext>
             </a:extLst>
           </p:cNvPr>
@@ -6078,7 +5967,7 @@
           <p:cNvPr id="14" name="">
             <a:extLst xmlns:a="http://schemas.openxmlformats.org/drawingml/2006/main">
               <a:ext uri="{FF2B5EF4-FFF2-40B4-BE49-F238E27FC236}">
-                <a16:creationId xmlns:a16="http://schemas.microsoft.com/office/drawing/2014/main" id="{B1726652-F277-4907-B34A-C2F9391EF561}"/>
+                <a16:creationId xmlns:a16="http://schemas.microsoft.com/office/drawing/2014/main" id="{2E1009EB-A8F9-486E-87F0-8548044704E4}"/>
               </a:ext>
             </a:extLst>
           </p:cNvPr>
@@ -6109,7 +5998,7 @@
           <p:cNvPr id="26" name="slide-number">
             <a:extLst xmlns:a="http://schemas.openxmlformats.org/drawingml/2006/main">
               <a:ext uri="{FF2B5EF4-FFF2-40B4-BE49-F238E27FC236}">
-                <a16:creationId xmlns:a16="http://schemas.microsoft.com/office/drawing/2014/main" id="{B428BDCD-00AE-4456-A914-A4F0C8F90BF3}"/>
+                <a16:creationId xmlns:a16="http://schemas.microsoft.com/office/drawing/2014/main" id="{06BA9E92-17F5-4589-9B07-F52C2C9B13C7}"/>
               </a:ext>
             </a:extLst>
           </p:cNvPr>
@@ -6177,7 +6066,7 @@
           <p:cNvPr id="2" name="slide-title">
             <a:extLst xmlns:a="http://schemas.openxmlformats.org/drawingml/2006/main">
               <a:ext uri="{FF2B5EF4-FFF2-40B4-BE49-F238E27FC236}">
-                <a16:creationId xmlns:a16="http://schemas.microsoft.com/office/drawing/2014/main" id="{5B45A227-0BE6-4AE0-80DB-95B163C1DAC6}"/>
+                <a16:creationId xmlns:a16="http://schemas.microsoft.com/office/drawing/2014/main" id="{0206276E-588B-4E9F-9D0D-FD67B8AF8A75}"/>
               </a:ext>
             </a:extLst>
           </p:cNvPr>
@@ -6245,7 +6134,7 @@
           <p:cNvPr id="3" name="architecture-description">
             <a:extLst xmlns:a="http://schemas.openxmlformats.org/drawingml/2006/main">
               <a:ext uri="{FF2B5EF4-FFF2-40B4-BE49-F238E27FC236}">
-                <a16:creationId xmlns:a16="http://schemas.microsoft.com/office/drawing/2014/main" id="{6A2F579B-BED3-4BA8-88B0-2263EF0CFDD5}"/>
+                <a16:creationId xmlns:a16="http://schemas.microsoft.com/office/drawing/2014/main" id="{3DFC914E-CDEC-4C45-997B-F7B509B343DD}"/>
               </a:ext>
             </a:extLst>
           </p:cNvPr>
@@ -6313,7 +6202,7 @@
           <p:cNvPr id="4" name="scout">
             <a:extLst xmlns:a="http://schemas.openxmlformats.org/drawingml/2006/main">
               <a:ext uri="{FF2B5EF4-FFF2-40B4-BE49-F238E27FC236}">
-                <a16:creationId xmlns:a16="http://schemas.microsoft.com/office/drawing/2014/main" id="{2201D45F-6744-406F-AC92-A7EBD3864778}"/>
+                <a16:creationId xmlns:a16="http://schemas.microsoft.com/office/drawing/2014/main" id="{1BD61E17-5353-47A1-90B8-B9CE5D74E6BE}"/>
               </a:ext>
             </a:extLst>
           </p:cNvPr>
@@ -6383,7 +6272,7 @@
           <p:cNvPr id="5" name="causal">
             <a:extLst xmlns:a="http://schemas.openxmlformats.org/drawingml/2006/main">
               <a:ext uri="{FF2B5EF4-FFF2-40B4-BE49-F238E27FC236}">
-                <a16:creationId xmlns:a16="http://schemas.microsoft.com/office/drawing/2014/main" id="{7B65675A-A555-4ECD-9C2D-F9F507958CE8}"/>
+                <a16:creationId xmlns:a16="http://schemas.microsoft.com/office/drawing/2014/main" id="{9EA11600-45A5-47D8-AF96-098615CB5A7F}"/>
               </a:ext>
             </a:extLst>
           </p:cNvPr>
@@ -6453,7 +6342,7 @@
           <p:cNvPr id="6" name="hunter">
             <a:extLst xmlns:a="http://schemas.openxmlformats.org/drawingml/2006/main">
               <a:ext uri="{FF2B5EF4-FFF2-40B4-BE49-F238E27FC236}">
-                <a16:creationId xmlns:a16="http://schemas.microsoft.com/office/drawing/2014/main" id="{15F99817-E02D-4A8B-9763-19AFE4503C24}"/>
+                <a16:creationId xmlns:a16="http://schemas.microsoft.com/office/drawing/2014/main" id="{9FA22A4C-8768-4C3D-B6D8-02FB7061BE9A}"/>
               </a:ext>
             </a:extLst>
           </p:cNvPr>
@@ -6523,7 +6412,7 @@
           <p:cNvPr id="7" name="founder">
             <a:extLst xmlns:a="http://schemas.openxmlformats.org/drawingml/2006/main">
               <a:ext uri="{FF2B5EF4-FFF2-40B4-BE49-F238E27FC236}">
-                <a16:creationId xmlns:a16="http://schemas.microsoft.com/office/drawing/2014/main" id="{EA1B4A6C-CD71-4401-AD51-B6FEB23B70A6}"/>
+                <a16:creationId xmlns:a16="http://schemas.microsoft.com/office/drawing/2014/main" id="{3087E8A0-D123-4E00-A00F-2A81DB62D1F3}"/>
               </a:ext>
             </a:extLst>
           </p:cNvPr>
@@ -6593,7 +6482,7 @@
           <p:cNvPr id="8" name="competitive">
             <a:extLst xmlns:a="http://schemas.openxmlformats.org/drawingml/2006/main">
               <a:ext uri="{FF2B5EF4-FFF2-40B4-BE49-F238E27FC236}">
-                <a16:creationId xmlns:a16="http://schemas.microsoft.com/office/drawing/2014/main" id="{CC7631F9-AE1D-4031-B4ED-C54D93A6AB64}"/>
+                <a16:creationId xmlns:a16="http://schemas.microsoft.com/office/drawing/2014/main" id="{7EE96F2F-3C6D-488E-904A-F26BE00F7919}"/>
               </a:ext>
             </a:extLst>
           </p:cNvPr>
@@ -6686,7 +6575,7 @@
           <p:cNvPr id="9" name="bull">
             <a:extLst xmlns:a="http://schemas.openxmlformats.org/drawingml/2006/main">
               <a:ext uri="{FF2B5EF4-FFF2-40B4-BE49-F238E27FC236}">
-                <a16:creationId xmlns:a16="http://schemas.microsoft.com/office/drawing/2014/main" id="{84E10E16-7542-4F9F-9C40-80BA708C3FE8}"/>
+                <a16:creationId xmlns:a16="http://schemas.microsoft.com/office/drawing/2014/main" id="{3E4AFB3C-2024-4B1C-96B7-EFD232992652}"/>
               </a:ext>
             </a:extLst>
           </p:cNvPr>
@@ -6756,7 +6645,7 @@
           <p:cNvPr id="10" name="bear">
             <a:extLst xmlns:a="http://schemas.openxmlformats.org/drawingml/2006/main">
               <a:ext uri="{FF2B5EF4-FFF2-40B4-BE49-F238E27FC236}">
-                <a16:creationId xmlns:a16="http://schemas.microsoft.com/office/drawing/2014/main" id="{9C29FABA-CB1C-4A6A-B907-09B9E424BCCD}"/>
+                <a16:creationId xmlns:a16="http://schemas.microsoft.com/office/drawing/2014/main" id="{B2089D40-83AA-4DB9-B30C-C43CDCAB5D4E}"/>
               </a:ext>
             </a:extLst>
           </p:cNvPr>
@@ -6826,7 +6715,7 @@
           <p:cNvPr id="11" name="verifier">
             <a:extLst xmlns:a="http://schemas.openxmlformats.org/drawingml/2006/main">
               <a:ext uri="{FF2B5EF4-FFF2-40B4-BE49-F238E27FC236}">
-                <a16:creationId xmlns:a16="http://schemas.microsoft.com/office/drawing/2014/main" id="{BDB54B35-D188-4622-9DA6-BEB50DD63AA9}"/>
+                <a16:creationId xmlns:a16="http://schemas.microsoft.com/office/drawing/2014/main" id="{6BE6C391-968C-4DBD-A8F6-3636910209B7}"/>
               </a:ext>
             </a:extLst>
           </p:cNvPr>
@@ -6896,7 +6785,7 @@
           <p:cNvPr id="12" name="revision">
             <a:extLst xmlns:a="http://schemas.openxmlformats.org/drawingml/2006/main">
               <a:ext uri="{FF2B5EF4-FFF2-40B4-BE49-F238E27FC236}">
-                <a16:creationId xmlns:a16="http://schemas.microsoft.com/office/drawing/2014/main" id="{CE7D510C-E23B-457E-B606-B375A45D756D}"/>
+                <a16:creationId xmlns:a16="http://schemas.microsoft.com/office/drawing/2014/main" id="{22907BCA-4873-42E7-A9A1-0F02CC6E5D03}"/>
               </a:ext>
             </a:extLst>
           </p:cNvPr>
@@ -6966,7 +6855,7 @@
           <p:cNvPr id="13" name="committee">
             <a:extLst xmlns:a="http://schemas.openxmlformats.org/drawingml/2006/main">
               <a:ext uri="{FF2B5EF4-FFF2-40B4-BE49-F238E27FC236}">
-                <a16:creationId xmlns:a16="http://schemas.microsoft.com/office/drawing/2014/main" id="{221F51EF-033D-4D39-A354-223C2393995A}"/>
+                <a16:creationId xmlns:a16="http://schemas.microsoft.com/office/drawing/2014/main" id="{0A4F7874-E7B3-4430-B2B8-1185B63C13F3}"/>
               </a:ext>
             </a:extLst>
           </p:cNvPr>
@@ -7059,7 +6948,7 @@
           <p:cNvPr id="24" name="parallel-research">
             <a:extLst xmlns:a="http://schemas.openxmlformats.org/drawingml/2006/main">
               <a:ext uri="{FF2B5EF4-FFF2-40B4-BE49-F238E27FC236}">
-                <a16:creationId xmlns:a16="http://schemas.microsoft.com/office/drawing/2014/main" id="{B4790285-C12F-4513-83C7-3EFB9EDFF62C}"/>
+                <a16:creationId xmlns:a16="http://schemas.microsoft.com/office/drawing/2014/main" id="{D3173220-E6C1-4600-8301-D397252FE70E}"/>
               </a:ext>
             </a:extLst>
           </p:cNvPr>
@@ -7127,7 +7016,7 @@
           <p:cNvPr id="25" name="architecture-note">
             <a:extLst xmlns:a="http://schemas.openxmlformats.org/drawingml/2006/main">
               <a:ext uri="{FF2B5EF4-FFF2-40B4-BE49-F238E27FC236}">
-                <a16:creationId xmlns:a16="http://schemas.microsoft.com/office/drawing/2014/main" id="{E78175BC-690D-4334-9567-5F873A2F27E2}"/>
+                <a16:creationId xmlns:a16="http://schemas.microsoft.com/office/drawing/2014/main" id="{F6AB6161-40C9-4A90-8475-73D3AE21AC79}"/>
               </a:ext>
             </a:extLst>
           </p:cNvPr>
@@ -7193,7 +7082,7 @@
     </p:spTree>
     <p:extLst>
       <p:ext uri="{BB962C8B-B14F-4D97-AF65-F5344CB8AC3E}">
-        <p14:creationId xmlns:p14="http://schemas.microsoft.com/office/powerpoint/2010/main" val="2059843951"/>
+        <p14:creationId xmlns:p14="http://schemas.microsoft.com/office/powerpoint/2010/main" val="207526064"/>
       </p:ext>
     </p:extLst>
   </p:cSld>
@@ -7224,7 +7113,7 @@
           <p:cNvPr id="10" name="slide-number">
             <a:extLst xmlns:a="http://schemas.openxmlformats.org/drawingml/2006/main">
               <a:ext uri="{FF2B5EF4-FFF2-40B4-BE49-F238E27FC236}">
-                <a16:creationId xmlns:a16="http://schemas.microsoft.com/office/drawing/2014/main" id="{F5361051-2F1E-4058-8B57-A4A556AAAA35}"/>
+                <a16:creationId xmlns:a16="http://schemas.microsoft.com/office/drawing/2014/main" id="{2364BF79-83BC-4B55-BA6A-599555D279B8}"/>
               </a:ext>
             </a:extLst>
           </p:cNvPr>
@@ -7292,7 +7181,7 @@
           <p:cNvPr id="2" name="slide-title">
             <a:extLst xmlns:a="http://schemas.openxmlformats.org/drawingml/2006/main">
               <a:ext uri="{FF2B5EF4-FFF2-40B4-BE49-F238E27FC236}">
-                <a16:creationId xmlns:a16="http://schemas.microsoft.com/office/drawing/2014/main" id="{3208B202-27AA-4EE2-B307-B55251CF4878}"/>
+                <a16:creationId xmlns:a16="http://schemas.microsoft.com/office/drawing/2014/main" id="{A7076196-36A7-47A3-B838-34F0287E8C13}"/>
               </a:ext>
             </a:extLst>
           </p:cNvPr>
@@ -7360,7 +7249,7 @@
           <p:cNvPr id="3" name="case-label">
             <a:extLst xmlns:a="http://schemas.openxmlformats.org/drawingml/2006/main">
               <a:ext uri="{FF2B5EF4-FFF2-40B4-BE49-F238E27FC236}">
-                <a16:creationId xmlns:a16="http://schemas.microsoft.com/office/drawing/2014/main" id="{469E15AE-2A78-4597-BE63-8D2FB6A85D48}"/>
+                <a16:creationId xmlns:a16="http://schemas.microsoft.com/office/drawing/2014/main" id="{3B277D41-7290-4A2B-A60A-C2FA9CC1677A}"/>
               </a:ext>
             </a:extLst>
           </p:cNvPr>
@@ -7428,7 +7317,7 @@
           <p:cNvPr id="4" name="wrong-attribution">
             <a:extLst xmlns:a="http://schemas.openxmlformats.org/drawingml/2006/main">
               <a:ext uri="{FF2B5EF4-FFF2-40B4-BE49-F238E27FC236}">
-                <a16:creationId xmlns:a16="http://schemas.microsoft.com/office/drawing/2014/main" id="{7B554482-A49C-401B-ACB6-4537630D5F31}"/>
+                <a16:creationId xmlns:a16="http://schemas.microsoft.com/office/drawing/2014/main" id="{C6EF29E9-246E-411F-9ECF-D8C3241A36EA}"/>
               </a:ext>
             </a:extLst>
           </p:cNvPr>
@@ -7496,7 +7385,7 @@
           <p:cNvPr id="5" name="case-explanation">
             <a:extLst xmlns:a="http://schemas.openxmlformats.org/drawingml/2006/main">
               <a:ext uri="{FF2B5EF4-FFF2-40B4-BE49-F238E27FC236}">
-                <a16:creationId xmlns:a16="http://schemas.microsoft.com/office/drawing/2014/main" id="{6B09F560-98E4-4463-8107-B17B6BDBC6D2}"/>
+                <a16:creationId xmlns:a16="http://schemas.microsoft.com/office/drawing/2014/main" id="{D53F88EA-DF5D-4781-9ACA-00C69B01346E}"/>
               </a:ext>
             </a:extLst>
           </p:cNvPr>
@@ -7610,7 +7499,7 @@
           <p:cNvPr id="6" name="case-verdict">
             <a:extLst xmlns:a="http://schemas.openxmlformats.org/drawingml/2006/main">
               <a:ext uri="{FF2B5EF4-FFF2-40B4-BE49-F238E27FC236}">
-                <a16:creationId xmlns:a16="http://schemas.microsoft.com/office/drawing/2014/main" id="{BE7B36F5-2629-459C-95E6-3CCCD0E176C4}"/>
+                <a16:creationId xmlns:a16="http://schemas.microsoft.com/office/drawing/2014/main" id="{5AEDA869-F32F-43F0-87F6-D8A057E5CDA1}"/>
               </a:ext>
             </a:extLst>
           </p:cNvPr>
@@ -7678,7 +7567,7 @@
           <p:cNvPr id="7" name="case-confidence">
             <a:extLst xmlns:a="http://schemas.openxmlformats.org/drawingml/2006/main">
               <a:ext uri="{FF2B5EF4-FFF2-40B4-BE49-F238E27FC236}">
-                <a16:creationId xmlns:a16="http://schemas.microsoft.com/office/drawing/2014/main" id="{500C7AA0-6F42-408A-822B-9A36B6D8E64B}"/>
+                <a16:creationId xmlns:a16="http://schemas.microsoft.com/office/drawing/2014/main" id="{34F7DAD4-F14F-4C0A-8659-A58F123844CC}"/>
               </a:ext>
             </a:extLst>
           </p:cNvPr>
@@ -7746,7 +7635,7 @@
           <p:cNvPr id="8" name="">
             <a:extLst xmlns:a="http://schemas.openxmlformats.org/drawingml/2006/main">
               <a:ext uri="{FF2B5EF4-FFF2-40B4-BE49-F238E27FC236}">
-                <a16:creationId xmlns:a16="http://schemas.microsoft.com/office/drawing/2014/main" id="{5BA6687C-F681-4C35-8B6B-A0DC9B98BE1D}"/>
+                <a16:creationId xmlns:a16="http://schemas.microsoft.com/office/drawing/2014/main" id="{ECA1DE08-8699-427F-BD3B-6F8D7546637E}"/>
               </a:ext>
             </a:extLst>
           </p:cNvPr>
@@ -7756,7 +7645,7 @@
           <p:nvPr/>
         </p:nvPicPr>
         <p:blipFill>
-          <a:blip xmlns:r="http://schemas.openxmlformats.org/officeDocument/2006/relationships" xmlns:a="http://schemas.openxmlformats.org/drawingml/2006/main" r:embed="R90179436aa9045af"/>
+          <a:blip xmlns:r="http://schemas.openxmlformats.org/officeDocument/2006/relationships" xmlns:a="http://schemas.openxmlformats.org/drawingml/2006/main" r:embed="R963251300ee54345"/>
           <a:stretch xmlns:a="http://schemas.openxmlformats.org/drawingml/2006/main"/>
         </p:blipFill>
         <p:spPr>
@@ -7774,7 +7663,7 @@
           <p:cNvPr id="9" name="case-counts">
             <a:extLst xmlns:a="http://schemas.openxmlformats.org/drawingml/2006/main">
               <a:ext uri="{FF2B5EF4-FFF2-40B4-BE49-F238E27FC236}">
-                <a16:creationId xmlns:a16="http://schemas.microsoft.com/office/drawing/2014/main" id="{922B8508-6E61-4DD8-832F-5B7EE66B6FBA}"/>
+                <a16:creationId xmlns:a16="http://schemas.microsoft.com/office/drawing/2014/main" id="{83F0B795-1E27-4C6A-94DF-BACECB202F48}"/>
               </a:ext>
             </a:extLst>
           </p:cNvPr>
@@ -7840,7 +7729,7 @@
     </p:spTree>
     <p:extLst>
       <p:ext uri="{BB962C8B-B14F-4D97-AF65-F5344CB8AC3E}">
-        <p14:creationId xmlns:p14="http://schemas.microsoft.com/office/powerpoint/2010/main" val="1700005948"/>
+        <p14:creationId xmlns:p14="http://schemas.microsoft.com/office/powerpoint/2010/main" val="1492063593"/>
       </p:ext>
     </p:extLst>
   </p:cSld>
@@ -7871,7 +7760,7 @@
           <p:cNvPr id="16" name="slide-number">
             <a:extLst xmlns:a="http://schemas.openxmlformats.org/drawingml/2006/main">
               <a:ext uri="{FF2B5EF4-FFF2-40B4-BE49-F238E27FC236}">
-                <a16:creationId xmlns:a16="http://schemas.microsoft.com/office/drawing/2014/main" id="{0885C1AE-5B81-43D0-8B29-5143186F0024}"/>
+                <a16:creationId xmlns:a16="http://schemas.microsoft.com/office/drawing/2014/main" id="{E71274F7-ECEC-4561-A80B-6E8E9DA7E569}"/>
               </a:ext>
             </a:extLst>
           </p:cNvPr>
@@ -7939,7 +7828,7 @@
           <p:cNvPr id="2" name="slide-title">
             <a:extLst xmlns:a="http://schemas.openxmlformats.org/drawingml/2006/main">
               <a:ext uri="{FF2B5EF4-FFF2-40B4-BE49-F238E27FC236}">
-                <a16:creationId xmlns:a16="http://schemas.microsoft.com/office/drawing/2014/main" id="{C9EA708E-D869-4D5B-8604-C54F543FB928}"/>
+                <a16:creationId xmlns:a16="http://schemas.microsoft.com/office/drawing/2014/main" id="{451A9123-47C6-4D65-B679-6B3FD687D419}"/>
               </a:ext>
             </a:extLst>
           </p:cNvPr>
@@ -8007,7 +7896,7 @@
           <p:cNvPr id="3" name="rule-01">
             <a:extLst xmlns:a="http://schemas.openxmlformats.org/drawingml/2006/main">
               <a:ext uri="{FF2B5EF4-FFF2-40B4-BE49-F238E27FC236}">
-                <a16:creationId xmlns:a16="http://schemas.microsoft.com/office/drawing/2014/main" id="{C6466899-D25E-4B0A-BE24-36EFE7F66620}"/>
+                <a16:creationId xmlns:a16="http://schemas.microsoft.com/office/drawing/2014/main" id="{4631C017-30E8-4552-8F6A-2860D5D88AF4}"/>
               </a:ext>
             </a:extLst>
           </p:cNvPr>
@@ -8075,7 +7964,7 @@
           <p:cNvPr id="4" name="rule-title-01">
             <a:extLst xmlns:a="http://schemas.openxmlformats.org/drawingml/2006/main">
               <a:ext uri="{FF2B5EF4-FFF2-40B4-BE49-F238E27FC236}">
-                <a16:creationId xmlns:a16="http://schemas.microsoft.com/office/drawing/2014/main" id="{3FC8986F-BDFF-419F-8985-EB62607C1528}"/>
+                <a16:creationId xmlns:a16="http://schemas.microsoft.com/office/drawing/2014/main" id="{EBCA1291-7D3F-4B28-814D-908D5588BF68}"/>
               </a:ext>
             </a:extLst>
           </p:cNvPr>
@@ -8133,7 +8022,7 @@
                 <a:ea typeface="Arial"/>
                 <a:cs typeface="Arial"/>
               </a:rPr>
-              <a:t>Company, financing amount and date</a:t>
+              <a:t>Company, valuation amount and date</a:t>
             </a:r>
           </a:p>
         </p:txBody>
@@ -8143,7 +8032,7 @@
           <p:cNvPr id="5" name="rule-body-01">
             <a:extLst xmlns:a="http://schemas.openxmlformats.org/drawingml/2006/main">
               <a:ext uri="{FF2B5EF4-FFF2-40B4-BE49-F238E27FC236}">
-                <a16:creationId xmlns:a16="http://schemas.microsoft.com/office/drawing/2014/main" id="{8649BDFB-F718-4292-848E-9B8DEA499246}"/>
+                <a16:creationId xmlns:a16="http://schemas.microsoft.com/office/drawing/2014/main" id="{538F015F-32AA-4A34-869A-8CE8D9741791}"/>
               </a:ext>
             </a:extLst>
           </p:cNvPr>
@@ -8211,7 +8100,7 @@
           <p:cNvPr id="6" name="rule-02">
             <a:extLst xmlns:a="http://schemas.openxmlformats.org/drawingml/2006/main">
               <a:ext uri="{FF2B5EF4-FFF2-40B4-BE49-F238E27FC236}">
-                <a16:creationId xmlns:a16="http://schemas.microsoft.com/office/drawing/2014/main" id="{EB8AF633-27F3-47F2-BD89-DE6147F3491D}"/>
+                <a16:creationId xmlns:a16="http://schemas.microsoft.com/office/drawing/2014/main" id="{146848A1-66D8-4A28-A980-0A632A3A544A}"/>
               </a:ext>
             </a:extLst>
           </p:cNvPr>
@@ -8279,7 +8168,7 @@
           <p:cNvPr id="7" name="rule-title-02">
             <a:extLst xmlns:a="http://schemas.openxmlformats.org/drawingml/2006/main">
               <a:ext uri="{FF2B5EF4-FFF2-40B4-BE49-F238E27FC236}">
-                <a16:creationId xmlns:a16="http://schemas.microsoft.com/office/drawing/2014/main" id="{F6CFCF5A-DE80-4859-922D-627DE09F089E}"/>
+                <a16:creationId xmlns:a16="http://schemas.microsoft.com/office/drawing/2014/main" id="{C6E033AB-F712-47CA-A837-B9A1FABE29AD}"/>
               </a:ext>
             </a:extLst>
           </p:cNvPr>
@@ -8347,7 +8236,7 @@
           <p:cNvPr id="8" name="rule-body-02">
             <a:extLst xmlns:a="http://schemas.openxmlformats.org/drawingml/2006/main">
               <a:ext uri="{FF2B5EF4-FFF2-40B4-BE49-F238E27FC236}">
-                <a16:creationId xmlns:a16="http://schemas.microsoft.com/office/drawing/2014/main" id="{6FE0858B-DBB0-45C9-A02C-9AF29653A4BA}"/>
+                <a16:creationId xmlns:a16="http://schemas.microsoft.com/office/drawing/2014/main" id="{7B413F07-94A4-42E7-A76B-D5C5EFA08317}"/>
               </a:ext>
             </a:extLst>
           </p:cNvPr>
@@ -8415,7 +8304,7 @@
           <p:cNvPr id="9" name="rule-03">
             <a:extLst xmlns:a="http://schemas.openxmlformats.org/drawingml/2006/main">
               <a:ext uri="{FF2B5EF4-FFF2-40B4-BE49-F238E27FC236}">
-                <a16:creationId xmlns:a16="http://schemas.microsoft.com/office/drawing/2014/main" id="{FBB53F69-A59B-433E-BF24-AD37BE95F89D}"/>
+                <a16:creationId xmlns:a16="http://schemas.microsoft.com/office/drawing/2014/main" id="{D60E7FC7-F88C-4322-9BEA-B966230F19F4}"/>
               </a:ext>
             </a:extLst>
           </p:cNvPr>
@@ -8483,7 +8372,7 @@
           <p:cNvPr id="10" name="rule-title-03">
             <a:extLst xmlns:a="http://schemas.openxmlformats.org/drawingml/2006/main">
               <a:ext uri="{FF2B5EF4-FFF2-40B4-BE49-F238E27FC236}">
-                <a16:creationId xmlns:a16="http://schemas.microsoft.com/office/drawing/2014/main" id="{A2EA090E-3B8B-4F11-AE4D-5E605EF0FFBC}"/>
+                <a16:creationId xmlns:a16="http://schemas.microsoft.com/office/drawing/2014/main" id="{A11FD5EC-4647-4531-9477-299A98916B83}"/>
               </a:ext>
             </a:extLst>
           </p:cNvPr>
@@ -8551,7 +8440,7 @@
           <p:cNvPr id="11" name="rule-body-03">
             <a:extLst xmlns:a="http://schemas.openxmlformats.org/drawingml/2006/main">
               <a:ext uri="{FF2B5EF4-FFF2-40B4-BE49-F238E27FC236}">
-                <a16:creationId xmlns:a16="http://schemas.microsoft.com/office/drawing/2014/main" id="{BE9EA2BE-93E9-4D85-B962-F3BF2CAD0976}"/>
+                <a16:creationId xmlns:a16="http://schemas.microsoft.com/office/drawing/2014/main" id="{91EB8036-0C3E-4E99-86A0-53441E60D8D9}"/>
               </a:ext>
             </a:extLst>
           </p:cNvPr>
@@ -8619,7 +8508,7 @@
           <p:cNvPr id="12" name="rule-04">
             <a:extLst xmlns:a="http://schemas.openxmlformats.org/drawingml/2006/main">
               <a:ext uri="{FF2B5EF4-FFF2-40B4-BE49-F238E27FC236}">
-                <a16:creationId xmlns:a16="http://schemas.microsoft.com/office/drawing/2014/main" id="{64F4F1B3-0C48-43D1-8E46-3030B7138AC2}"/>
+                <a16:creationId xmlns:a16="http://schemas.microsoft.com/office/drawing/2014/main" id="{DC2A8D96-EED9-482B-9214-150E0668A87A}"/>
               </a:ext>
             </a:extLst>
           </p:cNvPr>
@@ -8687,7 +8576,7 @@
           <p:cNvPr id="13" name="rule-title-04">
             <a:extLst xmlns:a="http://schemas.openxmlformats.org/drawingml/2006/main">
               <a:ext uri="{FF2B5EF4-FFF2-40B4-BE49-F238E27FC236}">
-                <a16:creationId xmlns:a16="http://schemas.microsoft.com/office/drawing/2014/main" id="{26DCD72C-8EA3-46F1-8935-9131AE1DCFBA}"/>
+                <a16:creationId xmlns:a16="http://schemas.microsoft.com/office/drawing/2014/main" id="{87889705-30B1-410F-8EF9-43D7218BC4B7}"/>
               </a:ext>
             </a:extLst>
           </p:cNvPr>
@@ -8755,7 +8644,7 @@
           <p:cNvPr id="14" name="rule-body-04">
             <a:extLst xmlns:a="http://schemas.openxmlformats.org/drawingml/2006/main">
               <a:ext uri="{FF2B5EF4-FFF2-40B4-BE49-F238E27FC236}">
-                <a16:creationId xmlns:a16="http://schemas.microsoft.com/office/drawing/2014/main" id="{7ADFE5F6-58B3-4CDA-A96F-A4AD8F8D89F8}"/>
+                <a16:creationId xmlns:a16="http://schemas.microsoft.com/office/drawing/2014/main" id="{E527549A-A200-4204-8584-9A18E71CF568}"/>
               </a:ext>
             </a:extLst>
           </p:cNvPr>
@@ -8823,7 +8712,7 @@
           <p:cNvPr id="15" name="source-history-limitation">
             <a:extLst xmlns:a="http://schemas.openxmlformats.org/drawingml/2006/main">
               <a:ext uri="{FF2B5EF4-FFF2-40B4-BE49-F238E27FC236}">
-                <a16:creationId xmlns:a16="http://schemas.microsoft.com/office/drawing/2014/main" id="{D8E7D2BB-AE6F-486F-88EF-85DED3714CF9}"/>
+                <a16:creationId xmlns:a16="http://schemas.microsoft.com/office/drawing/2014/main" id="{D7675E8A-3D04-4C19-9806-23CD6703BA8E}"/>
               </a:ext>
             </a:extLst>
           </p:cNvPr>
@@ -8889,7 +8778,7 @@
     </p:spTree>
     <p:extLst>
       <p:ext uri="{BB962C8B-B14F-4D97-AF65-F5344CB8AC3E}">
-        <p14:creationId xmlns:p14="http://schemas.microsoft.com/office/powerpoint/2010/main" val="1849806050"/>
+        <p14:creationId xmlns:p14="http://schemas.microsoft.com/office/powerpoint/2010/main" val="1897385546"/>
       </p:ext>
     </p:extLst>
   </p:cSld>
@@ -8920,7 +8809,7 @@
           <p:cNvPr id="11" name="slide-number">
             <a:extLst xmlns:a="http://schemas.openxmlformats.org/drawingml/2006/main">
               <a:ext uri="{FF2B5EF4-FFF2-40B4-BE49-F238E27FC236}">
-                <a16:creationId xmlns:a16="http://schemas.microsoft.com/office/drawing/2014/main" id="{A0E8169A-4808-46DD-9BEC-825051FBF9B9}"/>
+                <a16:creationId xmlns:a16="http://schemas.microsoft.com/office/drawing/2014/main" id="{DDF42B7A-D094-4ADF-A8A4-91405AEE0D44}"/>
               </a:ext>
             </a:extLst>
           </p:cNvPr>
@@ -8988,7 +8877,7 @@
           <p:cNvPr id="2" name="slide-title">
             <a:extLst xmlns:a="http://schemas.openxmlformats.org/drawingml/2006/main">
               <a:ext uri="{FF2B5EF4-FFF2-40B4-BE49-F238E27FC236}">
-                <a16:creationId xmlns:a16="http://schemas.microsoft.com/office/drawing/2014/main" id="{AB8FD6CC-4734-4665-9563-F9BF1186E37F}"/>
+                <a16:creationId xmlns:a16="http://schemas.microsoft.com/office/drawing/2014/main" id="{64923644-E602-455A-A9F3-8D11BF449385}"/>
               </a:ext>
             </a:extLst>
           </p:cNvPr>
@@ -9056,7 +8945,7 @@
           <p:cNvPr id="3" name="pricing-label">
             <a:extLst xmlns:a="http://schemas.openxmlformats.org/drawingml/2006/main">
               <a:ext uri="{FF2B5EF4-FFF2-40B4-BE49-F238E27FC236}">
-                <a16:creationId xmlns:a16="http://schemas.microsoft.com/office/drawing/2014/main" id="{3875638B-EF24-4BCD-8D06-FED0ACDC4E12}"/>
+                <a16:creationId xmlns:a16="http://schemas.microsoft.com/office/drawing/2014/main" id="{EDD484AE-41CF-4441-9D7E-59E8EF9674B9}"/>
               </a:ext>
             </a:extLst>
           </p:cNvPr>
@@ -9124,7 +9013,7 @@
           <p:cNvPr id="4" name="pricing">
             <a:extLst xmlns:a="http://schemas.openxmlformats.org/drawingml/2006/main">
               <a:ext uri="{FF2B5EF4-FFF2-40B4-BE49-F238E27FC236}">
-                <a16:creationId xmlns:a16="http://schemas.microsoft.com/office/drawing/2014/main" id="{24C961B3-FDDF-4C0A-A626-7B9B644BFEB9}"/>
+                <a16:creationId xmlns:a16="http://schemas.microsoft.com/office/drawing/2014/main" id="{43DE12D5-B2D3-4FAF-BDA2-63425D3350C6}"/>
               </a:ext>
             </a:extLst>
           </p:cNvPr>
@@ -9192,7 +9081,7 @@
           <p:cNvPr id="5" name="pricing-unit">
             <a:extLst xmlns:a="http://schemas.openxmlformats.org/drawingml/2006/main">
               <a:ext uri="{FF2B5EF4-FFF2-40B4-BE49-F238E27FC236}">
-                <a16:creationId xmlns:a16="http://schemas.microsoft.com/office/drawing/2014/main" id="{F4C00742-1785-4E23-ACFF-35FFB353AE1A}"/>
+                <a16:creationId xmlns:a16="http://schemas.microsoft.com/office/drawing/2014/main" id="{97C59AF9-C3E8-49E6-B143-959FF3F0751E}"/>
               </a:ext>
             </a:extLst>
           </p:cNvPr>
@@ -9260,7 +9149,7 @@
           <p:cNvPr id="6" name="pricing-team">
             <a:extLst xmlns:a="http://schemas.openxmlformats.org/drawingml/2006/main">
               <a:ext uri="{FF2B5EF4-FFF2-40B4-BE49-F238E27FC236}">
-                <a16:creationId xmlns:a16="http://schemas.microsoft.com/office/drawing/2014/main" id="{EBCC2DE3-BDCC-4D27-ABBA-7658276150DF}"/>
+                <a16:creationId xmlns:a16="http://schemas.microsoft.com/office/drawing/2014/main" id="{019F709F-3C49-45CC-9093-B0034E6A9559}"/>
               </a:ext>
             </a:extLst>
           </p:cNvPr>
@@ -9351,7 +9240,7 @@
           <p:cNvPr id="7" name="pilot-ask">
             <a:extLst xmlns:a="http://schemas.openxmlformats.org/drawingml/2006/main">
               <a:ext uri="{FF2B5EF4-FFF2-40B4-BE49-F238E27FC236}">
-                <a16:creationId xmlns:a16="http://schemas.microsoft.com/office/drawing/2014/main" id="{C35B6BD1-3A8B-4D4C-8AA8-4ACDE5144577}"/>
+                <a16:creationId xmlns:a16="http://schemas.microsoft.com/office/drawing/2014/main" id="{E3F2F27D-C542-41CB-9D9F-3DBC85619A1A}"/>
               </a:ext>
             </a:extLst>
           </p:cNvPr>
@@ -9419,7 +9308,7 @@
           <p:cNvPr id="8" name="pilot-description">
             <a:extLst xmlns:a="http://schemas.openxmlformats.org/drawingml/2006/main">
               <a:ext uri="{FF2B5EF4-FFF2-40B4-BE49-F238E27FC236}">
-                <a16:creationId xmlns:a16="http://schemas.microsoft.com/office/drawing/2014/main" id="{587F498C-5598-4250-BCEB-97E747F0D964}"/>
+                <a16:creationId xmlns:a16="http://schemas.microsoft.com/office/drawing/2014/main" id="{DE7479E0-E727-4FEE-B58A-93915CFC1211}"/>
               </a:ext>
             </a:extLst>
           </p:cNvPr>
@@ -9510,7 +9399,7 @@
           <p:cNvPr id="9" name="pilot-evaluation">
             <a:extLst xmlns:a="http://schemas.openxmlformats.org/drawingml/2006/main">
               <a:ext uri="{FF2B5EF4-FFF2-40B4-BE49-F238E27FC236}">
-                <a16:creationId xmlns:a16="http://schemas.microsoft.com/office/drawing/2014/main" id="{2F54A6DC-1824-4941-8998-B089F8ECE32E}"/>
+                <a16:creationId xmlns:a16="http://schemas.microsoft.com/office/drawing/2014/main" id="{37021788-C7F0-475C-900E-D7E3F96E1B8F}"/>
               </a:ext>
             </a:extLst>
           </p:cNvPr>
@@ -9624,7 +9513,7 @@
           <p:cNvPr id="10" name="pricing-limitation">
             <a:extLst xmlns:a="http://schemas.openxmlformats.org/drawingml/2006/main">
               <a:ext uri="{FF2B5EF4-FFF2-40B4-BE49-F238E27FC236}">
-                <a16:creationId xmlns:a16="http://schemas.microsoft.com/office/drawing/2014/main" id="{1277A65F-1996-4203-8228-22948F29F2A1}"/>
+                <a16:creationId xmlns:a16="http://schemas.microsoft.com/office/drawing/2014/main" id="{982FF7F2-45D5-464F-BEB3-36AE393EF606}"/>
               </a:ext>
             </a:extLst>
           </p:cNvPr>
@@ -9690,7 +9579,7 @@
     </p:spTree>
     <p:extLst>
       <p:ext uri="{BB962C8B-B14F-4D97-AF65-F5344CB8AC3E}">
-        <p14:creationId xmlns:p14="http://schemas.microsoft.com/office/powerpoint/2010/main" val="797459016"/>
+        <p14:creationId xmlns:p14="http://schemas.microsoft.com/office/powerpoint/2010/main" val="1268377796"/>
       </p:ext>
     </p:extLst>
   </p:cSld>

</xml_diff>

<commit_message>
Publish approved live research access and screenshot-led judge pitch
</commit_message>
<xml_diff>
--- a/docs/submission/pitch.pptx
+++ b/docs/submission/pitch.pptx
@@ -2,20 +2,20 @@
 <file path=ppt/presentation.xml><?xml version="1.0" encoding="utf-8"?>
 <p:presentation xmlns:p="http://schemas.openxmlformats.org/presentationml/2006/main">
   <p:sldMasterIdLst>
-    <p:sldMasterId xmlns:r="http://schemas.openxmlformats.org/officeDocument/2006/relationships" id="2147483648" r:id="R4373effcc41b4d5a"/>
+    <p:sldMasterId xmlns:r="http://schemas.openxmlformats.org/officeDocument/2006/relationships" id="2147483648" r:id="Reaa3e1ed23c041da"/>
   </p:sldMasterIdLst>
   <p:notesMasterIdLst>
-    <p:notesMasterId xmlns:r="http://schemas.openxmlformats.org/officeDocument/2006/relationships" r:id="R28919c5e45aa46a9"/>
+    <p:notesMasterId xmlns:r="http://schemas.openxmlformats.org/officeDocument/2006/relationships" r:id="R2bbf1c822848412e"/>
   </p:notesMasterIdLst>
   <p:sldIdLst>
-    <p:sldId xmlns:r="http://schemas.openxmlformats.org/officeDocument/2006/relationships" id="256" r:id="Re3b02ac23602483a"/>
-    <p:sldId xmlns:r="http://schemas.openxmlformats.org/officeDocument/2006/relationships" id="257" r:id="Rde94b61844f8483d"/>
-    <p:sldId xmlns:r="http://schemas.openxmlformats.org/officeDocument/2006/relationships" id="258" r:id="Rdab422c5250748c9"/>
-    <p:sldId xmlns:r="http://schemas.openxmlformats.org/officeDocument/2006/relationships" id="259" r:id="R9865262c1b044564"/>
-    <p:sldId xmlns:r="http://schemas.openxmlformats.org/officeDocument/2006/relationships" id="260" r:id="R9c21ae4b7ba94999"/>
-    <p:sldId xmlns:r="http://schemas.openxmlformats.org/officeDocument/2006/relationships" id="261" r:id="R6a3223e17c6846b1"/>
-    <p:sldId xmlns:r="http://schemas.openxmlformats.org/officeDocument/2006/relationships" id="262" r:id="Rc4ef52b2481342a6"/>
-    <p:sldId xmlns:r="http://schemas.openxmlformats.org/officeDocument/2006/relationships" id="263" r:id="Rded0d4a6f48a481d"/>
+    <p:sldId xmlns:r="http://schemas.openxmlformats.org/officeDocument/2006/relationships" id="256" r:id="R3188f915dc234975"/>
+    <p:sldId xmlns:r="http://schemas.openxmlformats.org/officeDocument/2006/relationships" id="257" r:id="Re76ec1e277954f44"/>
+    <p:sldId xmlns:r="http://schemas.openxmlformats.org/officeDocument/2006/relationships" id="258" r:id="Rb53c03f73d054016"/>
+    <p:sldId xmlns:r="http://schemas.openxmlformats.org/officeDocument/2006/relationships" id="259" r:id="R2c912c367120469d"/>
+    <p:sldId xmlns:r="http://schemas.openxmlformats.org/officeDocument/2006/relationships" id="260" r:id="R020d50fa35934ba4"/>
+    <p:sldId xmlns:r="http://schemas.openxmlformats.org/officeDocument/2006/relationships" id="261" r:id="Reaeac47ec0aa4928"/>
+    <p:sldId xmlns:r="http://schemas.openxmlformats.org/officeDocument/2006/relationships" id="262" r:id="Rbc60bc292e1942b2"/>
+    <p:sldId xmlns:r="http://schemas.openxmlformats.org/officeDocument/2006/relationships" id="263" r:id="R603c574ca76a4906"/>
   </p:sldIdLst>
   <p:sldSz cx="12192000" cy="6858000"/>
   <p:notesSz cx="6858000" cy="9144000"/>
@@ -619,7 +619,7 @@
           <a:lstStyle xmlns:a="http://schemas.openxmlformats.org/drawingml/2006/main"/>
           <a:p xmlns:a="http://schemas.openxmlformats.org/drawingml/2006/main">
             <a:r>
-              <a:t>Demonstrate Themes, choose a theme, and open a company. The preferred valuation ceiling is a preference, not a guarantee. A lower disclosed valuation alone does not establish relative value. The board may admit fewer than five when evidence is missing. Manual priority ordering stays distinct from the agent ranking. This screenshot reflects the actual prepared workspace, and the presenter must state its actual shortlist size.</a:t>
+              <a:t>Actual completed source-reviewed shortlist. Prices are historical company-stated or reported marks, with dates and qualifications. The source audit includes external review.</a:t>
             </a:r>
           </a:p>
           <a:p xmlns:a="http://schemas.openxmlformats.org/drawingml/2006/main">
@@ -634,17 +634,7 @@
           </a:p>
           <a:p xmlns:a="http://schemas.openxmlformats.org/drawingml/2006/main">
             <a:r>
-              <a:t>https://github.com/eliott-crypto/PARALLAX/blob/main/shared/boards.ts</a:t>
-            </a:r>
-          </a:p>
-          <a:p xmlns:a="http://schemas.openxmlformats.org/drawingml/2006/main">
-            <a:r>
-              <a:t>https://github.com/eliott-crypto/PARALLAX/blob/main/server/boards.ts</a:t>
-            </a:r>
-          </a:p>
-          <a:p xmlns:a="http://schemas.openxmlformats.org/drawingml/2006/main">
-            <a:r>
-              <a:t>/Users/pascalboneu/Desktop/PARALLAX/docs/screenshots/top5.jpg</a:t>
+              <a:t>https://eliott-crypto.github.io/PARALLAX/</a:t>
             </a:r>
           </a:p>
         </p:txBody>
@@ -714,7 +704,7 @@
           <a:lstStyle xmlns:a="http://schemas.openxmlformats.org/drawingml/2006/main"/>
           <a:p xmlns:a="http://schemas.openxmlformats.org/drawingml/2006/main">
             <a:r>
-              <a:t>Click Remove company claims in Universe. The independent lens retains supported INDEPENDENT_REPORT, RESEARCH_PUBLICATION and PUBLIC_PROFESSIONAL_RECORD records. Distance uses supported records divided by unique cited evidence IDs. Height uses the latest completed linked review confidence when present, otherwise the shortlist assessment. Horizontal direction is layout only. Ghost markers preserve the original position. The lens is a reversible deterministic scenario, not new live research or a probability of success.</a:t>
+              <a:t>Demonstrate the independence lens. This visual measures admitted research support, not expected returns.</a:t>
             </a:r>
           </a:p>
           <a:p xmlns:a="http://schemas.openxmlformats.org/drawingml/2006/main">
@@ -730,11 +720,6 @@
           <a:p xmlns:a="http://schemas.openxmlformats.org/drawingml/2006/main">
             <a:r>
               <a:t>https://github.com/eliott-crypto/PARALLAX/blob/main/src/lib/universe.ts</a:t>
-            </a:r>
-          </a:p>
-          <a:p xmlns:a="http://schemas.openxmlformats.org/drawingml/2006/main">
-            <a:r>
-              <a:t>https://github.com/eliott-crypto/PARALLAX/blob/main/src/components/ThesisUniverse.tsx</a:t>
             </a:r>
           </a:p>
         </p:txBody>
@@ -1151,7 +1136,7 @@
           <p:cNvPr id="3" name="Title">
             <a:extLst xmlns:a="http://schemas.openxmlformats.org/drawingml/2006/main">
               <a:ext uri="{FF2B5EF4-FFF2-40B4-BE49-F238E27FC236}">
-                <a16:creationId xmlns:a16="http://schemas.microsoft.com/office/drawing/2014/main" id="{443D7081-20ED-4608-A74C-6F1750931D17}"/>
+                <a16:creationId xmlns:a16="http://schemas.microsoft.com/office/drawing/2014/main" id="{10DA0506-338A-4277-9F6A-2436FF25475E}"/>
               </a:ext>
             </a:extLst>
           </p:cNvPr>
@@ -1308,7 +1293,7 @@
           <p:cNvPr id="2" name="Subtitle">
             <a:extLst xmlns:a="http://schemas.openxmlformats.org/drawingml/2006/main">
               <a:ext uri="{FF2B5EF4-FFF2-40B4-BE49-F238E27FC236}">
-                <a16:creationId xmlns:a16="http://schemas.microsoft.com/office/drawing/2014/main" id="{2445450A-AD1A-44DE-ADBC-419B68836252}"/>
+                <a16:creationId xmlns:a16="http://schemas.microsoft.com/office/drawing/2014/main" id="{347EC114-B90D-46B3-B4C1-06D0AE93689E}"/>
               </a:ext>
             </a:extLst>
           </p:cNvPr>
@@ -1482,7 +1467,7 @@
           <p:cNvPr id="2" name="Section title">
             <a:extLst xmlns:a="http://schemas.openxmlformats.org/drawingml/2006/main">
               <a:ext uri="{FF2B5EF4-FFF2-40B4-BE49-F238E27FC236}">
-                <a16:creationId xmlns:a16="http://schemas.microsoft.com/office/drawing/2014/main" id="{9E16C008-7129-4895-A40A-83E257FDD66A}"/>
+                <a16:creationId xmlns:a16="http://schemas.microsoft.com/office/drawing/2014/main" id="{773D48BF-6DD5-4FA4-95B5-A802E0813CDA}"/>
               </a:ext>
             </a:extLst>
           </p:cNvPr>
@@ -1656,7 +1641,7 @@
           <p:cNvPr id="3" name="Title">
             <a:extLst xmlns:a="http://schemas.openxmlformats.org/drawingml/2006/main">
               <a:ext uri="{FF2B5EF4-FFF2-40B4-BE49-F238E27FC236}">
-                <a16:creationId xmlns:a16="http://schemas.microsoft.com/office/drawing/2014/main" id="{BC29AC3C-1EBA-4B12-9BA4-9B0CD043141A}"/>
+                <a16:creationId xmlns:a16="http://schemas.microsoft.com/office/drawing/2014/main" id="{88DA7593-BC35-4207-9625-4BDEAA575A15}"/>
               </a:ext>
             </a:extLst>
           </p:cNvPr>
@@ -1813,7 +1798,7 @@
           <p:cNvPr id="2" name="Body">
             <a:extLst xmlns:a="http://schemas.openxmlformats.org/drawingml/2006/main">
               <a:ext uri="{FF2B5EF4-FFF2-40B4-BE49-F238E27FC236}">
-                <a16:creationId xmlns:a16="http://schemas.microsoft.com/office/drawing/2014/main" id="{C8D396EA-8799-476C-AE36-F5FA02FF7F74}"/>
+                <a16:creationId xmlns:a16="http://schemas.microsoft.com/office/drawing/2014/main" id="{940EB0B5-776C-47C6-BCF2-B1086D2E7A5D}"/>
               </a:ext>
             </a:extLst>
           </p:cNvPr>
@@ -1987,7 +1972,7 @@
           <p:cNvPr id="4" name="Title">
             <a:extLst xmlns:a="http://schemas.openxmlformats.org/drawingml/2006/main">
               <a:ext uri="{FF2B5EF4-FFF2-40B4-BE49-F238E27FC236}">
-                <a16:creationId xmlns:a16="http://schemas.microsoft.com/office/drawing/2014/main" id="{7D3D014B-EE74-4CE7-AA60-D523C6AE017D}"/>
+                <a16:creationId xmlns:a16="http://schemas.microsoft.com/office/drawing/2014/main" id="{21274864-5D59-4316-B4F4-7FEAC854FF62}"/>
               </a:ext>
             </a:extLst>
           </p:cNvPr>
@@ -2144,7 +2129,7 @@
           <p:cNvPr id="2" name="Left column">
             <a:extLst xmlns:a="http://schemas.openxmlformats.org/drawingml/2006/main">
               <a:ext uri="{FF2B5EF4-FFF2-40B4-BE49-F238E27FC236}">
-                <a16:creationId xmlns:a16="http://schemas.microsoft.com/office/drawing/2014/main" id="{5A0933C1-BE81-4914-B2E4-0A41F04A4B4E}"/>
+                <a16:creationId xmlns:a16="http://schemas.microsoft.com/office/drawing/2014/main" id="{35DE8D40-7584-4941-AC2D-4F8E3B68B551}"/>
               </a:ext>
             </a:extLst>
           </p:cNvPr>
@@ -2301,7 +2286,7 @@
           <p:cNvPr id="3" name="Right column">
             <a:extLst xmlns:a="http://schemas.openxmlformats.org/drawingml/2006/main">
               <a:ext uri="{FF2B5EF4-FFF2-40B4-BE49-F238E27FC236}">
-                <a16:creationId xmlns:a16="http://schemas.microsoft.com/office/drawing/2014/main" id="{17015657-7FA0-4C21-A29A-FF75B23F5E5A}"/>
+                <a16:creationId xmlns:a16="http://schemas.microsoft.com/office/drawing/2014/main" id="{939C0E94-58C5-4263-8292-FC764205B7FC}"/>
               </a:ext>
             </a:extLst>
           </p:cNvPr>
@@ -2475,7 +2460,7 @@
           <p:cNvPr id="3" name="Title">
             <a:extLst xmlns:a="http://schemas.openxmlformats.org/drawingml/2006/main">
               <a:ext uri="{FF2B5EF4-FFF2-40B4-BE49-F238E27FC236}">
-                <a16:creationId xmlns:a16="http://schemas.microsoft.com/office/drawing/2014/main" id="{0713EB83-D95D-4A80-944C-30A3C831F83C}"/>
+                <a16:creationId xmlns:a16="http://schemas.microsoft.com/office/drawing/2014/main" id="{0FC3962E-0874-435B-82CD-986B5B1EAF75}"/>
               </a:ext>
             </a:extLst>
           </p:cNvPr>
@@ -2632,7 +2617,7 @@
           <p:cNvPr id="2" name="Left column">
             <a:extLst xmlns:a="http://schemas.openxmlformats.org/drawingml/2006/main">
               <a:ext uri="{FF2B5EF4-FFF2-40B4-BE49-F238E27FC236}">
-                <a16:creationId xmlns:a16="http://schemas.microsoft.com/office/drawing/2014/main" id="{B1AB22E3-9B5B-496B-A72F-467E8538C825}"/>
+                <a16:creationId xmlns:a16="http://schemas.microsoft.com/office/drawing/2014/main" id="{4E3B725E-628F-4CEB-93A6-A7204B5CB6BF}"/>
               </a:ext>
             </a:extLst>
           </p:cNvPr>
@@ -2827,12 +2812,12 @@
   </p:cSld>
   <p:clrMap bg1="lt1" tx1="dk1" bg2="lt2" tx2="dk2" accent1="accent1" accent2="accent2" accent3="accent3" accent4="accent4" accent5="accent5" accent6="accent6" hlink="hlink" folHlink="folHlink"/>
   <p:sldLayoutIdLst>
-    <p:sldLayoutId xmlns:r="http://schemas.openxmlformats.org/officeDocument/2006/relationships" id="2147483649" r:id="R25ccc8d1ebef44c3"/>
-    <p:sldLayoutId xmlns:r="http://schemas.openxmlformats.org/officeDocument/2006/relationships" id="2147483650" r:id="R1b860bf577a343cf"/>
-    <p:sldLayoutId xmlns:r="http://schemas.openxmlformats.org/officeDocument/2006/relationships" id="2147483651" r:id="Rca229b02f6af4159"/>
-    <p:sldLayoutId xmlns:r="http://schemas.openxmlformats.org/officeDocument/2006/relationships" id="2147483652" r:id="R455df05343dc4550"/>
-    <p:sldLayoutId xmlns:r="http://schemas.openxmlformats.org/officeDocument/2006/relationships" id="2147483653" r:id="Reec86ebaf86c41b5"/>
-    <p:sldLayoutId xmlns:r="http://schemas.openxmlformats.org/officeDocument/2006/relationships" id="2147483654" r:id="Rf264cae9b29147f3"/>
+    <p:sldLayoutId xmlns:r="http://schemas.openxmlformats.org/officeDocument/2006/relationships" id="2147483649" r:id="R6ec9ebb854ac4bf8"/>
+    <p:sldLayoutId xmlns:r="http://schemas.openxmlformats.org/officeDocument/2006/relationships" id="2147483650" r:id="R6df626ecb9444581"/>
+    <p:sldLayoutId xmlns:r="http://schemas.openxmlformats.org/officeDocument/2006/relationships" id="2147483651" r:id="R89b357f09bb14f58"/>
+    <p:sldLayoutId xmlns:r="http://schemas.openxmlformats.org/officeDocument/2006/relationships" id="2147483652" r:id="Rab83ae36e89c4318"/>
+    <p:sldLayoutId xmlns:r="http://schemas.openxmlformats.org/officeDocument/2006/relationships" id="2147483653" r:id="R97e2c36e9df044ef"/>
+    <p:sldLayoutId xmlns:r="http://schemas.openxmlformats.org/officeDocument/2006/relationships" id="2147483654" r:id="Re37e3c74fcfe4813"/>
   </p:sldLayoutIdLst>
   <p:txStyles>
     <p:titleStyle>
@@ -3383,7 +3368,7 @@
           <p:cNvPr id="7" name="slide-number">
             <a:extLst xmlns:a="http://schemas.openxmlformats.org/drawingml/2006/main">
               <a:ext uri="{FF2B5EF4-FFF2-40B4-BE49-F238E27FC236}">
-                <a16:creationId xmlns:a16="http://schemas.microsoft.com/office/drawing/2014/main" id="{C9290A94-EC6D-484B-B297-E4B60ACE65D1}"/>
+                <a16:creationId xmlns:a16="http://schemas.microsoft.com/office/drawing/2014/main" id="{FB7E23AC-5956-4EE5-B33F-D22D94466D85}"/>
               </a:ext>
             </a:extLst>
           </p:cNvPr>
@@ -3451,7 +3436,7 @@
           <p:cNvPr id="2" name="">
             <a:extLst xmlns:a="http://schemas.openxmlformats.org/drawingml/2006/main">
               <a:ext uri="{FF2B5EF4-FFF2-40B4-BE49-F238E27FC236}">
-                <a16:creationId xmlns:a16="http://schemas.microsoft.com/office/drawing/2014/main" id="{4FEFD1E5-C313-4CCB-AA60-CCBA8F66E946}"/>
+                <a16:creationId xmlns:a16="http://schemas.microsoft.com/office/drawing/2014/main" id="{289B8414-A088-4F49-BA08-E87DBE0A66EC}"/>
               </a:ext>
             </a:extLst>
           </p:cNvPr>
@@ -3461,10 +3446,10 @@
           <p:nvPr/>
         </p:nvPicPr>
         <p:blipFill>
-          <a:blip xmlns:r="http://schemas.openxmlformats.org/officeDocument/2006/relationships" xmlns:a="http://schemas.openxmlformats.org/drawingml/2006/main" r:embed="Rcfd1047079354857">
+          <a:blip xmlns:r="http://schemas.openxmlformats.org/officeDocument/2006/relationships" xmlns:a="http://schemas.openxmlformats.org/drawingml/2006/main" r:embed="R6b893b8ef6b64bee">
             <a:extLst>
               <a:ext uri="{96DAC541-7B7A-43D3-8B79-37D633B846F1}">
-                <asvg:svgBlip xmlns:asvg="http://schemas.microsoft.com/office/drawing/2016/SVG/main" r:embed="R9db32e91fb5e4a4f"/>
+                <asvg:svgBlip xmlns:asvg="http://schemas.microsoft.com/office/drawing/2016/SVG/main" r:embed="R6935e4c4e8fa4193"/>
               </a:ext>
             </a:extLst>
           </a:blip>
@@ -3485,7 +3470,7 @@
           <p:cNvPr id="3" name="wordmark">
             <a:extLst xmlns:a="http://schemas.openxmlformats.org/drawingml/2006/main">
               <a:ext uri="{FF2B5EF4-FFF2-40B4-BE49-F238E27FC236}">
-                <a16:creationId xmlns:a16="http://schemas.microsoft.com/office/drawing/2014/main" id="{16B6D334-DA06-4D25-AE31-8867018A78B5}"/>
+                <a16:creationId xmlns:a16="http://schemas.microsoft.com/office/drawing/2014/main" id="{5C973F53-A5C2-4944-9252-89A2492580D2}"/>
               </a:ext>
             </a:extLst>
           </p:cNvPr>
@@ -3553,7 +3538,7 @@
           <p:cNvPr id="4" name="cover-title">
             <a:extLst xmlns:a="http://schemas.openxmlformats.org/drawingml/2006/main">
               <a:ext uri="{FF2B5EF4-FFF2-40B4-BE49-F238E27FC236}">
-                <a16:creationId xmlns:a16="http://schemas.microsoft.com/office/drawing/2014/main" id="{0136E58B-3FBB-4807-8AAE-013014FE8307}"/>
+                <a16:creationId xmlns:a16="http://schemas.microsoft.com/office/drawing/2014/main" id="{166EB8D3-4789-4A44-884D-A5C05CC91519}"/>
               </a:ext>
             </a:extLst>
           </p:cNvPr>
@@ -3644,7 +3629,7 @@
           <p:cNvPr id="5" name="cover-description">
             <a:extLst xmlns:a="http://schemas.openxmlformats.org/drawingml/2006/main">
               <a:ext uri="{FF2B5EF4-FFF2-40B4-BE49-F238E27FC236}">
-                <a16:creationId xmlns:a16="http://schemas.microsoft.com/office/drawing/2014/main" id="{55D9DEDB-BE02-496D-8729-390B72781ACA}"/>
+                <a16:creationId xmlns:a16="http://schemas.microsoft.com/office/drawing/2014/main" id="{4EB00118-F598-434F-8ABC-776F7015D691}"/>
               </a:ext>
             </a:extLst>
           </p:cNvPr>
@@ -3712,7 +3697,7 @@
           <p:cNvPr id="6" name="cover-link">
             <a:extLst xmlns:a="http://schemas.openxmlformats.org/drawingml/2006/main">
               <a:ext uri="{FF2B5EF4-FFF2-40B4-BE49-F238E27FC236}">
-                <a16:creationId xmlns:a16="http://schemas.microsoft.com/office/drawing/2014/main" id="{824FFBE1-F8F0-4522-ABCD-813BD8539854}"/>
+                <a16:creationId xmlns:a16="http://schemas.microsoft.com/office/drawing/2014/main" id="{7392F52F-A46B-4464-8F6D-3F9E66BB0264}"/>
               </a:ext>
             </a:extLst>
           </p:cNvPr>
@@ -3769,7 +3754,7 @@
                 <a:latin typeface="Arial"/>
                 <a:ea typeface="Arial"/>
                 <a:cs typeface="Arial"/>
-                <a:hlinkClick xmlns:r="http://schemas.openxmlformats.org/officeDocument/2006/relationships" r:id="R217d8230dbfe47f7"/>
+                <a:hlinkClick xmlns:r="http://schemas.openxmlformats.org/officeDocument/2006/relationships" r:id="R562e0192d8a84594"/>
               </a:rPr>
               <a:t>eliott-crypto.github.io/PARALLAX</a:t>
             </a:r>
@@ -3779,7 +3764,7 @@
     </p:spTree>
     <p:extLst>
       <p:ext uri="{BB962C8B-B14F-4D97-AF65-F5344CB8AC3E}">
-        <p14:creationId xmlns:p14="http://schemas.microsoft.com/office/powerpoint/2010/main" val="575917113"/>
+        <p14:creationId xmlns:p14="http://schemas.microsoft.com/office/powerpoint/2010/main" val="522328440"/>
       </p:ext>
     </p:extLst>
   </p:cSld>
@@ -3810,7 +3795,7 @@
           <p:cNvPr id="8" name="slide-number">
             <a:extLst xmlns:a="http://schemas.openxmlformats.org/drawingml/2006/main">
               <a:ext uri="{FF2B5EF4-FFF2-40B4-BE49-F238E27FC236}">
-                <a16:creationId xmlns:a16="http://schemas.microsoft.com/office/drawing/2014/main" id="{906D2C77-0579-4635-9B47-10BEAE5B3D8E}"/>
+                <a16:creationId xmlns:a16="http://schemas.microsoft.com/office/drawing/2014/main" id="{1D383CDA-6B29-48AC-97BA-A6BB04BD0F04}"/>
               </a:ext>
             </a:extLst>
           </p:cNvPr>
@@ -3878,7 +3863,7 @@
           <p:cNvPr id="2" name="slide-title">
             <a:extLst xmlns:a="http://schemas.openxmlformats.org/drawingml/2006/main">
               <a:ext uri="{FF2B5EF4-FFF2-40B4-BE49-F238E27FC236}">
-                <a16:creationId xmlns:a16="http://schemas.microsoft.com/office/drawing/2014/main" id="{8B8BF4E1-BE23-411A-83B6-FA02B34C8040}"/>
+                <a16:creationId xmlns:a16="http://schemas.microsoft.com/office/drawing/2014/main" id="{03F7149A-B285-4F7E-96B4-31A29D490D69}"/>
               </a:ext>
             </a:extLst>
           </p:cNvPr>
@@ -3936,7 +3921,7 @@
                 <a:ea typeface="Arial"/>
                 <a:cs typeface="Arial"/>
               </a:rPr>
-              <a:t>The next diligence call</a:t>
+              <a:t>Business: the next diligence call</a:t>
             </a:r>
           </a:p>
         </p:txBody>
@@ -3946,7 +3931,7 @@
           <p:cNvPr id="3" name="customer-label">
             <a:extLst xmlns:a="http://schemas.openxmlformats.org/drawingml/2006/main">
               <a:ext uri="{FF2B5EF4-FFF2-40B4-BE49-F238E27FC236}">
-                <a16:creationId xmlns:a16="http://schemas.microsoft.com/office/drawing/2014/main" id="{FBA00276-9BAD-4DA5-96E3-6745E1ABF5E1}"/>
+                <a16:creationId xmlns:a16="http://schemas.microsoft.com/office/drawing/2014/main" id="{05629D19-B623-4E98-B115-96AD05EB5AAC}"/>
               </a:ext>
             </a:extLst>
           </p:cNvPr>
@@ -4014,7 +3999,7 @@
           <p:cNvPr id="4" name="customer">
             <a:extLst xmlns:a="http://schemas.openxmlformats.org/drawingml/2006/main">
               <a:ext uri="{FF2B5EF4-FFF2-40B4-BE49-F238E27FC236}">
-                <a16:creationId xmlns:a16="http://schemas.microsoft.com/office/drawing/2014/main" id="{BD5DABDA-019E-4CB8-9DE9-F036DF847D1A}"/>
+                <a16:creationId xmlns:a16="http://schemas.microsoft.com/office/drawing/2014/main" id="{FA86D496-1CF0-463A-8EDE-A8184715495F}"/>
               </a:ext>
             </a:extLst>
           </p:cNvPr>
@@ -4105,7 +4090,7 @@
           <p:cNvPr id="5" name="customer-job">
             <a:extLst xmlns:a="http://schemas.openxmlformats.org/drawingml/2006/main">
               <a:ext uri="{FF2B5EF4-FFF2-40B4-BE49-F238E27FC236}">
-                <a16:creationId xmlns:a16="http://schemas.microsoft.com/office/drawing/2014/main" id="{12D11661-4FA4-4517-96E7-EA268B221081}"/>
+                <a16:creationId xmlns:a16="http://schemas.microsoft.com/office/drawing/2014/main" id="{D2CD3FD2-A7C4-4954-A2C5-0CF47A543E4B}"/>
               </a:ext>
             </a:extLst>
           </p:cNvPr>
@@ -4219,7 +4204,7 @@
           <p:cNvPr id="6" name="decision">
             <a:extLst xmlns:a="http://schemas.openxmlformats.org/drawingml/2006/main">
               <a:ext uri="{FF2B5EF4-FFF2-40B4-BE49-F238E27FC236}">
-                <a16:creationId xmlns:a16="http://schemas.microsoft.com/office/drawing/2014/main" id="{7199ECE1-0B75-47AA-B030-13477CB1750E}"/>
+                <a16:creationId xmlns:a16="http://schemas.microsoft.com/office/drawing/2014/main" id="{858C81E7-66AB-4619-BBF9-6A6441A35629}"/>
               </a:ext>
             </a:extLst>
           </p:cNvPr>
@@ -4310,7 +4295,7 @@
           <p:cNvPr id="7" name="decision-risk">
             <a:extLst xmlns:a="http://schemas.openxmlformats.org/drawingml/2006/main">
               <a:ext uri="{FF2B5EF4-FFF2-40B4-BE49-F238E27FC236}">
-                <a16:creationId xmlns:a16="http://schemas.microsoft.com/office/drawing/2014/main" id="{2188CEBB-C124-4263-AFC4-E82108541B35}"/>
+                <a16:creationId xmlns:a16="http://schemas.microsoft.com/office/drawing/2014/main" id="{9F387E44-0711-469B-B748-99E1D10845E9}"/>
               </a:ext>
             </a:extLst>
           </p:cNvPr>
@@ -4422,7 +4407,7 @@
     </p:spTree>
     <p:extLst>
       <p:ext uri="{BB962C8B-B14F-4D97-AF65-F5344CB8AC3E}">
-        <p14:creationId xmlns:p14="http://schemas.microsoft.com/office/powerpoint/2010/main" val="1728693295"/>
+        <p14:creationId xmlns:p14="http://schemas.microsoft.com/office/powerpoint/2010/main" val="2090798616"/>
       </p:ext>
     </p:extLst>
   </p:cSld>
@@ -4450,10 +4435,10 @@
       </p:grpSpPr>
       <p:sp>
         <p:nvSpPr>
-          <p:cNvPr id="8" name="slide-number">
+          <p:cNvPr id="5" name="slide-number">
             <a:extLst xmlns:a="http://schemas.openxmlformats.org/drawingml/2006/main">
               <a:ext uri="{FF2B5EF4-FFF2-40B4-BE49-F238E27FC236}">
-                <a16:creationId xmlns:a16="http://schemas.microsoft.com/office/drawing/2014/main" id="{77E06140-B8DF-49CA-854B-1BAB23A41976}"/>
+                <a16:creationId xmlns:a16="http://schemas.microsoft.com/office/drawing/2014/main" id="{07A95A5B-09EE-4CBC-B3A6-53DBD47A3551}"/>
               </a:ext>
             </a:extLst>
           </p:cNvPr>
@@ -4521,7 +4506,7 @@
           <p:cNvPr id="2" name="slide-title">
             <a:extLst xmlns:a="http://schemas.openxmlformats.org/drawingml/2006/main">
               <a:ext uri="{FF2B5EF4-FFF2-40B4-BE49-F238E27FC236}">
-                <a16:creationId xmlns:a16="http://schemas.microsoft.com/office/drawing/2014/main" id="{6304A87A-9D20-4F8B-9892-AF88B8F66E07}"/>
+                <a16:creationId xmlns:a16="http://schemas.microsoft.com/office/drawing/2014/main" id="{B3574912-6C40-499D-91CC-3AEAA5B9E89B}"/>
               </a:ext>
             </a:extLst>
           </p:cNvPr>
@@ -4579,336 +4564,17 @@
                 <a:ea typeface="Arial"/>
                 <a:cs typeface="Arial"/>
               </a:rPr>
-              <a:t>A ranked shortlist for each theme</a:t>
-            </a:r>
-          </a:p>
-        </p:txBody>
-      </p:sp>
-      <p:sp>
-        <p:nvSpPr>
-          <p:cNvPr id="3" name="shortlist-description">
+              <a:t>Real output: a Top 5 you can investigate</a:t>
+            </a:r>
+          </a:p>
+        </p:txBody>
+      </p:sp>
+      <p:pic>
+        <p:nvPicPr>
+          <p:cNvPr id="3" name="">
             <a:extLst xmlns:a="http://schemas.openxmlformats.org/drawingml/2006/main">
               <a:ext uri="{FF2B5EF4-FFF2-40B4-BE49-F238E27FC236}">
-                <a16:creationId xmlns:a16="http://schemas.microsoft.com/office/drawing/2014/main" id="{6CFBD159-BF7A-4250-A99D-000F03BA9BD5}"/>
-              </a:ext>
-            </a:extLst>
-          </p:cNvPr>
-          <p:cNvSpPr>
-            <a:spLocks xmlns:a="http://schemas.openxmlformats.org/drawingml/2006/main" noGrp="1"/>
-          </p:cNvSpPr>
-          <p:nvPr/>
-        </p:nvSpPr>
-        <p:spPr>
-          <a:xfrm xmlns:a="http://schemas.openxmlformats.org/drawingml/2006/main">
-            <a:off x="619125" y="1695450"/>
-            <a:ext cx="3790950" cy="1104900"/>
-          </a:xfrm>
-          <a:prstGeom xmlns:a="http://schemas.openxmlformats.org/drawingml/2006/main" prst="rect">
-            <a:avLst/>
-          </a:prstGeom>
-          <a:noFill xmlns:a="http://schemas.openxmlformats.org/drawingml/2006/main"/>
-          <a:ln xmlns:a="http://schemas.openxmlformats.org/drawingml/2006/main" w="0">
-            <a:noFill/>
-          </a:ln>
-        </p:spPr>
-        <p:txBody>
-          <a:bodyPr xmlns:a="http://schemas.openxmlformats.org/drawingml/2006/main" wrap="square" lIns="0" tIns="0" rIns="0" bIns="0">
-            <a:noAutofit/>
-          </a:bodyPr>
-          <a:lstStyle xmlns:a="http://schemas.openxmlformats.org/drawingml/2006/main">
-            <a:defPPr>
-              <a:defRPr sz="2550" b="0">
-                <a:solidFill>
-                  <a:srgbClr val="B4E7DD"/>
-                </a:solidFill>
-                <a:latin typeface="Arial"/>
-                <a:ea typeface="Arial"/>
-                <a:cs typeface="Arial"/>
-              </a:defRPr>
-            </a:defPPr>
-          </a:lstStyle>
-          <a:p xmlns:a="http://schemas.openxmlformats.org/drawingml/2006/main">
-            <a:pPr>
-              <a:defRPr sz="2550" b="0">
-                <a:solidFill>
-                  <a:srgbClr val="B4E7DD"/>
-                </a:solidFill>
-                <a:latin typeface="Arial"/>
-                <a:ea typeface="Arial"/>
-                <a:cs typeface="Arial"/>
-              </a:defRPr>
-            </a:pPr>
-            <a:r>
-              <a:rPr sz="2550" b="0">
-                <a:solidFill>
-                  <a:srgbClr val="B4E7DD"/>
-                </a:solidFill>
-                <a:latin typeface="Arial"/>
-                <a:ea typeface="Arial"/>
-                <a:cs typeface="Arial"/>
-              </a:rPr>
-              <a:t>Niche private companies,</a:t>
-            </a:r>
-          </a:p>
-          <a:p xmlns:a="http://schemas.openxmlformats.org/drawingml/2006/main">
-            <a:pPr>
-              <a:defRPr sz="2550" b="0">
-                <a:solidFill>
-                  <a:srgbClr val="B4E7DD"/>
-                </a:solidFill>
-                <a:latin typeface="Arial"/>
-                <a:ea typeface="Arial"/>
-                <a:cs typeface="Arial"/>
-              </a:defRPr>
-            </a:pPr>
-            <a:r>
-              <a:rPr sz="2550" b="0">
-                <a:solidFill>
-                  <a:srgbClr val="B4E7DD"/>
-                </a:solidFill>
-                <a:latin typeface="Arial"/>
-                <a:ea typeface="Arial"/>
-                <a:cs typeface="Arial"/>
-              </a:rPr>
-              <a:t>with a reason to care now</a:t>
-            </a:r>
-          </a:p>
-        </p:txBody>
-      </p:sp>
-      <p:sp>
-        <p:nvSpPr>
-          <p:cNvPr id="4" name="shortlist-body">
-            <a:extLst xmlns:a="http://schemas.openxmlformats.org/drawingml/2006/main">
-              <a:ext uri="{FF2B5EF4-FFF2-40B4-BE49-F238E27FC236}">
-                <a16:creationId xmlns:a16="http://schemas.microsoft.com/office/drawing/2014/main" id="{EC750104-841F-46EA-849C-AA672459418A}"/>
-              </a:ext>
-            </a:extLst>
-          </p:cNvPr>
-          <p:cNvSpPr>
-            <a:spLocks xmlns:a="http://schemas.openxmlformats.org/drawingml/2006/main" noGrp="1"/>
-          </p:cNvSpPr>
-          <p:nvPr/>
-        </p:nvSpPr>
-        <p:spPr>
-          <a:xfrm xmlns:a="http://schemas.openxmlformats.org/drawingml/2006/main">
-            <a:off x="638175" y="3248025"/>
-            <a:ext cx="3705225" cy="1724025"/>
-          </a:xfrm>
-          <a:prstGeom xmlns:a="http://schemas.openxmlformats.org/drawingml/2006/main" prst="rect">
-            <a:avLst/>
-          </a:prstGeom>
-          <a:noFill xmlns:a="http://schemas.openxmlformats.org/drawingml/2006/main"/>
-          <a:ln xmlns:a="http://schemas.openxmlformats.org/drawingml/2006/main" w="0">
-            <a:noFill/>
-          </a:ln>
-        </p:spPr>
-        <p:txBody>
-          <a:bodyPr xmlns:a="http://schemas.openxmlformats.org/drawingml/2006/main" wrap="square" lIns="0" tIns="0" rIns="0" bIns="0">
-            <a:noAutofit/>
-          </a:bodyPr>
-          <a:lstStyle xmlns:a="http://schemas.openxmlformats.org/drawingml/2006/main">
-            <a:defPPr>
-              <a:defRPr sz="1875" b="0">
-                <a:solidFill>
-                  <a:srgbClr val="ABBDCC"/>
-                </a:solidFill>
-                <a:latin typeface="Arial"/>
-                <a:ea typeface="Arial"/>
-                <a:cs typeface="Arial"/>
-              </a:defRPr>
-            </a:defPPr>
-          </a:lstStyle>
-          <a:p xmlns:a="http://schemas.openxmlformats.org/drawingml/2006/main">
-            <a:pPr>
-              <a:defRPr sz="1875" b="0">
-                <a:solidFill>
-                  <a:srgbClr val="ABBDCC"/>
-                </a:solidFill>
-                <a:latin typeface="Arial"/>
-                <a:ea typeface="Arial"/>
-                <a:cs typeface="Arial"/>
-              </a:defRPr>
-            </a:pPr>
-            <a:r>
-              <a:rPr sz="1875" b="0">
-                <a:solidFill>
-                  <a:srgbClr val="ABBDCC"/>
-                </a:solidFill>
-                <a:latin typeface="Arial"/>
-                <a:ea typeface="Arial"/>
-                <a:cs typeface="Arial"/>
-              </a:rPr>
-              <a:t>A dated financing valuation</a:t>
-            </a:r>
-          </a:p>
-          <a:p xmlns:a="http://schemas.openxmlformats.org/drawingml/2006/main">
-            <a:pPr>
-              <a:defRPr sz="1875" b="0">
-                <a:solidFill>
-                  <a:srgbClr val="ABBDCC"/>
-                </a:solidFill>
-                <a:latin typeface="Arial"/>
-                <a:ea typeface="Arial"/>
-                <a:cs typeface="Arial"/>
-              </a:defRPr>
-            </a:pPr>
-            <a:r>
-              <a:rPr sz="1875" b="0">
-                <a:solidFill>
-                  <a:srgbClr val="ABBDCC"/>
-                </a:solidFill>
-                <a:latin typeface="Arial"/>
-                <a:ea typeface="Arial"/>
-                <a:cs typeface="Arial"/>
-              </a:rPr>
-              <a:t>The commercial hypothesis</a:t>
-            </a:r>
-          </a:p>
-          <a:p xmlns:a="http://schemas.openxmlformats.org/drawingml/2006/main">
-            <a:pPr>
-              <a:defRPr sz="1875" b="0">
-                <a:solidFill>
-                  <a:srgbClr val="ABBDCC"/>
-                </a:solidFill>
-                <a:latin typeface="Arial"/>
-                <a:ea typeface="Arial"/>
-                <a:cs typeface="Arial"/>
-              </a:defRPr>
-            </a:pPr>
-            <a:r>
-              <a:rPr sz="1875" b="0">
-                <a:solidFill>
-                  <a:srgbClr val="ABBDCC"/>
-                </a:solidFill>
-                <a:latin typeface="Arial"/>
-                <a:ea typeface="Arial"/>
-                <a:cs typeface="Arial"/>
-              </a:rPr>
-              <a:t>The strongest objection</a:t>
-            </a:r>
-          </a:p>
-          <a:p xmlns:a="http://schemas.openxmlformats.org/drawingml/2006/main">
-            <a:pPr>
-              <a:defRPr sz="1875" b="0">
-                <a:solidFill>
-                  <a:srgbClr val="ABBDCC"/>
-                </a:solidFill>
-                <a:latin typeface="Arial"/>
-                <a:ea typeface="Arial"/>
-                <a:cs typeface="Arial"/>
-              </a:defRPr>
-            </a:pPr>
-            <a:r>
-              <a:rPr sz="1875" b="0">
-                <a:solidFill>
-                  <a:srgbClr val="ABBDCC"/>
-                </a:solidFill>
-                <a:latin typeface="Arial"/>
-                <a:ea typeface="Arial"/>
-                <a:cs typeface="Arial"/>
-              </a:rPr>
-              <a:t>The next proof to collect</a:t>
-            </a:r>
-          </a:p>
-        </p:txBody>
-      </p:sp>
-      <p:sp>
-        <p:nvSpPr>
-          <p:cNvPr id="5" name="shortlist-preference">
-            <a:extLst xmlns:a="http://schemas.openxmlformats.org/drawingml/2006/main">
-              <a:ext uri="{FF2B5EF4-FFF2-40B4-BE49-F238E27FC236}">
-                <a16:creationId xmlns:a16="http://schemas.microsoft.com/office/drawing/2014/main" id="{D5D3BD7A-BBE2-4BBB-94E5-109DCB6C8C27}"/>
-              </a:ext>
-            </a:extLst>
-          </p:cNvPr>
-          <p:cNvSpPr>
-            <a:spLocks xmlns:a="http://schemas.openxmlformats.org/drawingml/2006/main" noGrp="1"/>
-          </p:cNvSpPr>
-          <p:nvPr/>
-        </p:nvSpPr>
-        <p:spPr>
-          <a:xfrm xmlns:a="http://schemas.openxmlformats.org/drawingml/2006/main">
-            <a:off x="638175" y="5305425"/>
-            <a:ext cx="3524250" cy="714375"/>
-          </a:xfrm>
-          <a:prstGeom xmlns:a="http://schemas.openxmlformats.org/drawingml/2006/main" prst="rect">
-            <a:avLst/>
-          </a:prstGeom>
-          <a:noFill xmlns:a="http://schemas.openxmlformats.org/drawingml/2006/main"/>
-          <a:ln xmlns:a="http://schemas.openxmlformats.org/drawingml/2006/main" w="0">
-            <a:noFill/>
-          </a:ln>
-        </p:spPr>
-        <p:txBody>
-          <a:bodyPr xmlns:a="http://schemas.openxmlformats.org/drawingml/2006/main" wrap="square" lIns="0" tIns="0" rIns="0" bIns="0">
-            <a:noAutofit/>
-          </a:bodyPr>
-          <a:lstStyle xmlns:a="http://schemas.openxmlformats.org/drawingml/2006/main">
-            <a:defPPr>
-              <a:defRPr sz="1950" b="0">
-                <a:solidFill>
-                  <a:srgbClr val="C6B6F3"/>
-                </a:solidFill>
-                <a:latin typeface="Arial"/>
-                <a:ea typeface="Arial"/>
-                <a:cs typeface="Arial"/>
-              </a:defRPr>
-            </a:defPPr>
-          </a:lstStyle>
-          <a:p xmlns:a="http://schemas.openxmlformats.org/drawingml/2006/main">
-            <a:pPr>
-              <a:defRPr sz="1950" b="0">
-                <a:solidFill>
-                  <a:srgbClr val="C6B6F3"/>
-                </a:solidFill>
-                <a:latin typeface="Arial"/>
-                <a:ea typeface="Arial"/>
-                <a:cs typeface="Arial"/>
-              </a:defRPr>
-            </a:pPr>
-            <a:r>
-              <a:rPr sz="1950" b="0">
-                <a:solidFill>
-                  <a:srgbClr val="C6B6F3"/>
-                </a:solidFill>
-                <a:latin typeface="Arial"/>
-                <a:ea typeface="Arial"/>
-                <a:cs typeface="Arial"/>
-              </a:rPr>
-              <a:t>Default preference</a:t>
-            </a:r>
-          </a:p>
-          <a:p xmlns:a="http://schemas.openxmlformats.org/drawingml/2006/main">
-            <a:pPr>
-              <a:defRPr sz="1950" b="0">
-                <a:solidFill>
-                  <a:srgbClr val="C6B6F3"/>
-                </a:solidFill>
-                <a:latin typeface="Arial"/>
-                <a:ea typeface="Arial"/>
-                <a:cs typeface="Arial"/>
-              </a:defRPr>
-            </a:pPr>
-            <a:r>
-              <a:rPr sz="1950" b="0">
-                <a:solidFill>
-                  <a:srgbClr val="C6B6F3"/>
-                </a:solidFill>
-                <a:latin typeface="Arial"/>
-                <a:ea typeface="Arial"/>
-                <a:cs typeface="Arial"/>
-              </a:rPr>
-              <a:t>$100M or below</a:t>
-            </a:r>
-          </a:p>
-        </p:txBody>
-      </p:sp>
-      <p:pic>
-        <p:nvPicPr>
-          <p:cNvPr id="6" name="">
-            <a:extLst xmlns:a="http://schemas.openxmlformats.org/drawingml/2006/main">
-              <a:ext uri="{FF2B5EF4-FFF2-40B4-BE49-F238E27FC236}">
-                <a16:creationId xmlns:a16="http://schemas.microsoft.com/office/drawing/2014/main" id="{B8D5AE33-B3AF-419F-B12C-58F33C18DAC6}"/>
+                <a16:creationId xmlns:a16="http://schemas.microsoft.com/office/drawing/2014/main" id="{93AC20C6-744A-4C46-98D9-55F7F03C628D}"/>
               </a:ext>
             </a:extLst>
           </p:cNvPr>
@@ -4918,13 +4584,13 @@
           <p:nvPr/>
         </p:nvPicPr>
         <p:blipFill>
-          <a:blip xmlns:r="http://schemas.openxmlformats.org/officeDocument/2006/relationships" xmlns:a="http://schemas.openxmlformats.org/drawingml/2006/main" r:embed="Rffa362fb2f3f41c3"/>
+          <a:blip xmlns:r="http://schemas.openxmlformats.org/officeDocument/2006/relationships" xmlns:a="http://schemas.openxmlformats.org/drawingml/2006/main" r:embed="Rd03427d214ce45f0"/>
           <a:stretch xmlns:a="http://schemas.openxmlformats.org/drawingml/2006/main"/>
         </p:blipFill>
         <p:spPr>
           <a:xfrm xmlns:a="http://schemas.openxmlformats.org/drawingml/2006/main">
-            <a:off x="5262634" y="1714500"/>
-            <a:ext cx="5648183" cy="4143375"/>
+            <a:off x="2914840" y="1409700"/>
+            <a:ext cx="6362321" cy="4667250"/>
           </a:xfrm>
           <a:prstGeom xmlns:a="http://schemas.openxmlformats.org/drawingml/2006/main" prst="rect">
             <a:avLst/>
@@ -4933,10 +4599,10 @@
       </p:pic>
       <p:sp>
         <p:nvSpPr>
-          <p:cNvPr id="7" name="financing-note">
+          <p:cNvPr id="4" name="product-caption">
             <a:extLst xmlns:a="http://schemas.openxmlformats.org/drawingml/2006/main">
               <a:ext uri="{FF2B5EF4-FFF2-40B4-BE49-F238E27FC236}">
-                <a16:creationId xmlns:a16="http://schemas.microsoft.com/office/drawing/2014/main" id="{72750356-A057-45D9-AA02-34A984DBF7B9}"/>
+                <a16:creationId xmlns:a16="http://schemas.microsoft.com/office/drawing/2014/main" id="{EAC3C956-FBA5-4F93-8C19-42FCE30BE34D}"/>
               </a:ext>
             </a:extLst>
           </p:cNvPr>
@@ -4947,8 +4613,8 @@
         </p:nvSpPr>
         <p:spPr>
           <a:xfrm xmlns:a="http://schemas.openxmlformats.org/drawingml/2006/main">
-            <a:off x="4552950" y="5924550"/>
-            <a:ext cx="6838950" cy="457200"/>
+            <a:off x="609600" y="6238875"/>
+            <a:ext cx="10906125" cy="352425"/>
           </a:xfrm>
           <a:prstGeom xmlns:a="http://schemas.openxmlformats.org/drawingml/2006/main" prst="rect">
             <a:avLst/>
@@ -4964,9 +4630,9 @@
           </a:bodyPr>
           <a:lstStyle xmlns:a="http://schemas.openxmlformats.org/drawingml/2006/main">
             <a:defPPr>
-              <a:defRPr sz="1275" b="0">
-                <a:solidFill>
-                  <a:srgbClr val="ABBDCC"/>
+              <a:defRPr sz="1500" b="0">
+                <a:solidFill>
+                  <a:srgbClr val="B4E7DD"/>
                 </a:solidFill>
                 <a:latin typeface="Arial"/>
                 <a:ea typeface="Arial"/>
@@ -4976,9 +4642,9 @@
           </a:lstStyle>
           <a:p xmlns:a="http://schemas.openxmlformats.org/drawingml/2006/main">
             <a:pPr>
-              <a:defRPr sz="1275" b="0">
-                <a:solidFill>
-                  <a:srgbClr val="ABBDCC"/>
+              <a:defRPr sz="1500" b="0">
+                <a:solidFill>
+                  <a:srgbClr val="B4E7DD"/>
                 </a:solidFill>
                 <a:latin typeface="Arial"/>
                 <a:ea typeface="Arial"/>
@@ -4986,15 +4652,15 @@
               </a:defRPr>
             </a:pPr>
             <a:r>
-              <a:rPr sz="1275" b="0">
-                <a:solidFill>
-                  <a:srgbClr val="ABBDCC"/>
+              <a:rPr sz="1500" b="0">
+                <a:solidFill>
+                  <a:srgbClr val="B4E7DD"/>
                 </a:solidFill>
                 <a:latin typeface="Arial"/>
                 <a:ea typeface="Arial"/>
                 <a:cs typeface="Arial"/>
               </a:rPr>
-              <a:t>Historical financing marks. Up to five qualify. Investment access and current entry terms need separate diligence.</a:t>
+              <a:t>Four companies at $100M or below. Click a company for its evidence and what could break the thesis.</a:t>
             </a:r>
           </a:p>
         </p:txBody>
@@ -5002,7 +4668,7 @@
     </p:spTree>
     <p:extLst>
       <p:ext uri="{BB962C8B-B14F-4D97-AF65-F5344CB8AC3E}">
-        <p14:creationId xmlns:p14="http://schemas.microsoft.com/office/powerpoint/2010/main" val="899557345"/>
+        <p14:creationId xmlns:p14="http://schemas.microsoft.com/office/powerpoint/2010/main" val="791619224"/>
       </p:ext>
     </p:extLst>
   </p:cSld>
@@ -5030,10 +4696,10 @@
       </p:grpSpPr>
       <p:sp>
         <p:nvSpPr>
-          <p:cNvPr id="10" name="slide-number">
+          <p:cNvPr id="5" name="slide-number">
             <a:extLst xmlns:a="http://schemas.openxmlformats.org/drawingml/2006/main">
               <a:ext uri="{FF2B5EF4-FFF2-40B4-BE49-F238E27FC236}">
-                <a16:creationId xmlns:a16="http://schemas.microsoft.com/office/drawing/2014/main" id="{3A7090CA-30CF-43E4-BE5B-AE77F98560DA}"/>
+                <a16:creationId xmlns:a16="http://schemas.microsoft.com/office/drawing/2014/main" id="{8F4A3096-ABB0-48FC-AB3C-CB8DC3989507}"/>
               </a:ext>
             </a:extLst>
           </p:cNvPr>
@@ -5101,7 +4767,7 @@
           <p:cNvPr id="2" name="slide-title">
             <a:extLst xmlns:a="http://schemas.openxmlformats.org/drawingml/2006/main">
               <a:ext uri="{FF2B5EF4-FFF2-40B4-BE49-F238E27FC236}">
-                <a16:creationId xmlns:a16="http://schemas.microsoft.com/office/drawing/2014/main" id="{055E40B4-784F-4A1D-95EF-7F4401D7A732}"/>
+                <a16:creationId xmlns:a16="http://schemas.microsoft.com/office/drawing/2014/main" id="{410B53F8-B3BB-4134-84C1-948614818F95}"/>
               </a:ext>
             </a:extLst>
           </p:cNvPr>
@@ -5159,108 +4825,17 @@
                 <a:ea typeface="Arial"/>
                 <a:cs typeface="Arial"/>
               </a:rPr>
-              <a:t>Conviction Universe</a:t>
-            </a:r>
-          </a:p>
-        </p:txBody>
-      </p:sp>
-      <p:sp>
-        <p:nvSpPr>
-          <p:cNvPr id="3" name="universe-question">
+              <a:t>Demo: remove the company’s own claims</a:t>
+            </a:r>
+          </a:p>
+        </p:txBody>
+      </p:sp>
+      <p:pic>
+        <p:nvPicPr>
+          <p:cNvPr id="3" name="">
             <a:extLst xmlns:a="http://schemas.openxmlformats.org/drawingml/2006/main">
               <a:ext uri="{FF2B5EF4-FFF2-40B4-BE49-F238E27FC236}">
-                <a16:creationId xmlns:a16="http://schemas.microsoft.com/office/drawing/2014/main" id="{FF4B80CE-4D06-4DF5-A8B7-F27385288DA7}"/>
-              </a:ext>
-            </a:extLst>
-          </p:cNvPr>
-          <p:cNvSpPr>
-            <a:spLocks xmlns:a="http://schemas.openxmlformats.org/drawingml/2006/main" noGrp="1"/>
-          </p:cNvSpPr>
-          <p:nvPr/>
-        </p:nvSpPr>
-        <p:spPr>
-          <a:xfrm xmlns:a="http://schemas.openxmlformats.org/drawingml/2006/main">
-            <a:off x="619125" y="1657350"/>
-            <a:ext cx="10477500" cy="1000125"/>
-          </a:xfrm>
-          <a:prstGeom xmlns:a="http://schemas.openxmlformats.org/drawingml/2006/main" prst="rect">
-            <a:avLst/>
-          </a:prstGeom>
-          <a:noFill xmlns:a="http://schemas.openxmlformats.org/drawingml/2006/main"/>
-          <a:ln xmlns:a="http://schemas.openxmlformats.org/drawingml/2006/main" w="0">
-            <a:noFill/>
-          </a:ln>
-        </p:spPr>
-        <p:txBody>
-          <a:bodyPr xmlns:a="http://schemas.openxmlformats.org/drawingml/2006/main" wrap="square" lIns="0" tIns="0" rIns="0" bIns="0">
-            <a:noAutofit/>
-          </a:bodyPr>
-          <a:lstStyle xmlns:a="http://schemas.openxmlformats.org/drawingml/2006/main">
-            <a:defPPr>
-              <a:defRPr sz="3225" b="0">
-                <a:solidFill>
-                  <a:srgbClr val="B4E7DD"/>
-                </a:solidFill>
-                <a:latin typeface="Arial"/>
-                <a:ea typeface="Arial"/>
-                <a:cs typeface="Arial"/>
-              </a:defRPr>
-            </a:defPPr>
-          </a:lstStyle>
-          <a:p xmlns:a="http://schemas.openxmlformats.org/drawingml/2006/main">
-            <a:pPr>
-              <a:defRPr sz="3225" b="0">
-                <a:solidFill>
-                  <a:srgbClr val="B4E7DD"/>
-                </a:solidFill>
-                <a:latin typeface="Arial"/>
-                <a:ea typeface="Arial"/>
-                <a:cs typeface="Arial"/>
-              </a:defRPr>
-            </a:pPr>
-            <a:r>
-              <a:rPr sz="3225" b="0">
-                <a:solidFill>
-                  <a:srgbClr val="B4E7DD"/>
-                </a:solidFill>
-                <a:latin typeface="Arial"/>
-                <a:ea typeface="Arial"/>
-                <a:cs typeface="Arial"/>
-              </a:rPr>
-              <a:t>What survives without</a:t>
-            </a:r>
-          </a:p>
-          <a:p xmlns:a="http://schemas.openxmlformats.org/drawingml/2006/main">
-            <a:pPr>
-              <a:defRPr sz="3225" b="0">
-                <a:solidFill>
-                  <a:srgbClr val="B4E7DD"/>
-                </a:solidFill>
-                <a:latin typeface="Arial"/>
-                <a:ea typeface="Arial"/>
-                <a:cs typeface="Arial"/>
-              </a:defRPr>
-            </a:pPr>
-            <a:r>
-              <a:rPr sz="3225" b="0">
-                <a:solidFill>
-                  <a:srgbClr val="B4E7DD"/>
-                </a:solidFill>
-                <a:latin typeface="Arial"/>
-                <a:ea typeface="Arial"/>
-                <a:cs typeface="Arial"/>
-              </a:rPr>
-              <a:t>company claims?</a:t>
-            </a:r>
-          </a:p>
-        </p:txBody>
-      </p:sp>
-      <p:pic>
-        <p:nvPicPr>
-          <p:cNvPr id="4" name="">
-            <a:extLst xmlns:a="http://schemas.openxmlformats.org/drawingml/2006/main">
-              <a:ext uri="{FF2B5EF4-FFF2-40B4-BE49-F238E27FC236}">
-                <a16:creationId xmlns:a16="http://schemas.microsoft.com/office/drawing/2014/main" id="{3610613E-D0A3-4796-B2D0-FE58B770C9BA}"/>
+                <a16:creationId xmlns:a16="http://schemas.microsoft.com/office/drawing/2014/main" id="{56A51DA5-153B-4EF2-B774-40AB5F3669C5}"/>
               </a:ext>
             </a:extLst>
           </p:cNvPr>
@@ -5270,13 +4845,13 @@
           <p:nvPr/>
         </p:nvPicPr>
         <p:blipFill>
-          <a:blip xmlns:r="http://schemas.openxmlformats.org/officeDocument/2006/relationships" xmlns:a="http://schemas.openxmlformats.org/drawingml/2006/main" r:embed="R6eeb2d6738214a01"/>
+          <a:blip xmlns:r="http://schemas.openxmlformats.org/officeDocument/2006/relationships" xmlns:a="http://schemas.openxmlformats.org/drawingml/2006/main" r:embed="R861a398ce6ed4c24"/>
           <a:stretch xmlns:a="http://schemas.openxmlformats.org/drawingml/2006/main"/>
         </p:blipFill>
         <p:spPr>
           <a:xfrm xmlns:a="http://schemas.openxmlformats.org/drawingml/2006/main">
-            <a:off x="2120497" y="2762250"/>
-            <a:ext cx="4531531" cy="3324225"/>
+            <a:off x="2901855" y="1381125"/>
+            <a:ext cx="6388290" cy="4686300"/>
           </a:xfrm>
           <a:prstGeom xmlns:a="http://schemas.openxmlformats.org/drawingml/2006/main" prst="rect">
             <a:avLst/>
@@ -5285,10 +4860,10 @@
       </p:pic>
       <p:sp>
         <p:nvSpPr>
-          <p:cNvPr id="5" name="universe-radius">
+          <p:cNvPr id="4" name="map-caption">
             <a:extLst xmlns:a="http://schemas.openxmlformats.org/drawingml/2006/main">
               <a:ext uri="{FF2B5EF4-FFF2-40B4-BE49-F238E27FC236}">
-                <a16:creationId xmlns:a16="http://schemas.microsoft.com/office/drawing/2014/main" id="{688700AC-1530-4E09-97C1-93BE5F6F3229}"/>
+                <a16:creationId xmlns:a16="http://schemas.microsoft.com/office/drawing/2014/main" id="{1CF30896-4268-466B-A6DE-1A2A95289E1C}"/>
               </a:ext>
             </a:extLst>
           </p:cNvPr>
@@ -5299,8 +4874,8 @@
         </p:nvSpPr>
         <p:spPr>
           <a:xfrm xmlns:a="http://schemas.openxmlformats.org/drawingml/2006/main">
-            <a:off x="8677275" y="2876550"/>
-            <a:ext cx="2952750" cy="304800"/>
+            <a:off x="609600" y="6238875"/>
+            <a:ext cx="10906125" cy="352425"/>
           </a:xfrm>
           <a:prstGeom xmlns:a="http://schemas.openxmlformats.org/drawingml/2006/main" prst="rect">
             <a:avLst/>
@@ -5316,9 +4891,9 @@
           </a:bodyPr>
           <a:lstStyle xmlns:a="http://schemas.openxmlformats.org/drawingml/2006/main">
             <a:defPPr>
-              <a:defRPr sz="1275" b="1">
-                <a:solidFill>
-                  <a:srgbClr val="C6B6F3"/>
+              <a:defRPr sz="1500" b="0">
+                <a:solidFill>
+                  <a:srgbClr val="B4E7DD"/>
                 </a:solidFill>
                 <a:latin typeface="Arial"/>
                 <a:ea typeface="Arial"/>
@@ -5328,9 +4903,9 @@
           </a:lstStyle>
           <a:p xmlns:a="http://schemas.openxmlformats.org/drawingml/2006/main">
             <a:pPr>
-              <a:defRPr sz="1275" b="1">
-                <a:solidFill>
-                  <a:srgbClr val="C6B6F3"/>
+              <a:defRPr sz="1500" b="0">
+                <a:solidFill>
+                  <a:srgbClr val="B4E7DD"/>
                 </a:solidFill>
                 <a:latin typeface="Arial"/>
                 <a:ea typeface="Arial"/>
@@ -5338,310 +4913,15 @@
               </a:defRPr>
             </a:pPr>
             <a:r>
-              <a:rPr sz="1275" b="1">
-                <a:solidFill>
-                  <a:srgbClr val="C6B6F3"/>
+              <a:rPr sz="1500" b="0">
+                <a:solidFill>
+                  <a:srgbClr val="B4E7DD"/>
                 </a:solidFill>
                 <a:latin typeface="Arial"/>
                 <a:ea typeface="Arial"/>
                 <a:cs typeface="Arial"/>
               </a:rPr>
-              <a:t>CLOSER TO THE CORE</a:t>
-            </a:r>
-          </a:p>
-        </p:txBody>
-      </p:sp>
-      <p:sp>
-        <p:nvSpPr>
-          <p:cNvPr id="6" name="universe-radius-body">
-            <a:extLst xmlns:a="http://schemas.openxmlformats.org/drawingml/2006/main">
-              <a:ext uri="{FF2B5EF4-FFF2-40B4-BE49-F238E27FC236}">
-                <a16:creationId xmlns:a16="http://schemas.microsoft.com/office/drawing/2014/main" id="{D8AF6325-B925-44B1-ADF8-55500A03EAA6}"/>
-              </a:ext>
-            </a:extLst>
-          </p:cNvPr>
-          <p:cNvSpPr>
-            <a:spLocks xmlns:a="http://schemas.openxmlformats.org/drawingml/2006/main" noGrp="1"/>
-          </p:cNvSpPr>
-          <p:nvPr/>
-        </p:nvSpPr>
-        <p:spPr>
-          <a:xfrm xmlns:a="http://schemas.openxmlformats.org/drawingml/2006/main">
-            <a:off x="8677275" y="3257550"/>
-            <a:ext cx="2952750" cy="866775"/>
-          </a:xfrm>
-          <a:prstGeom xmlns:a="http://schemas.openxmlformats.org/drawingml/2006/main" prst="rect">
-            <a:avLst/>
-          </a:prstGeom>
-          <a:noFill xmlns:a="http://schemas.openxmlformats.org/drawingml/2006/main"/>
-          <a:ln xmlns:a="http://schemas.openxmlformats.org/drawingml/2006/main" w="0">
-            <a:noFill/>
-          </a:ln>
-        </p:spPr>
-        <p:txBody>
-          <a:bodyPr xmlns:a="http://schemas.openxmlformats.org/drawingml/2006/main" wrap="square" lIns="0" tIns="0" rIns="0" bIns="0">
-            <a:noAutofit/>
-          </a:bodyPr>
-          <a:lstStyle xmlns:a="http://schemas.openxmlformats.org/drawingml/2006/main">
-            <a:defPPr>
-              <a:defRPr sz="1875" b="0">
-                <a:solidFill>
-                  <a:srgbClr val="F1F7FA"/>
-                </a:solidFill>
-                <a:latin typeface="Arial"/>
-                <a:ea typeface="Arial"/>
-                <a:cs typeface="Arial"/>
-              </a:defRPr>
-            </a:defPPr>
-          </a:lstStyle>
-          <a:p xmlns:a="http://schemas.openxmlformats.org/drawingml/2006/main">
-            <a:pPr>
-              <a:defRPr sz="1875" b="0">
-                <a:solidFill>
-                  <a:srgbClr val="F1F7FA"/>
-                </a:solidFill>
-                <a:latin typeface="Arial"/>
-                <a:ea typeface="Arial"/>
-                <a:cs typeface="Arial"/>
-              </a:defRPr>
-            </a:pPr>
-            <a:r>
-              <a:rPr sz="1875" b="0">
-                <a:solidFill>
-                  <a:srgbClr val="F1F7FA"/>
-                </a:solidFill>
-                <a:latin typeface="Arial"/>
-                <a:ea typeface="Arial"/>
-                <a:cs typeface="Arial"/>
-              </a:rPr>
-              <a:t>More cited evidence</a:t>
-            </a:r>
-          </a:p>
-          <a:p xmlns:a="http://schemas.openxmlformats.org/drawingml/2006/main">
-            <a:pPr>
-              <a:defRPr sz="1875" b="0">
-                <a:solidFill>
-                  <a:srgbClr val="F1F7FA"/>
-                </a:solidFill>
-                <a:latin typeface="Arial"/>
-                <a:ea typeface="Arial"/>
-                <a:cs typeface="Arial"/>
-              </a:defRPr>
-            </a:pPr>
-            <a:r>
-              <a:rPr sz="1875" b="0">
-                <a:solidFill>
-                  <a:srgbClr val="F1F7FA"/>
-                </a:solidFill>
-                <a:latin typeface="Arial"/>
-                <a:ea typeface="Arial"/>
-                <a:cs typeface="Arial"/>
-              </a:rPr>
-              <a:t>records supported</a:t>
-            </a:r>
-          </a:p>
-        </p:txBody>
-      </p:sp>
-      <p:sp>
-        <p:nvSpPr>
-          <p:cNvPr id="7" name="universe-height">
-            <a:extLst xmlns:a="http://schemas.openxmlformats.org/drawingml/2006/main">
-              <a:ext uri="{FF2B5EF4-FFF2-40B4-BE49-F238E27FC236}">
-                <a16:creationId xmlns:a16="http://schemas.microsoft.com/office/drawing/2014/main" id="{CABC015C-9CD1-462F-8F0E-D502AD4C9CE9}"/>
-              </a:ext>
-            </a:extLst>
-          </p:cNvPr>
-          <p:cNvSpPr>
-            <a:spLocks xmlns:a="http://schemas.openxmlformats.org/drawingml/2006/main" noGrp="1"/>
-          </p:cNvSpPr>
-          <p:nvPr/>
-        </p:nvSpPr>
-        <p:spPr>
-          <a:xfrm xmlns:a="http://schemas.openxmlformats.org/drawingml/2006/main">
-            <a:off x="8677275" y="4295775"/>
-            <a:ext cx="2952750" cy="304800"/>
-          </a:xfrm>
-          <a:prstGeom xmlns:a="http://schemas.openxmlformats.org/drawingml/2006/main" prst="rect">
-            <a:avLst/>
-          </a:prstGeom>
-          <a:noFill xmlns:a="http://schemas.openxmlformats.org/drawingml/2006/main"/>
-          <a:ln xmlns:a="http://schemas.openxmlformats.org/drawingml/2006/main" w="0">
-            <a:noFill/>
-          </a:ln>
-        </p:spPr>
-        <p:txBody>
-          <a:bodyPr xmlns:a="http://schemas.openxmlformats.org/drawingml/2006/main" wrap="square" lIns="0" tIns="0" rIns="0" bIns="0">
-            <a:noAutofit/>
-          </a:bodyPr>
-          <a:lstStyle xmlns:a="http://schemas.openxmlformats.org/drawingml/2006/main">
-            <a:defPPr>
-              <a:defRPr sz="1275" b="1">
-                <a:solidFill>
-                  <a:srgbClr val="C6B6F3"/>
-                </a:solidFill>
-                <a:latin typeface="Arial"/>
-                <a:ea typeface="Arial"/>
-                <a:cs typeface="Arial"/>
-              </a:defRPr>
-            </a:defPPr>
-          </a:lstStyle>
-          <a:p xmlns:a="http://schemas.openxmlformats.org/drawingml/2006/main">
-            <a:pPr>
-              <a:defRPr sz="1275" b="1">
-                <a:solidFill>
-                  <a:srgbClr val="C6B6F3"/>
-                </a:solidFill>
-                <a:latin typeface="Arial"/>
-                <a:ea typeface="Arial"/>
-                <a:cs typeface="Arial"/>
-              </a:defRPr>
-            </a:pPr>
-            <a:r>
-              <a:rPr sz="1275" b="1">
-                <a:solidFill>
-                  <a:srgbClr val="C6B6F3"/>
-                </a:solidFill>
-                <a:latin typeface="Arial"/>
-                <a:ea typeface="Arial"/>
-                <a:cs typeface="Arial"/>
-              </a:rPr>
-              <a:t>HIGHER POSITION</a:t>
-            </a:r>
-          </a:p>
-        </p:txBody>
-      </p:sp>
-      <p:sp>
-        <p:nvSpPr>
-          <p:cNvPr id="8" name="universe-height-body">
-            <a:extLst xmlns:a="http://schemas.openxmlformats.org/drawingml/2006/main">
-              <a:ext uri="{FF2B5EF4-FFF2-40B4-BE49-F238E27FC236}">
-                <a16:creationId xmlns:a16="http://schemas.microsoft.com/office/drawing/2014/main" id="{DD3BB6B7-4471-41B0-BA8D-18EC783F131F}"/>
-              </a:ext>
-            </a:extLst>
-          </p:cNvPr>
-          <p:cNvSpPr>
-            <a:spLocks xmlns:a="http://schemas.openxmlformats.org/drawingml/2006/main" noGrp="1"/>
-          </p:cNvSpPr>
-          <p:nvPr/>
-        </p:nvSpPr>
-        <p:spPr>
-          <a:xfrm xmlns:a="http://schemas.openxmlformats.org/drawingml/2006/main">
-            <a:off x="8677275" y="4676775"/>
-            <a:ext cx="2857500" cy="733425"/>
-          </a:xfrm>
-          <a:prstGeom xmlns:a="http://schemas.openxmlformats.org/drawingml/2006/main" prst="rect">
-            <a:avLst/>
-          </a:prstGeom>
-          <a:noFill xmlns:a="http://schemas.openxmlformats.org/drawingml/2006/main"/>
-          <a:ln xmlns:a="http://schemas.openxmlformats.org/drawingml/2006/main" w="0">
-            <a:noFill/>
-          </a:ln>
-        </p:spPr>
-        <p:txBody>
-          <a:bodyPr xmlns:a="http://schemas.openxmlformats.org/drawingml/2006/main" wrap="square" lIns="0" tIns="0" rIns="0" bIns="0">
-            <a:noAutofit/>
-          </a:bodyPr>
-          <a:lstStyle xmlns:a="http://schemas.openxmlformats.org/drawingml/2006/main">
-            <a:defPPr>
-              <a:defRPr sz="1875" b="0">
-                <a:solidFill>
-                  <a:srgbClr val="F1F7FA"/>
-                </a:solidFill>
-                <a:latin typeface="Arial"/>
-                <a:ea typeface="Arial"/>
-                <a:cs typeface="Arial"/>
-              </a:defRPr>
-            </a:defPPr>
-          </a:lstStyle>
-          <a:p xmlns:a="http://schemas.openxmlformats.org/drawingml/2006/main">
-            <a:pPr>
-              <a:defRPr sz="1875" b="0">
-                <a:solidFill>
-                  <a:srgbClr val="F1F7FA"/>
-                </a:solidFill>
-                <a:latin typeface="Arial"/>
-                <a:ea typeface="Arial"/>
-                <a:cs typeface="Arial"/>
-              </a:defRPr>
-            </a:pPr>
-            <a:r>
-              <a:rPr sz="1875" b="0">
-                <a:solidFill>
-                  <a:srgbClr val="F1F7FA"/>
-                </a:solidFill>
-                <a:latin typeface="Arial"/>
-                <a:ea typeface="Arial"/>
-                <a:cs typeface="Arial"/>
-              </a:rPr>
-              <a:t>Greater agent confidence</a:t>
-            </a:r>
-          </a:p>
-        </p:txBody>
-      </p:sp>
-      <p:sp>
-        <p:nvSpPr>
-          <p:cNvPr id="9" name="universe-note">
-            <a:extLst xmlns:a="http://schemas.openxmlformats.org/drawingml/2006/main">
-              <a:ext uri="{FF2B5EF4-FFF2-40B4-BE49-F238E27FC236}">
-                <a16:creationId xmlns:a16="http://schemas.microsoft.com/office/drawing/2014/main" id="{23059DDF-60C2-4D1E-98D2-AEC91D67BAF1}"/>
-              </a:ext>
-            </a:extLst>
-          </p:cNvPr>
-          <p:cNvSpPr>
-            <a:spLocks xmlns:a="http://schemas.openxmlformats.org/drawingml/2006/main" noGrp="1"/>
-          </p:cNvSpPr>
-          <p:nvPr/>
-        </p:nvSpPr>
-        <p:spPr>
-          <a:xfrm xmlns:a="http://schemas.openxmlformats.org/drawingml/2006/main">
-            <a:off x="619125" y="6267450"/>
-            <a:ext cx="10429875" cy="276225"/>
-          </a:xfrm>
-          <a:prstGeom xmlns:a="http://schemas.openxmlformats.org/drawingml/2006/main" prst="rect">
-            <a:avLst/>
-          </a:prstGeom>
-          <a:noFill xmlns:a="http://schemas.openxmlformats.org/drawingml/2006/main"/>
-          <a:ln xmlns:a="http://schemas.openxmlformats.org/drawingml/2006/main" w="0">
-            <a:noFill/>
-          </a:ln>
-        </p:spPr>
-        <p:txBody>
-          <a:bodyPr xmlns:a="http://schemas.openxmlformats.org/drawingml/2006/main" wrap="square" lIns="0" tIns="0" rIns="0" bIns="0">
-            <a:noAutofit/>
-          </a:bodyPr>
-          <a:lstStyle xmlns:a="http://schemas.openxmlformats.org/drawingml/2006/main">
-            <a:defPPr>
-              <a:defRPr sz="1275" b="0">
-                <a:solidFill>
-                  <a:srgbClr val="ABBDCC"/>
-                </a:solidFill>
-                <a:latin typeface="Arial"/>
-                <a:ea typeface="Arial"/>
-                <a:cs typeface="Arial"/>
-              </a:defRPr>
-            </a:defPPr>
-          </a:lstStyle>
-          <a:p xmlns:a="http://schemas.openxmlformats.org/drawingml/2006/main">
-            <a:pPr>
-              <a:defRPr sz="1275" b="0">
-                <a:solidFill>
-                  <a:srgbClr val="ABBDCC"/>
-                </a:solidFill>
-                <a:latin typeface="Arial"/>
-                <a:ea typeface="Arial"/>
-                <a:cs typeface="Arial"/>
-              </a:defRPr>
-            </a:pPr>
-            <a:r>
-              <a:rPr sz="1275" b="0">
-                <a:solidFill>
-                  <a:srgbClr val="ABBDCC"/>
-                </a:solidFill>
-                <a:latin typeface="Arial"/>
-                <a:ea typeface="Arial"/>
-                <a:cs typeface="Arial"/>
-              </a:rPr>
-              <a:t>A scenario based on admitted evidence. Position does not predict investment returns.</a:t>
+              <a:t>Watch the evidence move. Closer means more cited support. Height means agent confidence.</a:t>
             </a:r>
           </a:p>
         </p:txBody>
@@ -5649,7 +4929,7 @@
     </p:spTree>
     <p:extLst>
       <p:ext uri="{BB962C8B-B14F-4D97-AF65-F5344CB8AC3E}">
-        <p14:creationId xmlns:p14="http://schemas.microsoft.com/office/powerpoint/2010/main" val="1638505573"/>
+        <p14:creationId xmlns:p14="http://schemas.microsoft.com/office/powerpoint/2010/main" val="550788838"/>
       </p:ext>
     </p:extLst>
   </p:cSld>
@@ -5680,7 +4960,7 @@
           <p:cNvPr id="23" name="">
             <a:extLst xmlns:a="http://schemas.openxmlformats.org/drawingml/2006/main">
               <a:ext uri="{FF2B5EF4-FFF2-40B4-BE49-F238E27FC236}">
-                <a16:creationId xmlns:a16="http://schemas.microsoft.com/office/drawing/2014/main" id="{E164CEF3-7202-409E-8BC3-2FB47F1E4F29}"/>
+                <a16:creationId xmlns:a16="http://schemas.microsoft.com/office/drawing/2014/main" id="{1F2B9213-C248-4782-9F45-03C5AA072131}"/>
               </a:ext>
             </a:extLst>
           </p:cNvPr>
@@ -5711,7 +4991,7 @@
           <p:cNvPr id="22" name="">
             <a:extLst xmlns:a="http://schemas.openxmlformats.org/drawingml/2006/main">
               <a:ext uri="{FF2B5EF4-FFF2-40B4-BE49-F238E27FC236}">
-                <a16:creationId xmlns:a16="http://schemas.microsoft.com/office/drawing/2014/main" id="{1BB607C5-631D-406E-B636-7A73F8610ABD}"/>
+                <a16:creationId xmlns:a16="http://schemas.microsoft.com/office/drawing/2014/main" id="{F1AB8B29-3CC2-47C5-A166-AF02C59ADE97}"/>
               </a:ext>
             </a:extLst>
           </p:cNvPr>
@@ -5742,7 +5022,7 @@
           <p:cNvPr id="21" name="">
             <a:extLst xmlns:a="http://schemas.openxmlformats.org/drawingml/2006/main">
               <a:ext uri="{FF2B5EF4-FFF2-40B4-BE49-F238E27FC236}">
-                <a16:creationId xmlns:a16="http://schemas.microsoft.com/office/drawing/2014/main" id="{5B721A19-1801-49EC-8413-043F1F33A3EE}"/>
+                <a16:creationId xmlns:a16="http://schemas.microsoft.com/office/drawing/2014/main" id="{2C966A93-1F78-4683-9F92-5BEDACF054CF}"/>
               </a:ext>
             </a:extLst>
           </p:cNvPr>
@@ -5775,7 +5055,7 @@
           <p:cNvPr id="20" name="">
             <a:extLst xmlns:a="http://schemas.openxmlformats.org/drawingml/2006/main">
               <a:ext uri="{FF2B5EF4-FFF2-40B4-BE49-F238E27FC236}">
-                <a16:creationId xmlns:a16="http://schemas.microsoft.com/office/drawing/2014/main" id="{58927CB6-C25A-4472-9812-C5214A04A7C9}"/>
+                <a16:creationId xmlns:a16="http://schemas.microsoft.com/office/drawing/2014/main" id="{DFB31814-7EC0-4E5B-B383-5B680A720A10}"/>
               </a:ext>
             </a:extLst>
           </p:cNvPr>
@@ -5808,7 +5088,7 @@
           <p:cNvPr id="19" name="">
             <a:extLst xmlns:a="http://schemas.openxmlformats.org/drawingml/2006/main">
               <a:ext uri="{FF2B5EF4-FFF2-40B4-BE49-F238E27FC236}">
-                <a16:creationId xmlns:a16="http://schemas.microsoft.com/office/drawing/2014/main" id="{E781D17F-757B-404C-BE12-B4540A03D1B0}"/>
+                <a16:creationId xmlns:a16="http://schemas.microsoft.com/office/drawing/2014/main" id="{88F8CD73-DC69-4DD6-9423-EE8BD1EB71AC}"/>
               </a:ext>
             </a:extLst>
           </p:cNvPr>
@@ -5839,7 +5119,7 @@
           <p:cNvPr id="18" name="">
             <a:extLst xmlns:a="http://schemas.openxmlformats.org/drawingml/2006/main">
               <a:ext uri="{FF2B5EF4-FFF2-40B4-BE49-F238E27FC236}">
-                <a16:creationId xmlns:a16="http://schemas.microsoft.com/office/drawing/2014/main" id="{91472D9D-968A-4349-97F3-30AD1E0E7A18}"/>
+                <a16:creationId xmlns:a16="http://schemas.microsoft.com/office/drawing/2014/main" id="{BE24416F-5932-4732-9D3A-75F9E3A7A17D}"/>
               </a:ext>
             </a:extLst>
           </p:cNvPr>
@@ -5870,7 +5150,7 @@
           <p:cNvPr id="17" name="">
             <a:extLst xmlns:a="http://schemas.openxmlformats.org/drawingml/2006/main">
               <a:ext uri="{FF2B5EF4-FFF2-40B4-BE49-F238E27FC236}">
-                <a16:creationId xmlns:a16="http://schemas.microsoft.com/office/drawing/2014/main" id="{5C3BAC66-7A6F-4E61-9E0A-227DB614BDB0}"/>
+                <a16:creationId xmlns:a16="http://schemas.microsoft.com/office/drawing/2014/main" id="{646CE45F-7B8D-4A99-B5C0-1A2755E1BE31}"/>
               </a:ext>
             </a:extLst>
           </p:cNvPr>
@@ -5903,7 +5183,7 @@
           <p:cNvPr id="16" name="">
             <a:extLst xmlns:a="http://schemas.openxmlformats.org/drawingml/2006/main">
               <a:ext uri="{FF2B5EF4-FFF2-40B4-BE49-F238E27FC236}">
-                <a16:creationId xmlns:a16="http://schemas.microsoft.com/office/drawing/2014/main" id="{463FE674-4B89-484D-8BA5-022FF9196EB9}"/>
+                <a16:creationId xmlns:a16="http://schemas.microsoft.com/office/drawing/2014/main" id="{69604A0C-1E64-406C-B2DD-E850D91EED89}"/>
               </a:ext>
             </a:extLst>
           </p:cNvPr>
@@ -5936,7 +5216,7 @@
           <p:cNvPr id="15" name="">
             <a:extLst xmlns:a="http://schemas.openxmlformats.org/drawingml/2006/main">
               <a:ext uri="{FF2B5EF4-FFF2-40B4-BE49-F238E27FC236}">
-                <a16:creationId xmlns:a16="http://schemas.microsoft.com/office/drawing/2014/main" id="{EA9A1F20-B985-4F4F-A541-40A6F413694A}"/>
+                <a16:creationId xmlns:a16="http://schemas.microsoft.com/office/drawing/2014/main" id="{FA823A51-79FF-4424-8240-6B89B5D6011C}"/>
               </a:ext>
             </a:extLst>
           </p:cNvPr>
@@ -5967,7 +5247,7 @@
           <p:cNvPr id="14" name="">
             <a:extLst xmlns:a="http://schemas.openxmlformats.org/drawingml/2006/main">
               <a:ext uri="{FF2B5EF4-FFF2-40B4-BE49-F238E27FC236}">
-                <a16:creationId xmlns:a16="http://schemas.microsoft.com/office/drawing/2014/main" id="{2E1009EB-A8F9-486E-87F0-8548044704E4}"/>
+                <a16:creationId xmlns:a16="http://schemas.microsoft.com/office/drawing/2014/main" id="{6EB51155-0DFD-4840-AC83-764D2B859072}"/>
               </a:ext>
             </a:extLst>
           </p:cNvPr>
@@ -5998,7 +5278,7 @@
           <p:cNvPr id="26" name="slide-number">
             <a:extLst xmlns:a="http://schemas.openxmlformats.org/drawingml/2006/main">
               <a:ext uri="{FF2B5EF4-FFF2-40B4-BE49-F238E27FC236}">
-                <a16:creationId xmlns:a16="http://schemas.microsoft.com/office/drawing/2014/main" id="{06BA9E92-17F5-4589-9B07-F52C2C9B13C7}"/>
+                <a16:creationId xmlns:a16="http://schemas.microsoft.com/office/drawing/2014/main" id="{4499C98A-C769-4806-9653-0A9FA540FA16}"/>
               </a:ext>
             </a:extLst>
           </p:cNvPr>
@@ -6066,7 +5346,7 @@
           <p:cNvPr id="2" name="slide-title">
             <a:extLst xmlns:a="http://schemas.openxmlformats.org/drawingml/2006/main">
               <a:ext uri="{FF2B5EF4-FFF2-40B4-BE49-F238E27FC236}">
-                <a16:creationId xmlns:a16="http://schemas.microsoft.com/office/drawing/2014/main" id="{0206276E-588B-4E9F-9D0D-FD67B8AF8A75}"/>
+                <a16:creationId xmlns:a16="http://schemas.microsoft.com/office/drawing/2014/main" id="{A53219EB-40C5-452A-AED7-4B50227B4BA7}"/>
               </a:ext>
             </a:extLst>
           </p:cNvPr>
@@ -6124,7 +5404,7 @@
                 <a:ea typeface="Arial"/>
                 <a:cs typeface="Arial"/>
               </a:rPr>
-              <a:t>Nine agents with a feedback loop</a:t>
+              <a:t>Architecture: nine agents that challenge each other</a:t>
             </a:r>
           </a:p>
         </p:txBody>
@@ -6134,7 +5414,7 @@
           <p:cNvPr id="3" name="architecture-description">
             <a:extLst xmlns:a="http://schemas.openxmlformats.org/drawingml/2006/main">
               <a:ext uri="{FF2B5EF4-FFF2-40B4-BE49-F238E27FC236}">
-                <a16:creationId xmlns:a16="http://schemas.microsoft.com/office/drawing/2014/main" id="{3DFC914E-CDEC-4C45-997B-F7B509B343DD}"/>
+                <a16:creationId xmlns:a16="http://schemas.microsoft.com/office/drawing/2014/main" id="{FDA3A85A-E3EA-42F7-872D-E6BA011E9E76}"/>
               </a:ext>
             </a:extLst>
           </p:cNvPr>
@@ -6202,7 +5482,7 @@
           <p:cNvPr id="4" name="scout">
             <a:extLst xmlns:a="http://schemas.openxmlformats.org/drawingml/2006/main">
               <a:ext uri="{FF2B5EF4-FFF2-40B4-BE49-F238E27FC236}">
-                <a16:creationId xmlns:a16="http://schemas.microsoft.com/office/drawing/2014/main" id="{1BD61E17-5353-47A1-90B8-B9CE5D74E6BE}"/>
+                <a16:creationId xmlns:a16="http://schemas.microsoft.com/office/drawing/2014/main" id="{4D03F4F5-15E4-46D0-A2D2-B5CF524B3ED2}"/>
               </a:ext>
             </a:extLst>
           </p:cNvPr>
@@ -6272,7 +5552,7 @@
           <p:cNvPr id="5" name="causal">
             <a:extLst xmlns:a="http://schemas.openxmlformats.org/drawingml/2006/main">
               <a:ext uri="{FF2B5EF4-FFF2-40B4-BE49-F238E27FC236}">
-                <a16:creationId xmlns:a16="http://schemas.microsoft.com/office/drawing/2014/main" id="{9EA11600-45A5-47D8-AF96-098615CB5A7F}"/>
+                <a16:creationId xmlns:a16="http://schemas.microsoft.com/office/drawing/2014/main" id="{248AF589-EEF8-4EC7-B59F-D4EDAD560989}"/>
               </a:ext>
             </a:extLst>
           </p:cNvPr>
@@ -6342,7 +5622,7 @@
           <p:cNvPr id="6" name="hunter">
             <a:extLst xmlns:a="http://schemas.openxmlformats.org/drawingml/2006/main">
               <a:ext uri="{FF2B5EF4-FFF2-40B4-BE49-F238E27FC236}">
-                <a16:creationId xmlns:a16="http://schemas.microsoft.com/office/drawing/2014/main" id="{9FA22A4C-8768-4C3D-B6D8-02FB7061BE9A}"/>
+                <a16:creationId xmlns:a16="http://schemas.microsoft.com/office/drawing/2014/main" id="{8F41F6B0-0EE9-40BE-AB56-3ED24C308B68}"/>
               </a:ext>
             </a:extLst>
           </p:cNvPr>
@@ -6412,7 +5692,7 @@
           <p:cNvPr id="7" name="founder">
             <a:extLst xmlns:a="http://schemas.openxmlformats.org/drawingml/2006/main">
               <a:ext uri="{FF2B5EF4-FFF2-40B4-BE49-F238E27FC236}">
-                <a16:creationId xmlns:a16="http://schemas.microsoft.com/office/drawing/2014/main" id="{3087E8A0-D123-4E00-A00F-2A81DB62D1F3}"/>
+                <a16:creationId xmlns:a16="http://schemas.microsoft.com/office/drawing/2014/main" id="{CC15B17F-A0C1-4A5E-AEF8-6EF304CBF775}"/>
               </a:ext>
             </a:extLst>
           </p:cNvPr>
@@ -6482,7 +5762,7 @@
           <p:cNvPr id="8" name="competitive">
             <a:extLst xmlns:a="http://schemas.openxmlformats.org/drawingml/2006/main">
               <a:ext uri="{FF2B5EF4-FFF2-40B4-BE49-F238E27FC236}">
-                <a16:creationId xmlns:a16="http://schemas.microsoft.com/office/drawing/2014/main" id="{7EE96F2F-3C6D-488E-904A-F26BE00F7919}"/>
+                <a16:creationId xmlns:a16="http://schemas.microsoft.com/office/drawing/2014/main" id="{7445D332-A3E3-4E9C-92E8-3B9D35AC22C2}"/>
               </a:ext>
             </a:extLst>
           </p:cNvPr>
@@ -6575,7 +5855,7 @@
           <p:cNvPr id="9" name="bull">
             <a:extLst xmlns:a="http://schemas.openxmlformats.org/drawingml/2006/main">
               <a:ext uri="{FF2B5EF4-FFF2-40B4-BE49-F238E27FC236}">
-                <a16:creationId xmlns:a16="http://schemas.microsoft.com/office/drawing/2014/main" id="{3E4AFB3C-2024-4B1C-96B7-EFD232992652}"/>
+                <a16:creationId xmlns:a16="http://schemas.microsoft.com/office/drawing/2014/main" id="{F200B432-735E-46C8-883A-761CF4A80C90}"/>
               </a:ext>
             </a:extLst>
           </p:cNvPr>
@@ -6645,7 +5925,7 @@
           <p:cNvPr id="10" name="bear">
             <a:extLst xmlns:a="http://schemas.openxmlformats.org/drawingml/2006/main">
               <a:ext uri="{FF2B5EF4-FFF2-40B4-BE49-F238E27FC236}">
-                <a16:creationId xmlns:a16="http://schemas.microsoft.com/office/drawing/2014/main" id="{B2089D40-83AA-4DB9-B30C-C43CDCAB5D4E}"/>
+                <a16:creationId xmlns:a16="http://schemas.microsoft.com/office/drawing/2014/main" id="{30B951E5-7F6B-43F5-892C-1849374DE5AB}"/>
               </a:ext>
             </a:extLst>
           </p:cNvPr>
@@ -6715,7 +5995,7 @@
           <p:cNvPr id="11" name="verifier">
             <a:extLst xmlns:a="http://schemas.openxmlformats.org/drawingml/2006/main">
               <a:ext uri="{FF2B5EF4-FFF2-40B4-BE49-F238E27FC236}">
-                <a16:creationId xmlns:a16="http://schemas.microsoft.com/office/drawing/2014/main" id="{6BE6C391-968C-4DBD-A8F6-3636910209B7}"/>
+                <a16:creationId xmlns:a16="http://schemas.microsoft.com/office/drawing/2014/main" id="{2AA7FE91-D18A-4FFF-8BE4-8E7C511611CA}"/>
               </a:ext>
             </a:extLst>
           </p:cNvPr>
@@ -6785,7 +6065,7 @@
           <p:cNvPr id="12" name="revision">
             <a:extLst xmlns:a="http://schemas.openxmlformats.org/drawingml/2006/main">
               <a:ext uri="{FF2B5EF4-FFF2-40B4-BE49-F238E27FC236}">
-                <a16:creationId xmlns:a16="http://schemas.microsoft.com/office/drawing/2014/main" id="{22907BCA-4873-42E7-A9A1-0F02CC6E5D03}"/>
+                <a16:creationId xmlns:a16="http://schemas.microsoft.com/office/drawing/2014/main" id="{CA4442E2-F264-40D5-900D-4CDE2792C272}"/>
               </a:ext>
             </a:extLst>
           </p:cNvPr>
@@ -6855,7 +6135,7 @@
           <p:cNvPr id="13" name="committee">
             <a:extLst xmlns:a="http://schemas.openxmlformats.org/drawingml/2006/main">
               <a:ext uri="{FF2B5EF4-FFF2-40B4-BE49-F238E27FC236}">
-                <a16:creationId xmlns:a16="http://schemas.microsoft.com/office/drawing/2014/main" id="{0A4F7874-E7B3-4430-B2B8-1185B63C13F3}"/>
+                <a16:creationId xmlns:a16="http://schemas.microsoft.com/office/drawing/2014/main" id="{E0DAC068-65F3-4A68-9107-CAC4B50B9E8B}"/>
               </a:ext>
             </a:extLst>
           </p:cNvPr>
@@ -6948,7 +6228,7 @@
           <p:cNvPr id="24" name="parallel-research">
             <a:extLst xmlns:a="http://schemas.openxmlformats.org/drawingml/2006/main">
               <a:ext uri="{FF2B5EF4-FFF2-40B4-BE49-F238E27FC236}">
-                <a16:creationId xmlns:a16="http://schemas.microsoft.com/office/drawing/2014/main" id="{D3173220-E6C1-4600-8301-D397252FE70E}"/>
+                <a16:creationId xmlns:a16="http://schemas.microsoft.com/office/drawing/2014/main" id="{52F599D0-CB48-46E4-9F5B-5208E9FAAB03}"/>
               </a:ext>
             </a:extLst>
           </p:cNvPr>
@@ -7016,7 +6296,7 @@
           <p:cNvPr id="25" name="architecture-note">
             <a:extLst xmlns:a="http://schemas.openxmlformats.org/drawingml/2006/main">
               <a:ext uri="{FF2B5EF4-FFF2-40B4-BE49-F238E27FC236}">
-                <a16:creationId xmlns:a16="http://schemas.microsoft.com/office/drawing/2014/main" id="{F6AB6161-40C9-4A90-8475-73D3AE21AC79}"/>
+                <a16:creationId xmlns:a16="http://schemas.microsoft.com/office/drawing/2014/main" id="{55ABDCEC-38B5-487E-8AD5-5A84BB41327C}"/>
               </a:ext>
             </a:extLst>
           </p:cNvPr>
@@ -7082,7 +6362,7 @@
     </p:spTree>
     <p:extLst>
       <p:ext uri="{BB962C8B-B14F-4D97-AF65-F5344CB8AC3E}">
-        <p14:creationId xmlns:p14="http://schemas.microsoft.com/office/powerpoint/2010/main" val="207526064"/>
+        <p14:creationId xmlns:p14="http://schemas.microsoft.com/office/powerpoint/2010/main" val="772188483"/>
       </p:ext>
     </p:extLst>
   </p:cSld>
@@ -7113,7 +6393,7 @@
           <p:cNvPr id="10" name="slide-number">
             <a:extLst xmlns:a="http://schemas.openxmlformats.org/drawingml/2006/main">
               <a:ext uri="{FF2B5EF4-FFF2-40B4-BE49-F238E27FC236}">
-                <a16:creationId xmlns:a16="http://schemas.microsoft.com/office/drawing/2014/main" id="{2364BF79-83BC-4B55-BA6A-599555D279B8}"/>
+                <a16:creationId xmlns:a16="http://schemas.microsoft.com/office/drawing/2014/main" id="{7E8BCFB8-D441-4EE8-B189-75A9858C745A}"/>
               </a:ext>
             </a:extLst>
           </p:cNvPr>
@@ -7181,7 +6461,7 @@
           <p:cNvPr id="2" name="slide-title">
             <a:extLst xmlns:a="http://schemas.openxmlformats.org/drawingml/2006/main">
               <a:ext uri="{FF2B5EF4-FFF2-40B4-BE49-F238E27FC236}">
-                <a16:creationId xmlns:a16="http://schemas.microsoft.com/office/drawing/2014/main" id="{A7076196-36A7-47A3-B838-34F0287E8C13}"/>
+                <a16:creationId xmlns:a16="http://schemas.microsoft.com/office/drawing/2014/main" id="{F965FC3E-AC9A-4486-A762-06126C3E90FD}"/>
               </a:ext>
             </a:extLst>
           </p:cNvPr>
@@ -7249,7 +6529,7 @@
           <p:cNvPr id="3" name="case-label">
             <a:extLst xmlns:a="http://schemas.openxmlformats.org/drawingml/2006/main">
               <a:ext uri="{FF2B5EF4-FFF2-40B4-BE49-F238E27FC236}">
-                <a16:creationId xmlns:a16="http://schemas.microsoft.com/office/drawing/2014/main" id="{3B277D41-7290-4A2B-A60A-C2FA9CC1677A}"/>
+                <a16:creationId xmlns:a16="http://schemas.microsoft.com/office/drawing/2014/main" id="{8FC03FE3-0A10-4AD8-AEF7-9FAE1A8CFC95}"/>
               </a:ext>
             </a:extLst>
           </p:cNvPr>
@@ -7317,7 +6597,7 @@
           <p:cNvPr id="4" name="wrong-attribution">
             <a:extLst xmlns:a="http://schemas.openxmlformats.org/drawingml/2006/main">
               <a:ext uri="{FF2B5EF4-FFF2-40B4-BE49-F238E27FC236}">
-                <a16:creationId xmlns:a16="http://schemas.microsoft.com/office/drawing/2014/main" id="{C6EF29E9-246E-411F-9ECF-D8C3241A36EA}"/>
+                <a16:creationId xmlns:a16="http://schemas.microsoft.com/office/drawing/2014/main" id="{0020743D-3B6A-40CA-92D9-D21CD6087FAD}"/>
               </a:ext>
             </a:extLst>
           </p:cNvPr>
@@ -7385,7 +6665,7 @@
           <p:cNvPr id="5" name="case-explanation">
             <a:extLst xmlns:a="http://schemas.openxmlformats.org/drawingml/2006/main">
               <a:ext uri="{FF2B5EF4-FFF2-40B4-BE49-F238E27FC236}">
-                <a16:creationId xmlns:a16="http://schemas.microsoft.com/office/drawing/2014/main" id="{D53F88EA-DF5D-4781-9ACA-00C69B01346E}"/>
+                <a16:creationId xmlns:a16="http://schemas.microsoft.com/office/drawing/2014/main" id="{1E120CDC-1058-4036-952E-801896F61A83}"/>
               </a:ext>
             </a:extLst>
           </p:cNvPr>
@@ -7499,7 +6779,7 @@
           <p:cNvPr id="6" name="case-verdict">
             <a:extLst xmlns:a="http://schemas.openxmlformats.org/drawingml/2006/main">
               <a:ext uri="{FF2B5EF4-FFF2-40B4-BE49-F238E27FC236}">
-                <a16:creationId xmlns:a16="http://schemas.microsoft.com/office/drawing/2014/main" id="{5AEDA869-F32F-43F0-87F6-D8A057E5CDA1}"/>
+                <a16:creationId xmlns:a16="http://schemas.microsoft.com/office/drawing/2014/main" id="{939930A0-DB49-4422-A0B7-6760569E98F4}"/>
               </a:ext>
             </a:extLst>
           </p:cNvPr>
@@ -7567,7 +6847,7 @@
           <p:cNvPr id="7" name="case-confidence">
             <a:extLst xmlns:a="http://schemas.openxmlformats.org/drawingml/2006/main">
               <a:ext uri="{FF2B5EF4-FFF2-40B4-BE49-F238E27FC236}">
-                <a16:creationId xmlns:a16="http://schemas.microsoft.com/office/drawing/2014/main" id="{34F7DAD4-F14F-4C0A-8659-A58F123844CC}"/>
+                <a16:creationId xmlns:a16="http://schemas.microsoft.com/office/drawing/2014/main" id="{4DF78695-54D3-4042-A53E-BBA921B4B8B6}"/>
               </a:ext>
             </a:extLst>
           </p:cNvPr>
@@ -7635,7 +6915,7 @@
           <p:cNvPr id="8" name="">
             <a:extLst xmlns:a="http://schemas.openxmlformats.org/drawingml/2006/main">
               <a:ext uri="{FF2B5EF4-FFF2-40B4-BE49-F238E27FC236}">
-                <a16:creationId xmlns:a16="http://schemas.microsoft.com/office/drawing/2014/main" id="{ECA1DE08-8699-427F-BD3B-6F8D7546637E}"/>
+                <a16:creationId xmlns:a16="http://schemas.microsoft.com/office/drawing/2014/main" id="{B363DB56-F44F-4CDC-810F-6B11B4CAE640}"/>
               </a:ext>
             </a:extLst>
           </p:cNvPr>
@@ -7645,7 +6925,7 @@
           <p:nvPr/>
         </p:nvPicPr>
         <p:blipFill>
-          <a:blip xmlns:r="http://schemas.openxmlformats.org/officeDocument/2006/relationships" xmlns:a="http://schemas.openxmlformats.org/drawingml/2006/main" r:embed="R963251300ee54345"/>
+          <a:blip xmlns:r="http://schemas.openxmlformats.org/officeDocument/2006/relationships" xmlns:a="http://schemas.openxmlformats.org/drawingml/2006/main" r:embed="R43afb6f0afb74d40"/>
           <a:stretch xmlns:a="http://schemas.openxmlformats.org/drawingml/2006/main"/>
         </p:blipFill>
         <p:spPr>
@@ -7663,7 +6943,7 @@
           <p:cNvPr id="9" name="case-counts">
             <a:extLst xmlns:a="http://schemas.openxmlformats.org/drawingml/2006/main">
               <a:ext uri="{FF2B5EF4-FFF2-40B4-BE49-F238E27FC236}">
-                <a16:creationId xmlns:a16="http://schemas.microsoft.com/office/drawing/2014/main" id="{83F0B795-1E27-4C6A-94DF-BACECB202F48}"/>
+                <a16:creationId xmlns:a16="http://schemas.microsoft.com/office/drawing/2014/main" id="{C3144222-C438-46B7-BF43-D2104FA419AF}"/>
               </a:ext>
             </a:extLst>
           </p:cNvPr>
@@ -7729,7 +7009,7 @@
     </p:spTree>
     <p:extLst>
       <p:ext uri="{BB962C8B-B14F-4D97-AF65-F5344CB8AC3E}">
-        <p14:creationId xmlns:p14="http://schemas.microsoft.com/office/powerpoint/2010/main" val="1492063593"/>
+        <p14:creationId xmlns:p14="http://schemas.microsoft.com/office/powerpoint/2010/main" val="1043570017"/>
       </p:ext>
     </p:extLst>
   </p:cSld>
@@ -7760,7 +7040,7 @@
           <p:cNvPr id="16" name="slide-number">
             <a:extLst xmlns:a="http://schemas.openxmlformats.org/drawingml/2006/main">
               <a:ext uri="{FF2B5EF4-FFF2-40B4-BE49-F238E27FC236}">
-                <a16:creationId xmlns:a16="http://schemas.microsoft.com/office/drawing/2014/main" id="{E71274F7-ECEC-4561-A80B-6E8E9DA7E569}"/>
+                <a16:creationId xmlns:a16="http://schemas.microsoft.com/office/drawing/2014/main" id="{9DDF1E9E-D23B-4709-A58B-28633D660455}"/>
               </a:ext>
             </a:extLst>
           </p:cNvPr>
@@ -7828,7 +7108,7 @@
           <p:cNvPr id="2" name="slide-title">
             <a:extLst xmlns:a="http://schemas.openxmlformats.org/drawingml/2006/main">
               <a:ext uri="{FF2B5EF4-FFF2-40B4-BE49-F238E27FC236}">
-                <a16:creationId xmlns:a16="http://schemas.microsoft.com/office/drawing/2014/main" id="{451A9123-47C6-4D65-B679-6B3FD687D419}"/>
+                <a16:creationId xmlns:a16="http://schemas.microsoft.com/office/drawing/2014/main" id="{376B96F8-920C-420E-B7A1-6D91EB12F760}"/>
               </a:ext>
             </a:extLst>
           </p:cNvPr>
@@ -7886,7 +7166,7 @@
                 <a:ea typeface="Arial"/>
                 <a:cs typeface="Arial"/>
               </a:rPr>
-              <a:t>Evidence rules before a ranking</a:t>
+              <a:t>Responsible design: evidence before confidence</a:t>
             </a:r>
           </a:p>
         </p:txBody>
@@ -7896,7 +7176,7 @@
           <p:cNvPr id="3" name="rule-01">
             <a:extLst xmlns:a="http://schemas.openxmlformats.org/drawingml/2006/main">
               <a:ext uri="{FF2B5EF4-FFF2-40B4-BE49-F238E27FC236}">
-                <a16:creationId xmlns:a16="http://schemas.microsoft.com/office/drawing/2014/main" id="{4631C017-30E8-4552-8F6A-2860D5D88AF4}"/>
+                <a16:creationId xmlns:a16="http://schemas.microsoft.com/office/drawing/2014/main" id="{BC35DD34-8A3D-4506-90F0-7AB42F5116FB}"/>
               </a:ext>
             </a:extLst>
           </p:cNvPr>
@@ -7964,7 +7244,7 @@
           <p:cNvPr id="4" name="rule-title-01">
             <a:extLst xmlns:a="http://schemas.openxmlformats.org/drawingml/2006/main">
               <a:ext uri="{FF2B5EF4-FFF2-40B4-BE49-F238E27FC236}">
-                <a16:creationId xmlns:a16="http://schemas.microsoft.com/office/drawing/2014/main" id="{EBCA1291-7D3F-4B28-814D-908D5588BF68}"/>
+                <a16:creationId xmlns:a16="http://schemas.microsoft.com/office/drawing/2014/main" id="{6168F4AD-C908-4FFA-93F8-253569257B16}"/>
               </a:ext>
             </a:extLst>
           </p:cNvPr>
@@ -8032,7 +7312,7 @@
           <p:cNvPr id="5" name="rule-body-01">
             <a:extLst xmlns:a="http://schemas.openxmlformats.org/drawingml/2006/main">
               <a:ext uri="{FF2B5EF4-FFF2-40B4-BE49-F238E27FC236}">
-                <a16:creationId xmlns:a16="http://schemas.microsoft.com/office/drawing/2014/main" id="{538F015F-32AA-4A34-869A-8CE8D9741791}"/>
+                <a16:creationId xmlns:a16="http://schemas.microsoft.com/office/drawing/2014/main" id="{26252509-C578-4C9A-8BE1-B70760A2865D}"/>
               </a:ext>
             </a:extLst>
           </p:cNvPr>
@@ -8100,7 +7380,7 @@
           <p:cNvPr id="6" name="rule-02">
             <a:extLst xmlns:a="http://schemas.openxmlformats.org/drawingml/2006/main">
               <a:ext uri="{FF2B5EF4-FFF2-40B4-BE49-F238E27FC236}">
-                <a16:creationId xmlns:a16="http://schemas.microsoft.com/office/drawing/2014/main" id="{146848A1-66D8-4A28-A980-0A632A3A544A}"/>
+                <a16:creationId xmlns:a16="http://schemas.microsoft.com/office/drawing/2014/main" id="{6B7E63BE-3F5B-4833-97D6-326071988BF8}"/>
               </a:ext>
             </a:extLst>
           </p:cNvPr>
@@ -8168,7 +7448,7 @@
           <p:cNvPr id="7" name="rule-title-02">
             <a:extLst xmlns:a="http://schemas.openxmlformats.org/drawingml/2006/main">
               <a:ext uri="{FF2B5EF4-FFF2-40B4-BE49-F238E27FC236}">
-                <a16:creationId xmlns:a16="http://schemas.microsoft.com/office/drawing/2014/main" id="{C6E033AB-F712-47CA-A837-B9A1FABE29AD}"/>
+                <a16:creationId xmlns:a16="http://schemas.microsoft.com/office/drawing/2014/main" id="{BECAB6E2-A61A-42D0-B9DE-FF9BDCCD4C31}"/>
               </a:ext>
             </a:extLst>
           </p:cNvPr>
@@ -8236,7 +7516,7 @@
           <p:cNvPr id="8" name="rule-body-02">
             <a:extLst xmlns:a="http://schemas.openxmlformats.org/drawingml/2006/main">
               <a:ext uri="{FF2B5EF4-FFF2-40B4-BE49-F238E27FC236}">
-                <a16:creationId xmlns:a16="http://schemas.microsoft.com/office/drawing/2014/main" id="{7B413F07-94A4-42E7-A76B-D5C5EFA08317}"/>
+                <a16:creationId xmlns:a16="http://schemas.microsoft.com/office/drawing/2014/main" id="{09E254E3-0330-4BB6-8807-6A90C6998EA6}"/>
               </a:ext>
             </a:extLst>
           </p:cNvPr>
@@ -8304,7 +7584,7 @@
           <p:cNvPr id="9" name="rule-03">
             <a:extLst xmlns:a="http://schemas.openxmlformats.org/drawingml/2006/main">
               <a:ext uri="{FF2B5EF4-FFF2-40B4-BE49-F238E27FC236}">
-                <a16:creationId xmlns:a16="http://schemas.microsoft.com/office/drawing/2014/main" id="{D60E7FC7-F88C-4322-9BEA-B966230F19F4}"/>
+                <a16:creationId xmlns:a16="http://schemas.microsoft.com/office/drawing/2014/main" id="{6EA92F0D-4F70-4403-A085-ABB95D0123EA}"/>
               </a:ext>
             </a:extLst>
           </p:cNvPr>
@@ -8372,7 +7652,7 @@
           <p:cNvPr id="10" name="rule-title-03">
             <a:extLst xmlns:a="http://schemas.openxmlformats.org/drawingml/2006/main">
               <a:ext uri="{FF2B5EF4-FFF2-40B4-BE49-F238E27FC236}">
-                <a16:creationId xmlns:a16="http://schemas.microsoft.com/office/drawing/2014/main" id="{A11FD5EC-4647-4531-9477-299A98916B83}"/>
+                <a16:creationId xmlns:a16="http://schemas.microsoft.com/office/drawing/2014/main" id="{D16FD2EA-6396-47B8-8767-700114FDEF91}"/>
               </a:ext>
             </a:extLst>
           </p:cNvPr>
@@ -8440,7 +7720,7 @@
           <p:cNvPr id="11" name="rule-body-03">
             <a:extLst xmlns:a="http://schemas.openxmlformats.org/drawingml/2006/main">
               <a:ext uri="{FF2B5EF4-FFF2-40B4-BE49-F238E27FC236}">
-                <a16:creationId xmlns:a16="http://schemas.microsoft.com/office/drawing/2014/main" id="{91EB8036-0C3E-4E99-86A0-53441E60D8D9}"/>
+                <a16:creationId xmlns:a16="http://schemas.microsoft.com/office/drawing/2014/main" id="{4C8F947C-CB9B-4536-B498-AEB4D59A032E}"/>
               </a:ext>
             </a:extLst>
           </p:cNvPr>
@@ -8508,7 +7788,7 @@
           <p:cNvPr id="12" name="rule-04">
             <a:extLst xmlns:a="http://schemas.openxmlformats.org/drawingml/2006/main">
               <a:ext uri="{FF2B5EF4-FFF2-40B4-BE49-F238E27FC236}">
-                <a16:creationId xmlns:a16="http://schemas.microsoft.com/office/drawing/2014/main" id="{DC2A8D96-EED9-482B-9214-150E0668A87A}"/>
+                <a16:creationId xmlns:a16="http://schemas.microsoft.com/office/drawing/2014/main" id="{196856BB-13B1-44FF-A34B-02DE77C7EB6F}"/>
               </a:ext>
             </a:extLst>
           </p:cNvPr>
@@ -8576,7 +7856,7 @@
           <p:cNvPr id="13" name="rule-title-04">
             <a:extLst xmlns:a="http://schemas.openxmlformats.org/drawingml/2006/main">
               <a:ext uri="{FF2B5EF4-FFF2-40B4-BE49-F238E27FC236}">
-                <a16:creationId xmlns:a16="http://schemas.microsoft.com/office/drawing/2014/main" id="{87889705-30B1-410F-8EF9-43D7218BC4B7}"/>
+                <a16:creationId xmlns:a16="http://schemas.microsoft.com/office/drawing/2014/main" id="{33071821-C8AB-4A62-9EA1-226131938E35}"/>
               </a:ext>
             </a:extLst>
           </p:cNvPr>
@@ -8644,7 +7924,7 @@
           <p:cNvPr id="14" name="rule-body-04">
             <a:extLst xmlns:a="http://schemas.openxmlformats.org/drawingml/2006/main">
               <a:ext uri="{FF2B5EF4-FFF2-40B4-BE49-F238E27FC236}">
-                <a16:creationId xmlns:a16="http://schemas.microsoft.com/office/drawing/2014/main" id="{E527549A-A200-4204-8584-9A18E71CF568}"/>
+                <a16:creationId xmlns:a16="http://schemas.microsoft.com/office/drawing/2014/main" id="{C16A35EC-40DC-41B7-AC16-50C009DD2FBE}"/>
               </a:ext>
             </a:extLst>
           </p:cNvPr>
@@ -8712,7 +7992,7 @@
           <p:cNvPr id="15" name="source-history-limitation">
             <a:extLst xmlns:a="http://schemas.openxmlformats.org/drawingml/2006/main">
               <a:ext uri="{FF2B5EF4-FFF2-40B4-BE49-F238E27FC236}">
-                <a16:creationId xmlns:a16="http://schemas.microsoft.com/office/drawing/2014/main" id="{D7675E8A-3D04-4C19-9806-23CD6703BA8E}"/>
+                <a16:creationId xmlns:a16="http://schemas.microsoft.com/office/drawing/2014/main" id="{33ED3F77-11F6-4849-BE1D-BCE701E7B272}"/>
               </a:ext>
             </a:extLst>
           </p:cNvPr>
@@ -8778,7 +8058,7 @@
     </p:spTree>
     <p:extLst>
       <p:ext uri="{BB962C8B-B14F-4D97-AF65-F5344CB8AC3E}">
-        <p14:creationId xmlns:p14="http://schemas.microsoft.com/office/powerpoint/2010/main" val="1897385546"/>
+        <p14:creationId xmlns:p14="http://schemas.microsoft.com/office/powerpoint/2010/main" val="252148030"/>
       </p:ext>
     </p:extLst>
   </p:cSld>
@@ -8809,7 +8089,7 @@
           <p:cNvPr id="11" name="slide-number">
             <a:extLst xmlns:a="http://schemas.openxmlformats.org/drawingml/2006/main">
               <a:ext uri="{FF2B5EF4-FFF2-40B4-BE49-F238E27FC236}">
-                <a16:creationId xmlns:a16="http://schemas.microsoft.com/office/drawing/2014/main" id="{DDF42B7A-D094-4ADF-A8A4-91405AEE0D44}"/>
+                <a16:creationId xmlns:a16="http://schemas.microsoft.com/office/drawing/2014/main" id="{01F0A468-4715-49F8-BFF3-E79659B6A941}"/>
               </a:ext>
             </a:extLst>
           </p:cNvPr>
@@ -8877,7 +8157,7 @@
           <p:cNvPr id="2" name="slide-title">
             <a:extLst xmlns:a="http://schemas.openxmlformats.org/drawingml/2006/main">
               <a:ext uri="{FF2B5EF4-FFF2-40B4-BE49-F238E27FC236}">
-                <a16:creationId xmlns:a16="http://schemas.microsoft.com/office/drawing/2014/main" id="{64923644-E602-455A-A9F3-8D11BF449385}"/>
+                <a16:creationId xmlns:a16="http://schemas.microsoft.com/office/drawing/2014/main" id="{B2A32961-B9BB-4436-9255-4846128293DA}"/>
               </a:ext>
             </a:extLst>
           </p:cNvPr>
@@ -8945,7 +8225,7 @@
           <p:cNvPr id="3" name="pricing-label">
             <a:extLst xmlns:a="http://schemas.openxmlformats.org/drawingml/2006/main">
               <a:ext uri="{FF2B5EF4-FFF2-40B4-BE49-F238E27FC236}">
-                <a16:creationId xmlns:a16="http://schemas.microsoft.com/office/drawing/2014/main" id="{EDD484AE-41CF-4441-9D7E-59E8EF9674B9}"/>
+                <a16:creationId xmlns:a16="http://schemas.microsoft.com/office/drawing/2014/main" id="{BADB134F-5D3A-487C-9A21-AE281A777FE0}"/>
               </a:ext>
             </a:extLst>
           </p:cNvPr>
@@ -9013,7 +8293,7 @@
           <p:cNvPr id="4" name="pricing">
             <a:extLst xmlns:a="http://schemas.openxmlformats.org/drawingml/2006/main">
               <a:ext uri="{FF2B5EF4-FFF2-40B4-BE49-F238E27FC236}">
-                <a16:creationId xmlns:a16="http://schemas.microsoft.com/office/drawing/2014/main" id="{43DE12D5-B2D3-4FAF-BDA2-63425D3350C6}"/>
+                <a16:creationId xmlns:a16="http://schemas.microsoft.com/office/drawing/2014/main" id="{8E078C22-5F49-4954-A29E-3C3FB97BE3BB}"/>
               </a:ext>
             </a:extLst>
           </p:cNvPr>
@@ -9081,7 +8361,7 @@
           <p:cNvPr id="5" name="pricing-unit">
             <a:extLst xmlns:a="http://schemas.openxmlformats.org/drawingml/2006/main">
               <a:ext uri="{FF2B5EF4-FFF2-40B4-BE49-F238E27FC236}">
-                <a16:creationId xmlns:a16="http://schemas.microsoft.com/office/drawing/2014/main" id="{97C59AF9-C3E8-49E6-B143-959FF3F0751E}"/>
+                <a16:creationId xmlns:a16="http://schemas.microsoft.com/office/drawing/2014/main" id="{AEC91702-C71F-4A48-A58C-FC4EF9868341}"/>
               </a:ext>
             </a:extLst>
           </p:cNvPr>
@@ -9149,7 +8429,7 @@
           <p:cNvPr id="6" name="pricing-team">
             <a:extLst xmlns:a="http://schemas.openxmlformats.org/drawingml/2006/main">
               <a:ext uri="{FF2B5EF4-FFF2-40B4-BE49-F238E27FC236}">
-                <a16:creationId xmlns:a16="http://schemas.microsoft.com/office/drawing/2014/main" id="{019F709F-3C49-45CC-9093-B0034E6A9559}"/>
+                <a16:creationId xmlns:a16="http://schemas.microsoft.com/office/drawing/2014/main" id="{34B5B5C3-09DB-42BE-A4C1-376B5654D8B5}"/>
               </a:ext>
             </a:extLst>
           </p:cNvPr>
@@ -9240,7 +8520,7 @@
           <p:cNvPr id="7" name="pilot-ask">
             <a:extLst xmlns:a="http://schemas.openxmlformats.org/drawingml/2006/main">
               <a:ext uri="{FF2B5EF4-FFF2-40B4-BE49-F238E27FC236}">
-                <a16:creationId xmlns:a16="http://schemas.microsoft.com/office/drawing/2014/main" id="{E3F2F27D-C542-41CB-9D9F-3DBC85619A1A}"/>
+                <a16:creationId xmlns:a16="http://schemas.microsoft.com/office/drawing/2014/main" id="{72344EC5-436E-44DB-BDA4-25F19A201F35}"/>
               </a:ext>
             </a:extLst>
           </p:cNvPr>
@@ -9308,7 +8588,7 @@
           <p:cNvPr id="8" name="pilot-description">
             <a:extLst xmlns:a="http://schemas.openxmlformats.org/drawingml/2006/main">
               <a:ext uri="{FF2B5EF4-FFF2-40B4-BE49-F238E27FC236}">
-                <a16:creationId xmlns:a16="http://schemas.microsoft.com/office/drawing/2014/main" id="{DE7479E0-E727-4FEE-B58A-93915CFC1211}"/>
+                <a16:creationId xmlns:a16="http://schemas.microsoft.com/office/drawing/2014/main" id="{B35CCFF6-3325-4D04-A1D0-51EA0BA75DF2}"/>
               </a:ext>
             </a:extLst>
           </p:cNvPr>
@@ -9399,7 +8679,7 @@
           <p:cNvPr id="9" name="pilot-evaluation">
             <a:extLst xmlns:a="http://schemas.openxmlformats.org/drawingml/2006/main">
               <a:ext uri="{FF2B5EF4-FFF2-40B4-BE49-F238E27FC236}">
-                <a16:creationId xmlns:a16="http://schemas.microsoft.com/office/drawing/2014/main" id="{37021788-C7F0-475C-900E-D7E3F96E1B8F}"/>
+                <a16:creationId xmlns:a16="http://schemas.microsoft.com/office/drawing/2014/main" id="{C77AABC5-C6DB-4816-B0EE-C2383B65CA45}"/>
               </a:ext>
             </a:extLst>
           </p:cNvPr>
@@ -9513,7 +8793,7 @@
           <p:cNvPr id="10" name="pricing-limitation">
             <a:extLst xmlns:a="http://schemas.openxmlformats.org/drawingml/2006/main">
               <a:ext uri="{FF2B5EF4-FFF2-40B4-BE49-F238E27FC236}">
-                <a16:creationId xmlns:a16="http://schemas.microsoft.com/office/drawing/2014/main" id="{982FF7F2-45D5-464F-BEB3-36AE393EF606}"/>
+                <a16:creationId xmlns:a16="http://schemas.microsoft.com/office/drawing/2014/main" id="{3928D6AD-E6A2-4938-B047-34BF7B40BF95}"/>
               </a:ext>
             </a:extLst>
           </p:cNvPr>
@@ -9579,7 +8859,7 @@
     </p:spTree>
     <p:extLst>
       <p:ext uri="{BB962C8B-B14F-4D97-AF65-F5344CB8AC3E}">
-        <p14:creationId xmlns:p14="http://schemas.microsoft.com/office/powerpoint/2010/main" val="1268377796"/>
+        <p14:creationId xmlns:p14="http://schemas.microsoft.com/office/powerpoint/2010/main" val="1430276808"/>
       </p:ext>
     </p:extLst>
   </p:cSld>

</xml_diff>